<commit_message>
Right before session 1
</commit_message>
<xml_diff>
--- a/sesion-03/Sesion_03_Validacion_Critica.pptx
+++ b/sesion-03/Sesion_03_Validacion_Critica.pptx
@@ -516,7 +516,7 @@
           <a:p>
             <a:r>
               <a:rPr lang="en-US" dirty="0"/>
-              <a:t/>
+              <a:t>Ten listos: los seis equipos anunciados desde el martes, las salas de trabajo probadas, el informe sintético distribuido, y la clave abierta en tu segunda pantalla.</a:t>
             </a:r>
             <a:endParaRPr lang="en-US" dirty="0"/>
           </a:p>
@@ -692,7 +692,7 @@
           <a:p>
             <a:r>
               <a:rPr lang="en-US" dirty="0"/>
-              <a:t>Seis equipos de cuatro. Recorrer los equipos durante el ejercicio. No revelar cuántos errores hay hasta la puesta en común: saber el número cambia la forma en que buscan.</a:t>
+              <a:t>Seis equipos de cuatro. Recorre las salas. No reveles cuántos errores hay hasta la puesta en común: saber el número cambia cómo buscan.</a:t>
             </a:r>
             <a:endParaRPr lang="en-US" dirty="0"/>
           </a:p>
@@ -1484,7 +1484,7 @@
           <a:p>
             <a:r>
               <a:rPr lang="en-US" dirty="0"/>
-              <a:t>Usar una premisa falsa pero verosímil, por ejemplo que un programa amplió su cobertura en un año en que en realidad la redujo. Después pedirle que cite la evidencia y ver qué hace.</a:t>
+              <a:t>Usa una premisa falsa pero creíble, por ejemplo que un programa amplió su cobertura en un año en que la redujo. Después pídele que cite la evidencia y observa qué hace.</a:t>
             </a:r>
             <a:endParaRPr lang="en-US" dirty="0"/>
           </a:p>
@@ -2282,7 +2282,7 @@
                 <a:ea typeface="Arial" pitchFamily="34" charset="-122"/>
                 <a:cs typeface="Arial" pitchFamily="34" charset="-120"/>
               </a:rPr>
-              <a:t>Razonamiento analítico, validación crítica y control de calidad</a:t>
+              <a:t>Cómo detectar los errores de la IA y el Laboratorio Práctico 1</a:t>
             </a:r>
             <a:endParaRPr lang="en-US" sz="3400" dirty="0"/>
           </a:p>
@@ -2387,7 +2387,7 @@
                 <a:ea typeface="Calibri" pitchFamily="34" charset="-122"/>
                 <a:cs typeface="Calibri" pitchFamily="34" charset="-120"/>
               </a:rPr>
-              <a:t>Curso de Inteligencia Artificial Aplicada. INEGI 2026. Incluye el Laboratorio Práctico 1.</a:t>
+              <a:t>Curso de Inteligencia Artificial Aplicada. INEGI 2026. CC BY-NC-SA 4.0.</a:t>
             </a:r>
             <a:endParaRPr lang="en-US" sz="1300" dirty="0"/>
           </a:p>
@@ -2561,7 +2561,7 @@
                 <a:ea typeface="Arial" pitchFamily="34" charset="-122"/>
                 <a:cs typeface="Arial" pitchFamily="34" charset="-120"/>
               </a:rPr>
-              <a:t>Dictamen de validación</a:t>
+              <a:t>Encuentra lo que está mal en este informe</a:t>
             </a:r>
             <a:endParaRPr lang="en-US" sz="3400" dirty="0"/>
           </a:p>
@@ -2725,7 +2725,7 @@
                 <a:ea typeface="Arial" pitchFamily="34" charset="-122"/>
                 <a:cs typeface="Arial" pitchFamily="34" charset="-120"/>
               </a:rPr>
-              <a:t>AHORA USTEDES</a:t>
+              <a:t>TU TURNO</a:t>
             </a:r>
             <a:endParaRPr lang="en-US" sz="1300" dirty="0"/>
           </a:p>
@@ -2830,7 +2830,7 @@
                 <a:ea typeface="Arial" pitchFamily="34" charset="-122"/>
                 <a:cs typeface="Arial" pitchFamily="34" charset="-120"/>
               </a:rPr>
-              <a:t>Encuentren lo que está mal en este informe</a:t>
+              <a:t>Tu equipo hace un dictamen de validación</a:t>
             </a:r>
             <a:endParaRPr lang="en-US" sz="2900" dirty="0"/>
           </a:p>
@@ -2963,7 +2963,7 @@
                 <a:ea typeface="Calibri" pitchFamily="34" charset="-122"/>
                 <a:cs typeface="Calibri" pitchFamily="34" charset="-120"/>
               </a:rPr>
-              <a:t>Reciben un informe de evaluación de un programa de desarrollo social, de ocho páginas, generado con IA. Tiene errores plantados a propósito.</a:t>
+              <a:t>Reciben un informe de evaluación de un programa de desarrollo social, de ocho páginas, hecho con IA. Tiene errores puestos a propósito.</a:t>
             </a:r>
             <a:endParaRPr lang="en-US" sz="1450" dirty="0"/>
           </a:p>
@@ -3096,7 +3096,7 @@
                 <a:ea typeface="Calibri" pitchFamily="34" charset="-122"/>
                 <a:cs typeface="Calibri" pitchFamily="34" charset="-120"/>
               </a:rPr>
-              <a:t>Apliquen el protocolo de cuatro pasos. Los cuatro, en orden, y dejando registro de cada uno.</a:t>
+              <a:t>Los primeros diez minutos son de lectura humana. No abras ninguna herramienta todavía.</a:t>
             </a:r>
             <a:endParaRPr lang="en-US" sz="1450" dirty="0"/>
           </a:p>
@@ -3229,7 +3229,7 @@
                 <a:ea typeface="Calibri" pitchFamily="34" charset="-122"/>
                 <a:cs typeface="Calibri" pitchFamily="34" charset="-120"/>
               </a:rPr>
-              <a:t>Produzcan un dictamen de validación. Por cada hallazgo: ubicación exacta, tipo de error, la evidencia que sostiene que es un error, y la corrección propuesta.</a:t>
+              <a:t>Después aplica el protocolo de cuatro pasos. Los cuatro, en orden, y dejando registro de cada uno.</a:t>
             </a:r>
             <a:endParaRPr lang="en-US" sz="1450" dirty="0"/>
           </a:p>
@@ -3362,7 +3362,7 @@
                 <a:ea typeface="Calibri" pitchFamily="34" charset="-122"/>
                 <a:cs typeface="Calibri" pitchFamily="34" charset="-120"/>
               </a:rPr>
-              <a:t>Elijan el hallazgo que van a presentar en la puesta en común. No el más fácil: el más interesante.</a:t>
+              <a:t>Llena el dictamen. Por cada hallazgo: dónde está, qué tipo de error es, la evidencia de que es un error, y cómo debería decir.</a:t>
             </a:r>
             <a:endParaRPr lang="en-US" sz="1450" dirty="0"/>
           </a:p>
@@ -3428,7 +3428,7 @@
                 <a:ea typeface="Calibri" pitchFamily="34" charset="-122"/>
                 <a:cs typeface="Calibri" pitchFamily="34" charset="-120"/>
               </a:rPr>
-              <a:t>Archivos: Informe_sintetico_LAB1.docx y Formatos_de_trabajo_curso_IA.docx, Formato 3.</a:t>
+              <a:t>Archivos: Informe_sintetico_LAB1.docx y el Formato 3 de Formatos_de_trabajo_curso_IA.docx.</a:t>
             </a:r>
             <a:endParaRPr lang="en-US" sz="1350" dirty="0"/>
           </a:p>
@@ -3524,7 +3524,7 @@
                 <a:ea typeface="Calibri" pitchFamily="34" charset="-122"/>
                 <a:cs typeface="Calibri" pitchFamily="34" charset="-120"/>
               </a:rPr>
-              <a:t>ANTES DE QUE EMPIECEN, UNA ADVERTENCIA</a:t>
+              <a:t>ANTES DE QUE EMPIECES, UNA ADVERTENCIA</a:t>
             </a:r>
             <a:endParaRPr lang="en-US" sz="1400" dirty="0"/>
           </a:p>
@@ -3566,7 +3566,7 @@
                 <a:ea typeface="Arial" pitchFamily="34" charset="-122"/>
                 <a:cs typeface="Arial" pitchFamily="34" charset="-120"/>
               </a:rPr>
-              <a:t>Si le piden a Copilot que encuentre los errores, va a encontrar algunos, va a inventar otros, y va a pasar por alto casi todos los de omisión.</a:t>
+              <a:t>Si le pides a Copilot que encuentre los errores, el modelo va a encontrar algunos, va a inventar otros, y va a pasar por alto casi todos los de omisión.</a:t>
             </a:r>
             <a:endParaRPr lang="en-US" sz="3000" dirty="0"/>
           </a:p>
@@ -3608,7 +3608,7 @@
                 <a:ea typeface="Calibri" pitchFamily="34" charset="-122"/>
                 <a:cs typeface="Calibri" pitchFamily="34" charset="-120"/>
               </a:rPr>
-              <a:t>Eso está bien y es parte del ejercicio. Cada error que la herramienta reporte tiene que ser verificado por una persona del equipo antes de entrar al dictamen. Un hallazgo inventado por la herramienta se penaliza en el criterio de calidad de la evidencia. Anotar los que descartaron cuenta a favor.</a:t>
+              <a:t>Eso está bien y es parte del ejercicio. Cada error que el modelo te reporte lo tiene que verificar una persona de tu equipo antes de entrar al dictamen. Un hallazgo inventado por el modelo te baja puntos. Anotar los que descartaste te sube.</a:t>
             </a:r>
             <a:endParaRPr lang="en-US" sz="1600" dirty="0"/>
           </a:p>
@@ -3672,7 +3672,7 @@
                 <a:ea typeface="Arial" pitchFamily="34" charset="-122"/>
                 <a:cs typeface="Arial" pitchFamily="34" charset="-120"/>
               </a:rPr>
-              <a:t>Rúbrica del Laboratorio Práctico 1</a:t>
+              <a:t>Cómo se califica tu dictamen</a:t>
             </a:r>
             <a:endParaRPr lang="en-US" sz="3200" dirty="0"/>
           </a:p>
@@ -3711,7 +3711,7 @@
                 <a:ea typeface="Calibri" pitchFamily="34" charset="-122"/>
                 <a:cs typeface="Calibri" pitchFamily="34" charset="-120"/>
               </a:rPr>
-              <a:t>Se aplica en vivo durante la puesta en común, con ustedes viéndola.</a:t>
+              <a:t>Se aplica en vivo durante la puesta en común, contigo viéndola.</a:t>
             </a:r>
             <a:endParaRPr lang="en-US" sz="1500" dirty="0"/>
           </a:p>
@@ -3968,7 +3968,7 @@
                           <a:ea typeface="Calibri" pitchFamily="34" charset="-122"/>
                           <a:cs typeface="Calibri" pitchFamily="34" charset="-120"/>
                         </a:rPr>
-                        <a:t>Detección de errores</a:t>
+                        <a:t>Errores detectados</a:t>
                       </a:r>
                       <a:endParaRPr lang="en-US" sz="1250" dirty="0">
                         <a:latin typeface="Calibri" charset="0"/>
@@ -4104,7 +4104,7 @@
                           <a:ea typeface="Calibri" pitchFamily="34" charset="-122"/>
                           <a:cs typeface="Calibri" pitchFamily="34" charset="-120"/>
                         </a:rPr>
-                        <a:t>Cuántos de los errores plantados encontró el equipo y si los clasificó bien.</a:t>
+                        <a:t>Cuántos de los errores puestos a propósito encontró tu equipo y si los clasificó bien.</a:t>
                       </a:r>
                       <a:endParaRPr lang="en-US" sz="1250" dirty="0">
                         <a:latin typeface="Calibri" charset="0"/>
@@ -4174,7 +4174,7 @@
                           <a:ea typeface="Calibri" pitchFamily="34" charset="-122"/>
                           <a:cs typeface="Calibri" pitchFamily="34" charset="-120"/>
                         </a:rPr>
-                        <a:t>Aplicación del protocolo</a:t>
+                        <a:t>Uso del protocolo</a:t>
                       </a:r>
                       <a:endParaRPr lang="en-US" sz="1250" dirty="0">
                         <a:latin typeface="Calibri" charset="0"/>
@@ -4310,7 +4310,7 @@
                           <a:ea typeface="Calibri" pitchFamily="34" charset="-122"/>
                           <a:cs typeface="Calibri" pitchFamily="34" charset="-120"/>
                         </a:rPr>
-                        <a:t>Si se aplicaron los cuatro pasos y si quedó registro de cada uno en la bitácora.</a:t>
+                        <a:t>Si aplicaste los cuatro pasos y si quedó registro de cada uno en tu bitácora.</a:t>
                       </a:r>
                       <a:endParaRPr lang="en-US" sz="1250" dirty="0">
                         <a:latin typeface="Calibri" charset="0"/>
@@ -4722,7 +4722,7 @@
                           <a:ea typeface="Calibri" pitchFamily="34" charset="-122"/>
                           <a:cs typeface="Calibri" pitchFamily="34" charset="-120"/>
                         </a:rPr>
-                        <a:t>Si la corrección es viable y está redactada con claridad.</a:t>
+                        <a:t>Si la corrección es viable y está escrita con claridad.</a:t>
                       </a:r>
                       <a:endParaRPr lang="en-US" sz="1250" dirty="0">
                         <a:latin typeface="Calibri" charset="0"/>
@@ -4836,7 +4836,7 @@
                 <a:ea typeface="Arial" pitchFamily="34" charset="-122"/>
                 <a:cs typeface="Arial" pitchFamily="34" charset="-120"/>
               </a:rPr>
-              <a:t>Puesta en común: tres preguntas para cerrar</a:t>
+              <a:t>Tres preguntas para cerrar</a:t>
             </a:r>
             <a:endParaRPr lang="en-US" sz="3200" dirty="0"/>
           </a:p>
@@ -4890,11 +4890,11 @@
         <p:spPr>
           <a:xfrm>
             <a:off x="566928" y="2011680"/>
-            <a:ext cx="3503066" cy="2114296"/>
+            <a:ext cx="3503066" cy="2757932"/>
           </a:xfrm>
           <a:prstGeom prst="roundRect">
             <a:avLst>
-              <a:gd name="adj" fmla="val 3460"/>
+              <a:gd name="adj" fmla="val 2652"/>
             </a:avLst>
           </a:prstGeom>
           <a:solidFill>
@@ -4981,7 +4981,7 @@
         <p:spPr>
           <a:xfrm>
             <a:off x="804672" y="2798064"/>
-            <a:ext cx="3027578" cy="457200"/>
+            <a:ext cx="3027578" cy="583184"/>
           </a:xfrm>
           <a:prstGeom prst="rect">
             <a:avLst/>
@@ -5005,7 +5005,7 @@
                 <a:ea typeface="Arial" pitchFamily="34" charset="-122"/>
                 <a:cs typeface="Arial" pitchFamily="34" charset="-120"/>
               </a:rPr>
-              <a:t>¿Cuál error habría causado más daño?</a:t>
+              <a:t>¿Cuál error habría hecho más daño?</a:t>
             </a:r>
             <a:endParaRPr lang="en-US" sz="1600" dirty="0"/>
           </a:p>
@@ -5019,8 +5019,8 @@
         </p:nvSpPr>
         <p:spPr>
           <a:xfrm>
-            <a:off x="804672" y="3273552"/>
-            <a:ext cx="3027578" cy="614680"/>
+            <a:off x="804672" y="3527552"/>
+            <a:ext cx="3027578" cy="1040892"/>
           </a:xfrm>
           <a:prstGeom prst="rect">
             <a:avLst/>
@@ -5047,7 +5047,7 @@
                 <a:ea typeface="Calibri" pitchFamily="34" charset="-122"/>
                 <a:cs typeface="Calibri" pitchFamily="34" charset="-120"/>
               </a:rPr>
-              <a:t>Si el informe se hubiera publicado tal cual. Piénsenlo en términos de qué decisión se habría tomado mal.</a:t>
+              <a:t>Si el informe se publica tal cual. Piénsalo en términos de qué decisión se habría tomado mal.</a:t>
             </a:r>
             <a:endParaRPr lang="en-US" sz="1300" dirty="0"/>
           </a:p>
@@ -5062,11 +5062,11 @@
         <p:spPr>
           <a:xfrm>
             <a:off x="4344314" y="2011680"/>
-            <a:ext cx="3503066" cy="2114296"/>
+            <a:ext cx="3503066" cy="2757932"/>
           </a:xfrm>
           <a:prstGeom prst="roundRect">
             <a:avLst>
-              <a:gd name="adj" fmla="val 3460"/>
+              <a:gd name="adj" fmla="val 2652"/>
             </a:avLst>
           </a:prstGeom>
           <a:solidFill>
@@ -5153,7 +5153,7 @@
         <p:spPr>
           <a:xfrm>
             <a:off x="4582058" y="2798064"/>
-            <a:ext cx="3027578" cy="457200"/>
+            <a:ext cx="3027578" cy="583184"/>
           </a:xfrm>
           <a:prstGeom prst="rect">
             <a:avLst/>
@@ -5191,8 +5191,8 @@
         </p:nvSpPr>
         <p:spPr>
           <a:xfrm>
-            <a:off x="4582058" y="3273552"/>
-            <a:ext cx="3027578" cy="614680"/>
+            <a:off x="4582058" y="3527552"/>
+            <a:ext cx="3027578" cy="1040892"/>
           </a:xfrm>
           <a:prstGeom prst="rect">
             <a:avLst/>
@@ -5219,7 +5219,7 @@
                 <a:ea typeface="Calibri" pitchFamily="34" charset="-122"/>
                 <a:cs typeface="Calibri" pitchFamily="34" charset="-120"/>
               </a:rPr>
-              <a:t>Normalmente son muy pocos. Ese solo hallazgo justifica la sesión completa.</a:t>
+              <a:t>Normalmente son muy pocos. Ese solo dato justifica la sesión completa.</a:t>
             </a:r>
             <a:endParaRPr lang="en-US" sz="1300" dirty="0"/>
           </a:p>
@@ -5234,11 +5234,11 @@
         <p:spPr>
           <a:xfrm>
             <a:off x="8121701" y="2011680"/>
-            <a:ext cx="3503066" cy="2114296"/>
+            <a:ext cx="3503066" cy="2757932"/>
           </a:xfrm>
           <a:prstGeom prst="roundRect">
             <a:avLst>
-              <a:gd name="adj" fmla="val 3460"/>
+              <a:gd name="adj" fmla="val 2652"/>
             </a:avLst>
           </a:prstGeom>
           <a:solidFill>
@@ -5325,7 +5325,7 @@
         <p:spPr>
           <a:xfrm>
             <a:off x="8359445" y="2798064"/>
-            <a:ext cx="3027578" cy="457200"/>
+            <a:ext cx="3027578" cy="583184"/>
           </a:xfrm>
           <a:prstGeom prst="rect">
             <a:avLst/>
@@ -5349,7 +5349,7 @@
                 <a:ea typeface="Arial" pitchFamily="34" charset="-122"/>
                 <a:cs typeface="Arial" pitchFamily="34" charset="-120"/>
               </a:rPr>
-              <a:t>¿Cuál de los cuatro pasos rindió más?</a:t>
+              <a:t>¿Cuál de los cuatro pasos te rindió más?</a:t>
             </a:r>
             <a:endParaRPr lang="en-US" sz="1600" dirty="0"/>
           </a:p>
@@ -5363,8 +5363,8 @@
         </p:nvSpPr>
         <p:spPr>
           <a:xfrm>
-            <a:off x="8359445" y="3273552"/>
-            <a:ext cx="3027578" cy="614680"/>
+            <a:off x="8359445" y="3527552"/>
+            <a:ext cx="3027578" cy="1040892"/>
           </a:xfrm>
           <a:prstGeom prst="rect">
             <a:avLst/>
@@ -5391,7 +5391,7 @@
                 <a:ea typeface="Calibri" pitchFamily="34" charset="-122"/>
                 <a:cs typeface="Calibri" pitchFamily="34" charset="-120"/>
               </a:rPr>
-              <a:t>De ahí sale la regla práctica que cada quien se lleva a su trabajo.</a:t>
+              <a:t>De ahí sale la regla práctica que te llevas a tu escritorio.</a:t>
             </a:r>
             <a:endParaRPr lang="en-US" sz="1300" dirty="0"/>
           </a:p>
@@ -5526,7 +5526,7 @@
                 <a:ea typeface="Arial" pitchFamily="34" charset="-122"/>
                 <a:cs typeface="Arial" pitchFamily="34" charset="-120"/>
               </a:rPr>
-              <a:t>Entregables de la sesión 3</a:t>
+              <a:t>Lo que entregas hoy</a:t>
             </a:r>
             <a:endParaRPr lang="en-US" sz="3000" dirty="0"/>
           </a:p>
@@ -5648,7 +5648,7 @@
                 <a:ea typeface="Calibri" pitchFamily="34" charset="-122"/>
                 <a:cs typeface="Calibri" pitchFamily="34" charset="-120"/>
               </a:rPr>
-              <a:t>El dictamen de validación del equipo, con todos los hallazgos verificados.</a:t>
+              <a:t>El dictamen de validación de tu equipo, con todos los hallazgos verificados.</a:t>
             </a:r>
             <a:endParaRPr lang="en-US" sz="1450" dirty="0"/>
           </a:p>
@@ -5770,7 +5770,7 @@
                 <a:ea typeface="Calibri" pitchFamily="34" charset="-122"/>
                 <a:cs typeface="Calibri" pitchFamily="34" charset="-120"/>
               </a:rPr>
-              <a:t>La lista de hallazgos que la herramienta reportó y que ustedes descartaron, con la razón.</a:t>
+              <a:t>La lista de hallazgos que el modelo reportó y que tu equipo descartó, con la razón. Esa lista cuenta a favor.</a:t>
             </a:r>
             <a:endParaRPr lang="en-US" sz="1450" dirty="0"/>
           </a:p>
@@ -5892,7 +5892,7 @@
                 <a:ea typeface="Calibri" pitchFamily="34" charset="-122"/>
                 <a:cs typeface="Calibri" pitchFamily="34" charset="-120"/>
               </a:rPr>
-              <a:t>La bitácora individual actualizada con los prompts de verificación que usaron.</a:t>
+              <a:t>Tu bitácora al día, con los prompts de verificación que usaste.</a:t>
             </a:r>
             <a:endParaRPr lang="en-US" sz="1450" dirty="0"/>
           </a:p>
@@ -6014,7 +6014,7 @@
                 <a:ea typeface="Calibri" pitchFamily="34" charset="-122"/>
                 <a:cs typeface="Calibri" pitchFamily="34" charset="-120"/>
               </a:rPr>
-              <a:t>Con esto cierra el Módulo I. Mañana empieza el trabajo cualitativo.</a:t>
+              <a:t>Con esto cierra el Módulo I. Mañana empieza el trabajo cualitativo, que es donde vas a pasar la mayor parte del tiempo.</a:t>
             </a:r>
             <a:endParaRPr lang="en-US" sz="1450" dirty="0"/>
           </a:p>
@@ -6291,7 +6291,7 @@
                 <a:ea typeface="Calibri" pitchFamily="34" charset="-122"/>
                 <a:cs typeface="Calibri" pitchFamily="34" charset="-120"/>
               </a:rPr>
-              <a:t>Los seis errores típicos, con ejemplos de nuestras propias sesiones</a:t>
+              <a:t>Los seis errores típicos, con ejemplos de estas sesiones</a:t>
             </a:r>
             <a:endParaRPr lang="en-US" sz="1350" dirty="0"/>
           </a:p>
@@ -6615,7 +6615,7 @@
                 <a:ea typeface="Calibri" pitchFamily="34" charset="-122"/>
                 <a:cs typeface="Calibri" pitchFamily="34" charset="-120"/>
               </a:rPr>
-              <a:t>Laboratorio Práctico 1: dictamen de validación por equipos</a:t>
+              <a:t>Laboratorio Práctico 1: tu equipo hace un dictamen</a:t>
             </a:r>
             <a:endParaRPr lang="en-US" sz="1350" dirty="0"/>
           </a:p>
@@ -6723,7 +6723,7 @@
                 <a:ea typeface="Calibri" pitchFamily="34" charset="-122"/>
                 <a:cs typeface="Calibri" pitchFamily="34" charset="-120"/>
               </a:rPr>
-              <a:t>Puesta en común y aplicación de la rúbrica</a:t>
+              <a:t>Puesta en común y rúbrica</a:t>
             </a:r>
             <a:endParaRPr lang="en-US" sz="1350" dirty="0"/>
           </a:p>
@@ -6870,7 +6870,7 @@
                 <a:ea typeface="Calibri" pitchFamily="34" charset="-122"/>
                 <a:cs typeface="Calibri" pitchFamily="34" charset="-120"/>
               </a:rPr>
-              <a:t>Hoy son 65 minutos continuos de laboratorio. Formen equipos de cuatro desde el principio.</a:t>
+              <a:t>Hoy trabajas 65 minutos seguidos en equipo. Forma tu equipo desde el primer minuto.</a:t>
             </a:r>
             <a:endParaRPr lang="en-US" sz="1000" dirty="0"/>
           </a:p>
@@ -7174,7 +7174,7 @@
                 <a:ea typeface="Arial" pitchFamily="34" charset="-122"/>
                 <a:cs typeface="Arial" pitchFamily="34" charset="-120"/>
               </a:rPr>
-              <a:t>Tres que se ven cuando uno los busca</a:t>
+              <a:t>Tres que ves cuando los buscas</a:t>
             </a:r>
             <a:endParaRPr lang="en-US" sz="3200" dirty="0"/>
           </a:p>
@@ -7182,18 +7182,57 @@
       </p:sp>
       <p:sp>
         <p:nvSpPr>
-          <p:cNvPr id="3" name="Shape 1"/>
+          <p:cNvPr id="3" name="Text 1"/>
+          <p:cNvSpPr txBox="1"/>
+          <p:nvPr/>
+        </p:nvSpPr>
+        <p:spPr>
+          <a:xfrm>
+            <a:off x="566928" y="1280160"/>
+            <a:ext cx="9960559" cy="365760"/>
+          </a:xfrm>
+          <a:prstGeom prst="rect">
+            <a:avLst/>
+          </a:prstGeom>
+          <a:noFill/>
+          <a:ln/>
+        </p:spPr>
+        <p:txBody>
+          <a:bodyPr wrap="square" lIns="0" tIns="0" rIns="0" bIns="0" rtlCol="0" anchor="t"/>
+          <a:lstStyle/>
+          <a:p>
+            <a:pPr indent="0" marL="0">
+              <a:buNone/>
+            </a:pPr>
+            <a:r>
+              <a:rPr lang="en-US" sz="1500" dirty="0">
+                <a:solidFill>
+                  <a:srgbClr val="5A6B73"/>
+                </a:solidFill>
+                <a:latin typeface="Calibri" pitchFamily="34" charset="0"/>
+                <a:ea typeface="Calibri" pitchFamily="34" charset="-122"/>
+                <a:cs typeface="Calibri" pitchFamily="34" charset="-120"/>
+              </a:rPr>
+              <a:t>Los tres ya te pasaron en estas dos sesiones. Ahora tienen nombre.</a:t>
+            </a:r>
+            <a:endParaRPr lang="en-US" sz="1500" dirty="0"/>
+          </a:p>
+        </p:txBody>
+      </p:sp>
+      <p:sp>
+        <p:nvSpPr>
+          <p:cNvPr id="4" name="Shape 2"/>
           <p:cNvSpPr/>
           <p:nvPr/>
         </p:nvSpPr>
         <p:spPr>
           <a:xfrm>
-            <a:off x="566928" y="1609344"/>
-            <a:ext cx="3503066" cy="2623058"/>
+            <a:off x="566928" y="2011680"/>
+            <a:ext cx="3503066" cy="3302762"/>
           </a:xfrm>
           <a:prstGeom prst="roundRect">
             <a:avLst>
-              <a:gd name="adj" fmla="val 2789"/>
+              <a:gd name="adj" fmla="val 2215"/>
             </a:avLst>
           </a:prstGeom>
           <a:solidFill>
@@ -7209,13 +7248,13 @@
       </p:sp>
       <p:sp>
         <p:nvSpPr>
-          <p:cNvPr id="4" name="Shape 2"/>
+          <p:cNvPr id="5" name="Shape 3"/>
           <p:cNvSpPr/>
           <p:nvPr/>
         </p:nvSpPr>
         <p:spPr>
           <a:xfrm>
-            <a:off x="804672" y="1828800"/>
+            <a:off x="804672" y="2231136"/>
             <a:ext cx="420624" cy="420624"/>
           </a:xfrm>
           <a:prstGeom prst="ellipse">
@@ -7234,13 +7273,13 @@
       </p:sp>
       <p:sp>
         <p:nvSpPr>
-          <p:cNvPr id="5" name="Text 3"/>
-          <p:cNvSpPr txBox="1"/>
-          <p:nvPr/>
-        </p:nvSpPr>
-        <p:spPr>
-          <a:xfrm>
-            <a:off x="804672" y="1828800"/>
+          <p:cNvPr id="6" name="Text 4"/>
+          <p:cNvSpPr txBox="1"/>
+          <p:nvPr/>
+        </p:nvSpPr>
+        <p:spPr>
+          <a:xfrm>
+            <a:off x="804672" y="2231136"/>
             <a:ext cx="420624" cy="420624"/>
           </a:xfrm>
           <a:prstGeom prst="rect">
@@ -7273,14 +7312,14 @@
       </p:sp>
       <p:sp>
         <p:nvSpPr>
-          <p:cNvPr id="6" name="Text 4"/>
-          <p:cNvSpPr txBox="1"/>
-          <p:nvPr/>
-        </p:nvSpPr>
-        <p:spPr>
-          <a:xfrm>
-            <a:off x="804672" y="2395728"/>
-            <a:ext cx="3027578" cy="457200"/>
+          <p:cNvPr id="7" name="Text 5"/>
+          <p:cNvSpPr txBox="1"/>
+          <p:nvPr/>
+        </p:nvSpPr>
+        <p:spPr>
+          <a:xfrm>
+            <a:off x="804672" y="2798064"/>
+            <a:ext cx="3027578" cy="319024"/>
           </a:xfrm>
           <a:prstGeom prst="rect">
             <a:avLst/>
@@ -7304,7 +7343,7 @@
                 <a:ea typeface="Arial" pitchFamily="34" charset="-122"/>
                 <a:cs typeface="Arial" pitchFamily="34" charset="-120"/>
               </a:rPr>
-              <a:t>Fabricación de fuentes</a:t>
+              <a:t>Inventa fuentes</a:t>
             </a:r>
             <a:endParaRPr lang="en-US" sz="1600" dirty="0"/>
           </a:p>
@@ -7312,14 +7351,14 @@
       </p:sp>
       <p:sp>
         <p:nvSpPr>
-          <p:cNvPr id="7" name="Text 5"/>
-          <p:cNvSpPr txBox="1"/>
-          <p:nvPr/>
-        </p:nvSpPr>
-        <p:spPr>
-          <a:xfrm>
-            <a:off x="804672" y="2871216"/>
-            <a:ext cx="3027578" cy="1123442"/>
+          <p:cNvPr id="8" name="Text 6"/>
+          <p:cNvSpPr txBox="1"/>
+          <p:nvPr/>
+        </p:nvSpPr>
+        <p:spPr>
+          <a:xfrm>
+            <a:off x="804672" y="3263392"/>
+            <a:ext cx="3027578" cy="1849882"/>
           </a:xfrm>
           <a:prstGeom prst="rect">
             <a:avLst/>
@@ -7346,7 +7385,7 @@
                 <a:ea typeface="Calibri" pitchFamily="34" charset="-122"/>
                 <a:cs typeface="Calibri" pitchFamily="34" charset="-120"/>
               </a:rPr>
-              <a:t>Inventa un estudio, un autor o un número de artículo que suena correcto. La descripción es plausible y la referencia no existe.</a:t>
+              <a:t>Se saca de la manga un estudio, un autor o un número de artículo que suena bien. La descripción es creíble y la referencia no existe.</a:t>
             </a:r>
             <a:endParaRPr lang="en-US" sz="1300" dirty="0"/>
           </a:p>
@@ -7375,7 +7414,7 @@
                 <a:ea typeface="Calibri" pitchFamily="34" charset="-122"/>
                 <a:cs typeface="Calibri" pitchFamily="34" charset="-120"/>
               </a:rPr>
-              <a:t>Se detecta buscando la fuente. Casi nadie revisa la bibliografía.</a:t>
+              <a:t>Lo cachas buscando la fuente. Casi nadie revisa la bibliografía.</a:t>
             </a:r>
             <a:endParaRPr lang="en-US" sz="1300" dirty="0"/>
           </a:p>
@@ -7383,18 +7422,18 @@
       </p:sp>
       <p:sp>
         <p:nvSpPr>
-          <p:cNvPr id="8" name="Shape 6"/>
+          <p:cNvPr id="9" name="Shape 7"/>
           <p:cNvSpPr/>
           <p:nvPr/>
         </p:nvSpPr>
         <p:spPr>
           <a:xfrm>
-            <a:off x="4344314" y="1609344"/>
-            <a:ext cx="3503066" cy="2623058"/>
+            <a:off x="4344314" y="2011680"/>
+            <a:ext cx="3503066" cy="3302762"/>
           </a:xfrm>
           <a:prstGeom prst="roundRect">
             <a:avLst>
-              <a:gd name="adj" fmla="val 2789"/>
+              <a:gd name="adj" fmla="val 2215"/>
             </a:avLst>
           </a:prstGeom>
           <a:solidFill>
@@ -7410,13 +7449,13 @@
       </p:sp>
       <p:sp>
         <p:nvSpPr>
-          <p:cNvPr id="9" name="Shape 7"/>
+          <p:cNvPr id="10" name="Shape 8"/>
           <p:cNvSpPr/>
           <p:nvPr/>
         </p:nvSpPr>
         <p:spPr>
           <a:xfrm>
-            <a:off x="4582058" y="1828800"/>
+            <a:off x="4582058" y="2231136"/>
             <a:ext cx="420624" cy="420624"/>
           </a:xfrm>
           <a:prstGeom prst="ellipse">
@@ -7435,13 +7474,13 @@
       </p:sp>
       <p:sp>
         <p:nvSpPr>
-          <p:cNvPr id="10" name="Text 8"/>
-          <p:cNvSpPr txBox="1"/>
-          <p:nvPr/>
-        </p:nvSpPr>
-        <p:spPr>
-          <a:xfrm>
-            <a:off x="4582058" y="1828800"/>
+          <p:cNvPr id="11" name="Text 9"/>
+          <p:cNvSpPr txBox="1"/>
+          <p:nvPr/>
+        </p:nvSpPr>
+        <p:spPr>
+          <a:xfrm>
+            <a:off x="4582058" y="2231136"/>
             <a:ext cx="420624" cy="420624"/>
           </a:xfrm>
           <a:prstGeom prst="rect">
@@ -7474,14 +7513,14 @@
       </p:sp>
       <p:sp>
         <p:nvSpPr>
-          <p:cNvPr id="11" name="Text 9"/>
-          <p:cNvSpPr txBox="1"/>
-          <p:nvPr/>
-        </p:nvSpPr>
-        <p:spPr>
-          <a:xfrm>
-            <a:off x="4582058" y="2395728"/>
-            <a:ext cx="3027578" cy="457200"/>
+          <p:cNvPr id="12" name="Text 10"/>
+          <p:cNvSpPr txBox="1"/>
+          <p:nvPr/>
+        </p:nvSpPr>
+        <p:spPr>
+          <a:xfrm>
+            <a:off x="4582058" y="2798064"/>
+            <a:ext cx="3027578" cy="319024"/>
           </a:xfrm>
           <a:prstGeom prst="rect">
             <a:avLst/>
@@ -7505,7 +7544,7 @@
                 <a:ea typeface="Arial" pitchFamily="34" charset="-122"/>
                 <a:cs typeface="Arial" pitchFamily="34" charset="-120"/>
               </a:rPr>
-              <a:t>Invención de cifras</a:t>
+              <a:t>Inventa cifras</a:t>
             </a:r>
             <a:endParaRPr lang="en-US" sz="1600" dirty="0"/>
           </a:p>
@@ -7513,14 +7552,14 @@
       </p:sp>
       <p:sp>
         <p:nvSpPr>
-          <p:cNvPr id="12" name="Text 10"/>
-          <p:cNvSpPr txBox="1"/>
-          <p:nvPr/>
-        </p:nvSpPr>
-        <p:spPr>
-          <a:xfrm>
-            <a:off x="4582058" y="2871216"/>
-            <a:ext cx="3027578" cy="1123442"/>
+          <p:cNvPr id="13" name="Text 11"/>
+          <p:cNvSpPr txBox="1"/>
+          <p:nvPr/>
+        </p:nvSpPr>
+        <p:spPr>
+          <a:xfrm>
+            <a:off x="4582058" y="3263392"/>
+            <a:ext cx="3027578" cy="1849882"/>
           </a:xfrm>
           <a:prstGeom prst="rect">
             <a:avLst/>
@@ -7547,7 +7586,7 @@
                 <a:ea typeface="Calibri" pitchFamily="34" charset="-122"/>
                 <a:cs typeface="Calibri" pitchFamily="34" charset="-120"/>
               </a:rPr>
-              <a:t>Aparece sobre todo cuando trata de completar una tabla donde falta información. El hueco le incomoda más que el error.</a:t>
+              <a:t>Pasa sobre todo cuando intenta completar una tabla donde falta información. El hueco le incomoda más que el error.</a:t>
             </a:r>
             <a:endParaRPr lang="en-US" sz="1300" dirty="0"/>
           </a:p>
@@ -7576,7 +7615,7 @@
                 <a:ea typeface="Calibri" pitchFamily="34" charset="-122"/>
                 <a:cs typeface="Calibri" pitchFamily="34" charset="-120"/>
               </a:rPr>
-              <a:t>Se detecta recalculando.</a:t>
+              <a:t>Lo cachas recalculando.</a:t>
             </a:r>
             <a:endParaRPr lang="en-US" sz="1300" dirty="0"/>
           </a:p>
@@ -7584,18 +7623,18 @@
       </p:sp>
       <p:sp>
         <p:nvSpPr>
-          <p:cNvPr id="13" name="Shape 11"/>
+          <p:cNvPr id="14" name="Shape 12"/>
           <p:cNvSpPr/>
           <p:nvPr/>
         </p:nvSpPr>
         <p:spPr>
           <a:xfrm>
-            <a:off x="8121701" y="1609344"/>
-            <a:ext cx="3503066" cy="2623058"/>
+            <a:off x="8121701" y="2011680"/>
+            <a:ext cx="3503066" cy="3302762"/>
           </a:xfrm>
           <a:prstGeom prst="roundRect">
             <a:avLst>
-              <a:gd name="adj" fmla="val 2789"/>
+              <a:gd name="adj" fmla="val 2215"/>
             </a:avLst>
           </a:prstGeom>
           <a:solidFill>
@@ -7611,13 +7650,13 @@
       </p:sp>
       <p:sp>
         <p:nvSpPr>
-          <p:cNvPr id="14" name="Shape 12"/>
+          <p:cNvPr id="15" name="Shape 13"/>
           <p:cNvSpPr/>
           <p:nvPr/>
         </p:nvSpPr>
         <p:spPr>
           <a:xfrm>
-            <a:off x="8359445" y="1828800"/>
+            <a:off x="8359445" y="2231136"/>
             <a:ext cx="420624" cy="420624"/>
           </a:xfrm>
           <a:prstGeom prst="ellipse">
@@ -7636,13 +7675,13 @@
       </p:sp>
       <p:sp>
         <p:nvSpPr>
-          <p:cNvPr id="15" name="Text 13"/>
-          <p:cNvSpPr txBox="1"/>
-          <p:nvPr/>
-        </p:nvSpPr>
-        <p:spPr>
-          <a:xfrm>
-            <a:off x="8359445" y="1828800"/>
+          <p:cNvPr id="16" name="Text 14"/>
+          <p:cNvSpPr txBox="1"/>
+          <p:nvPr/>
+        </p:nvSpPr>
+        <p:spPr>
+          <a:xfrm>
+            <a:off x="8359445" y="2231136"/>
             <a:ext cx="420624" cy="420624"/>
           </a:xfrm>
           <a:prstGeom prst="rect">
@@ -7675,14 +7714,14 @@
       </p:sp>
       <p:sp>
         <p:nvSpPr>
-          <p:cNvPr id="16" name="Text 14"/>
-          <p:cNvSpPr txBox="1"/>
-          <p:nvPr/>
-        </p:nvSpPr>
-        <p:spPr>
-          <a:xfrm>
-            <a:off x="8359445" y="2395728"/>
-            <a:ext cx="3027578" cy="457200"/>
+          <p:cNvPr id="17" name="Text 15"/>
+          <p:cNvSpPr txBox="1"/>
+          <p:nvPr/>
+        </p:nvSpPr>
+        <p:spPr>
+          <a:xfrm>
+            <a:off x="8359445" y="2798064"/>
+            <a:ext cx="3027578" cy="319024"/>
           </a:xfrm>
           <a:prstGeom prst="rect">
             <a:avLst/>
@@ -7706,7 +7745,7 @@
                 <a:ea typeface="Arial" pitchFamily="34" charset="-122"/>
                 <a:cs typeface="Arial" pitchFamily="34" charset="-120"/>
               </a:rPr>
-              <a:t>Confusión de periodos</a:t>
+              <a:t>Mezcla años</a:t>
             </a:r>
             <a:endParaRPr lang="en-US" sz="1600" dirty="0"/>
           </a:p>
@@ -7714,14 +7753,14 @@
       </p:sp>
       <p:sp>
         <p:nvSpPr>
-          <p:cNvPr id="17" name="Text 15"/>
-          <p:cNvSpPr txBox="1"/>
-          <p:nvPr/>
-        </p:nvSpPr>
-        <p:spPr>
-          <a:xfrm>
-            <a:off x="8359445" y="2871216"/>
-            <a:ext cx="3027578" cy="1123442"/>
+          <p:cNvPr id="18" name="Text 16"/>
+          <p:cNvSpPr txBox="1"/>
+          <p:nvPr/>
+        </p:nvSpPr>
+        <p:spPr>
+          <a:xfrm>
+            <a:off x="8359445" y="3263392"/>
+            <a:ext cx="3027578" cy="1849882"/>
           </a:xfrm>
           <a:prstGeom prst="rect">
             <a:avLst/>
@@ -7748,7 +7787,7 @@
                 <a:ea typeface="Calibri" pitchFamily="34" charset="-122"/>
                 <a:cs typeface="Calibri" pitchFamily="34" charset="-120"/>
               </a:rPr>
-              <a:t>Mezcla datos de años distintos sin avisar, o presenta como línea base valores de ejercicios diferentes.</a:t>
+              <a:t>Junta datos de periodos distintos sin avisar, o presenta como línea base valores de ejercicios diferentes.</a:t>
             </a:r>
             <a:endParaRPr lang="en-US" sz="1300" dirty="0"/>
           </a:p>
@@ -7777,7 +7816,7 @@
                 <a:ea typeface="Calibri" pitchFamily="34" charset="-122"/>
                 <a:cs typeface="Calibri" pitchFamily="34" charset="-120"/>
               </a:rPr>
-              <a:t>Se detecta leyendo la metodología antes que los resultados.</a:t>
+              <a:t>Lo cachas leyendo la metodología antes que los resultados.</a:t>
             </a:r>
             <a:endParaRPr lang="en-US" sz="1300" dirty="0"/>
           </a:p>
@@ -7841,7 +7880,7 @@
                 <a:ea typeface="Arial" pitchFamily="34" charset="-122"/>
                 <a:cs typeface="Arial" pitchFamily="34" charset="-120"/>
               </a:rPr>
-              <a:t>Tres que se ven solo si uno sabe que existen</a:t>
+              <a:t>Tres que solo ves si sabes que existen</a:t>
             </a:r>
             <a:endParaRPr lang="en-US" sz="3200" dirty="0"/>
           </a:p>
@@ -7849,18 +7888,57 @@
       </p:sp>
       <p:sp>
         <p:nvSpPr>
-          <p:cNvPr id="3" name="Shape 1"/>
+          <p:cNvPr id="3" name="Text 1"/>
+          <p:cNvSpPr txBox="1"/>
+          <p:nvPr/>
+        </p:nvSpPr>
+        <p:spPr>
+          <a:xfrm>
+            <a:off x="566928" y="1280160"/>
+            <a:ext cx="9960559" cy="365760"/>
+          </a:xfrm>
+          <a:prstGeom prst="rect">
+            <a:avLst/>
+          </a:prstGeom>
+          <a:noFill/>
+          <a:ln/>
+        </p:spPr>
+        <p:txBody>
+          <a:bodyPr wrap="square" lIns="0" tIns="0" rIns="0" bIns="0" rtlCol="0" anchor="t"/>
+          <a:lstStyle/>
+          <a:p>
+            <a:pPr indent="0" marL="0">
+              <a:buNone/>
+            </a:pPr>
+            <a:r>
+              <a:rPr lang="en-US" sz="1500" dirty="0">
+                <a:solidFill>
+                  <a:srgbClr val="5A6B73"/>
+                </a:solidFill>
+                <a:latin typeface="Calibri" pitchFamily="34" charset="0"/>
+                <a:ea typeface="Calibri" pitchFamily="34" charset="-122"/>
+                <a:cs typeface="Calibri" pitchFamily="34" charset="-120"/>
+              </a:rPr>
+              <a:t>Estos son los caros. Nada de lo que está escrito es falso.</a:t>
+            </a:r>
+            <a:endParaRPr lang="en-US" sz="1500" dirty="0"/>
+          </a:p>
+        </p:txBody>
+      </p:sp>
+      <p:sp>
+        <p:nvSpPr>
+          <p:cNvPr id="4" name="Shape 2"/>
           <p:cNvSpPr/>
           <p:nvPr/>
         </p:nvSpPr>
         <p:spPr>
           <a:xfrm>
-            <a:off x="566928" y="1609344"/>
-            <a:ext cx="3503066" cy="2623058"/>
+            <a:off x="566928" y="2011680"/>
+            <a:ext cx="3503066" cy="3302762"/>
           </a:xfrm>
           <a:prstGeom prst="roundRect">
             <a:avLst>
-              <a:gd name="adj" fmla="val 2789"/>
+              <a:gd name="adj" fmla="val 2215"/>
             </a:avLst>
           </a:prstGeom>
           <a:solidFill>
@@ -7876,13 +7954,13 @@
       </p:sp>
       <p:sp>
         <p:nvSpPr>
-          <p:cNvPr id="4" name="Shape 2"/>
+          <p:cNvPr id="5" name="Shape 3"/>
           <p:cNvSpPr/>
           <p:nvPr/>
         </p:nvSpPr>
         <p:spPr>
           <a:xfrm>
-            <a:off x="804672" y="1828800"/>
+            <a:off x="804672" y="2231136"/>
             <a:ext cx="420624" cy="420624"/>
           </a:xfrm>
           <a:prstGeom prst="ellipse">
@@ -7901,13 +7979,13 @@
       </p:sp>
       <p:sp>
         <p:nvSpPr>
-          <p:cNvPr id="5" name="Text 3"/>
-          <p:cNvSpPr txBox="1"/>
-          <p:nvPr/>
-        </p:nvSpPr>
-        <p:spPr>
-          <a:xfrm>
-            <a:off x="804672" y="1828800"/>
+          <p:cNvPr id="6" name="Text 4"/>
+          <p:cNvSpPr txBox="1"/>
+          <p:nvPr/>
+        </p:nvSpPr>
+        <p:spPr>
+          <a:xfrm>
+            <a:off x="804672" y="2231136"/>
             <a:ext cx="420624" cy="420624"/>
           </a:xfrm>
           <a:prstGeom prst="rect">
@@ -7940,14 +8018,14 @@
       </p:sp>
       <p:sp>
         <p:nvSpPr>
-          <p:cNvPr id="6" name="Text 4"/>
-          <p:cNvSpPr txBox="1"/>
-          <p:nvPr/>
-        </p:nvSpPr>
-        <p:spPr>
-          <a:xfrm>
-            <a:off x="804672" y="2395728"/>
-            <a:ext cx="3027578" cy="457200"/>
+          <p:cNvPr id="7" name="Text 5"/>
+          <p:cNvSpPr txBox="1"/>
+          <p:nvPr/>
+        </p:nvSpPr>
+        <p:spPr>
+          <a:xfrm>
+            <a:off x="804672" y="2798064"/>
+            <a:ext cx="3027578" cy="319024"/>
           </a:xfrm>
           <a:prstGeom prst="rect">
             <a:avLst/>
@@ -7971,7 +8049,7 @@
                 <a:ea typeface="Arial" pitchFamily="34" charset="-122"/>
                 <a:cs typeface="Arial" pitchFamily="34" charset="-120"/>
               </a:rPr>
-              <a:t>Sesgo de complacencia</a:t>
+              <a:t>Te da la razón</a:t>
             </a:r>
             <a:endParaRPr lang="en-US" sz="1600" dirty="0"/>
           </a:p>
@@ -7979,14 +8057,14 @@
       </p:sp>
       <p:sp>
         <p:nvSpPr>
-          <p:cNvPr id="7" name="Text 5"/>
-          <p:cNvSpPr txBox="1"/>
-          <p:nvPr/>
-        </p:nvSpPr>
-        <p:spPr>
-          <a:xfrm>
-            <a:off x="804672" y="2871216"/>
-            <a:ext cx="3027578" cy="1123442"/>
+          <p:cNvPr id="8" name="Text 6"/>
+          <p:cNvSpPr txBox="1"/>
+          <p:nvPr/>
+        </p:nvSpPr>
+        <p:spPr>
+          <a:xfrm>
+            <a:off x="804672" y="3263392"/>
+            <a:ext cx="3027578" cy="1849882"/>
           </a:xfrm>
           <a:prstGeom prst="rect">
             <a:avLst/>
@@ -8013,7 +8091,7 @@
                 <a:ea typeface="Calibri" pitchFamily="34" charset="-122"/>
                 <a:cs typeface="Calibri" pitchFamily="34" charset="-120"/>
               </a:rPr>
-              <a:t>Tiende a darle la razón a quien pregunta, incluso cuando la premisa de la pregunta es falsa.</a:t>
+              <a:t>Tiende a confirmar lo que tú ya afirmaste, aunque tu premisa sea falsa.</a:t>
             </a:r>
             <a:endParaRPr lang="en-US" sz="1300" dirty="0"/>
           </a:p>
@@ -8042,7 +8120,7 @@
                 <a:ea typeface="Calibri" pitchFamily="34" charset="-122"/>
                 <a:cs typeface="Calibri" pitchFamily="34" charset="-120"/>
               </a:rPr>
-              <a:t>No miente: selecciona la evidencia que confirma lo que usted ya le dijo que quería oír.</a:t>
+              <a:t>No te miente: elige la evidencia que confirma lo que le dijiste que querías oír.</a:t>
             </a:r>
             <a:endParaRPr lang="en-US" sz="1300" dirty="0"/>
           </a:p>
@@ -8050,18 +8128,18 @@
       </p:sp>
       <p:sp>
         <p:nvSpPr>
-          <p:cNvPr id="8" name="Shape 6"/>
+          <p:cNvPr id="9" name="Shape 7"/>
           <p:cNvSpPr/>
           <p:nvPr/>
         </p:nvSpPr>
         <p:spPr>
           <a:xfrm>
-            <a:off x="4344314" y="1609344"/>
-            <a:ext cx="3503066" cy="2623058"/>
+            <a:off x="4344314" y="2011680"/>
+            <a:ext cx="3503066" cy="3302762"/>
           </a:xfrm>
           <a:prstGeom prst="roundRect">
             <a:avLst>
-              <a:gd name="adj" fmla="val 2789"/>
+              <a:gd name="adj" fmla="val 2215"/>
             </a:avLst>
           </a:prstGeom>
           <a:solidFill>
@@ -8077,13 +8155,13 @@
       </p:sp>
       <p:sp>
         <p:nvSpPr>
-          <p:cNvPr id="9" name="Shape 7"/>
+          <p:cNvPr id="10" name="Shape 8"/>
           <p:cNvSpPr/>
           <p:nvPr/>
         </p:nvSpPr>
         <p:spPr>
           <a:xfrm>
-            <a:off x="4582058" y="1828800"/>
+            <a:off x="4582058" y="2231136"/>
             <a:ext cx="420624" cy="420624"/>
           </a:xfrm>
           <a:prstGeom prst="ellipse">
@@ -8102,13 +8180,13 @@
       </p:sp>
       <p:sp>
         <p:nvSpPr>
-          <p:cNvPr id="10" name="Text 8"/>
-          <p:cNvSpPr txBox="1"/>
-          <p:nvPr/>
-        </p:nvSpPr>
-        <p:spPr>
-          <a:xfrm>
-            <a:off x="4582058" y="1828800"/>
+          <p:cNvPr id="11" name="Text 9"/>
+          <p:cNvSpPr txBox="1"/>
+          <p:nvPr/>
+        </p:nvSpPr>
+        <p:spPr>
+          <a:xfrm>
+            <a:off x="4582058" y="2231136"/>
             <a:ext cx="420624" cy="420624"/>
           </a:xfrm>
           <a:prstGeom prst="rect">
@@ -8141,14 +8219,14 @@
       </p:sp>
       <p:sp>
         <p:nvSpPr>
-          <p:cNvPr id="11" name="Text 9"/>
-          <p:cNvSpPr txBox="1"/>
-          <p:nvPr/>
-        </p:nvSpPr>
-        <p:spPr>
-          <a:xfrm>
-            <a:off x="4582058" y="2395728"/>
-            <a:ext cx="3027578" cy="457200"/>
+          <p:cNvPr id="12" name="Text 10"/>
+          <p:cNvSpPr txBox="1"/>
+          <p:nvPr/>
+        </p:nvSpPr>
+        <p:spPr>
+          <a:xfrm>
+            <a:off x="4582058" y="2798064"/>
+            <a:ext cx="3027578" cy="319024"/>
           </a:xfrm>
           <a:prstGeom prst="rect">
             <a:avLst/>
@@ -8172,7 +8250,7 @@
                 <a:ea typeface="Arial" pitchFamily="34" charset="-122"/>
                 <a:cs typeface="Arial" pitchFamily="34" charset="-120"/>
               </a:rPr>
-              <a:t>Generalización sin evidencia</a:t>
+              <a:t>Generaliza de más</a:t>
             </a:r>
             <a:endParaRPr lang="en-US" sz="1600" dirty="0"/>
           </a:p>
@@ -8180,14 +8258,14 @@
       </p:sp>
       <p:sp>
         <p:nvSpPr>
-          <p:cNvPr id="12" name="Text 10"/>
-          <p:cNvSpPr txBox="1"/>
-          <p:nvPr/>
-        </p:nvSpPr>
-        <p:spPr>
-          <a:xfrm>
-            <a:off x="4582058" y="2871216"/>
-            <a:ext cx="3027578" cy="1123442"/>
+          <p:cNvPr id="13" name="Text 11"/>
+          <p:cNvSpPr txBox="1"/>
+          <p:nvPr/>
+        </p:nvSpPr>
+        <p:spPr>
+          <a:xfrm>
+            <a:off x="4582058" y="3263392"/>
+            <a:ext cx="3027578" cy="1849882"/>
           </a:xfrm>
           <a:prstGeom prst="rect">
             <a:avLst/>
@@ -8214,7 +8292,7 @@
                 <a:ea typeface="Calibri" pitchFamily="34" charset="-122"/>
                 <a:cs typeface="Calibri" pitchFamily="34" charset="-120"/>
               </a:rPr>
-              <a:t>Extiende a todos los casos una conclusión que era válida para uno. O concluye sobre algo que nunca midió.</a:t>
+              <a:t>Extiende a todos los casos una conclusión que valía para uno. O concluye sobre algo que nunca midió.</a:t>
             </a:r>
             <a:endParaRPr lang="en-US" sz="1300" dirty="0"/>
           </a:p>
@@ -8243,7 +8321,7 @@
                 <a:ea typeface="Calibri" pitchFamily="34" charset="-122"/>
                 <a:cs typeface="Calibri" pitchFamily="34" charset="-120"/>
               </a:rPr>
-              <a:t>Se detecta preguntando dónde está el dato que sostiene la frase.</a:t>
+              <a:t>Lo cachas preguntando dónde está el dato que sostiene la frase.</a:t>
             </a:r>
             <a:endParaRPr lang="en-US" sz="1300" dirty="0"/>
           </a:p>
@@ -8251,18 +8329,18 @@
       </p:sp>
       <p:sp>
         <p:nvSpPr>
-          <p:cNvPr id="13" name="Shape 11"/>
+          <p:cNvPr id="14" name="Shape 12"/>
           <p:cNvSpPr/>
           <p:nvPr/>
         </p:nvSpPr>
         <p:spPr>
           <a:xfrm>
-            <a:off x="8121701" y="1609344"/>
-            <a:ext cx="3503066" cy="2623058"/>
+            <a:off x="8121701" y="2011680"/>
+            <a:ext cx="3503066" cy="3302762"/>
           </a:xfrm>
           <a:prstGeom prst="roundRect">
             <a:avLst>
-              <a:gd name="adj" fmla="val 2789"/>
+              <a:gd name="adj" fmla="val 2215"/>
             </a:avLst>
           </a:prstGeom>
           <a:solidFill>
@@ -8278,13 +8356,13 @@
       </p:sp>
       <p:sp>
         <p:nvSpPr>
-          <p:cNvPr id="14" name="Shape 12"/>
+          <p:cNvPr id="15" name="Shape 13"/>
           <p:cNvSpPr/>
           <p:nvPr/>
         </p:nvSpPr>
         <p:spPr>
           <a:xfrm>
-            <a:off x="8359445" y="1828800"/>
+            <a:off x="8359445" y="2231136"/>
             <a:ext cx="420624" cy="420624"/>
           </a:xfrm>
           <a:prstGeom prst="ellipse">
@@ -8303,13 +8381,13 @@
       </p:sp>
       <p:sp>
         <p:nvSpPr>
-          <p:cNvPr id="15" name="Text 13"/>
-          <p:cNvSpPr txBox="1"/>
-          <p:nvPr/>
-        </p:nvSpPr>
-        <p:spPr>
-          <a:xfrm>
-            <a:off x="8359445" y="1828800"/>
+          <p:cNvPr id="16" name="Text 14"/>
+          <p:cNvSpPr txBox="1"/>
+          <p:nvPr/>
+        </p:nvSpPr>
+        <p:spPr>
+          <a:xfrm>
+            <a:off x="8359445" y="2231136"/>
             <a:ext cx="420624" cy="420624"/>
           </a:xfrm>
           <a:prstGeom prst="rect">
@@ -8342,14 +8420,14 @@
       </p:sp>
       <p:sp>
         <p:nvSpPr>
-          <p:cNvPr id="16" name="Text 14"/>
-          <p:cNvSpPr txBox="1"/>
-          <p:nvPr/>
-        </p:nvSpPr>
-        <p:spPr>
-          <a:xfrm>
-            <a:off x="8359445" y="2395728"/>
-            <a:ext cx="3027578" cy="457200"/>
+          <p:cNvPr id="17" name="Text 15"/>
+          <p:cNvSpPr txBox="1"/>
+          <p:nvPr/>
+        </p:nvSpPr>
+        <p:spPr>
+          <a:xfrm>
+            <a:off x="8359445" y="2798064"/>
+            <a:ext cx="3027578" cy="319024"/>
           </a:xfrm>
           <a:prstGeom prst="rect">
             <a:avLst/>
@@ -8373,7 +8451,7 @@
                 <a:ea typeface="Arial" pitchFamily="34" charset="-122"/>
                 <a:cs typeface="Arial" pitchFamily="34" charset="-120"/>
               </a:rPr>
-              <a:t>Omisión silenciosa</a:t>
+              <a:t>Omite sin avisar</a:t>
             </a:r>
             <a:endParaRPr lang="en-US" sz="1600" dirty="0"/>
           </a:p>
@@ -8381,14 +8459,14 @@
       </p:sp>
       <p:sp>
         <p:nvSpPr>
-          <p:cNvPr id="17" name="Text 15"/>
-          <p:cNvSpPr txBox="1"/>
-          <p:nvPr/>
-        </p:nvSpPr>
-        <p:spPr>
-          <a:xfrm>
-            <a:off x="8359445" y="2871216"/>
-            <a:ext cx="3027578" cy="1123442"/>
+          <p:cNvPr id="18" name="Text 16"/>
+          <p:cNvSpPr txBox="1"/>
+          <p:nvPr/>
+        </p:nvSpPr>
+        <p:spPr>
+          <a:xfrm>
+            <a:off x="8359445" y="3263392"/>
+            <a:ext cx="3027578" cy="1849882"/>
           </a:xfrm>
           <a:prstGeom prst="rect">
             <a:avLst/>
@@ -8415,7 +8493,7 @@
                 <a:ea typeface="Calibri" pitchFamily="34" charset="-122"/>
                 <a:cs typeface="Calibri" pitchFamily="34" charset="-120"/>
               </a:rPr>
-              <a:t>El más peligroso de los seis. Deja fuera información relevante sin decir que la dejó fuera.</a:t>
+              <a:t>El más peligroso de los seis. Deja fuera información importante sin decir que la dejó fuera.</a:t>
             </a:r>
             <a:endParaRPr lang="en-US" sz="1300" dirty="0"/>
           </a:p>
@@ -8444,7 +8522,7 @@
                 <a:ea typeface="Calibri" pitchFamily="34" charset="-122"/>
                 <a:cs typeface="Calibri" pitchFamily="34" charset="-120"/>
               </a:rPr>
-              <a:t>No hay nada escrito que sea falso. Solo falta algo, y por eso es tan difícil de ver.</a:t>
+              <a:t>No hay nada escrito que sea falso. Solo falta algo. Por eso es tan difícil de ver.</a:t>
             </a:r>
             <a:endParaRPr lang="en-US" sz="1300" dirty="0"/>
           </a:p>
@@ -8582,7 +8660,7 @@
                 <a:ea typeface="Arial" pitchFamily="34" charset="-122"/>
                 <a:cs typeface="Arial" pitchFamily="34" charset="-120"/>
               </a:rPr>
-              <a:t>Le voy a decir al modelo algo falso sobre un programa social. Vean si lo acepta y lo desarrolla.</a:t>
+              <a:t>Le voy a decir al modelo algo falso sobre un programa social. Fíjense si lo acepta y lo desarrolla.</a:t>
             </a:r>
             <a:endParaRPr lang="en-US" sz="3000" dirty="0"/>
           </a:p>
@@ -8624,7 +8702,7 @@
                 <a:ea typeface="Calibri" pitchFamily="34" charset="-122"/>
                 <a:cs typeface="Calibri" pitchFamily="34" charset="-120"/>
               </a:rPr>
-              <a:t>Esta es la demostración del sesgo de complacencia. Es la que más molesta y la que más se recuerda. Lo que hay que observar no es que se equivoque, sino que se equivoque con seguridad y con argumentos bien redactados.</a:t>
+              <a:t>Esta es la demostración del error número 4, el de darte la razón. Es la que más molesta y la que más se recuerda. Lo que hay que observar no es que se equivoque, sino que se equivoque con seguridad y con argumentos bien redactados.</a:t>
             </a:r>
             <a:endParaRPr lang="en-US" sz="1600" dirty="0"/>
           </a:p>
@@ -8798,7 +8876,7 @@
                 <a:ea typeface="Arial" pitchFamily="34" charset="-122"/>
                 <a:cs typeface="Arial" pitchFamily="34" charset="-120"/>
               </a:rPr>
-              <a:t>El protocolo de verificación en cuatro pasos</a:t>
+              <a:t>El protocolo de verificación</a:t>
             </a:r>
             <a:endParaRPr lang="en-US" sz="3400" dirty="0"/>
           </a:p>
@@ -8928,7 +9006,7 @@
                 <a:ea typeface="Arial" pitchFamily="34" charset="-122"/>
                 <a:cs typeface="Arial" pitchFamily="34" charset="-120"/>
               </a:rPr>
-              <a:t>Cuatro pasos, siempre los cuatro</a:t>
+              <a:t>Cuatro pasos, siempre en este orden</a:t>
             </a:r>
             <a:endParaRPr lang="en-US" sz="3200" dirty="0"/>
           </a:p>
@@ -8967,7 +9045,7 @@
                 <a:ea typeface="Calibri" pitchFamily="34" charset="-122"/>
                 <a:cs typeface="Calibri" pitchFamily="34" charset="-120"/>
               </a:rPr>
-              <a:t>Este es el protocolo que vamos a usar el resto del curso. No es negociable saltarse pasos.</a:t>
+              <a:t>Es el protocolo que vas a usar el resto del curso. Saltarte pasos no es negociable.</a:t>
             </a:r>
             <a:endParaRPr lang="en-US" sz="1500" dirty="0"/>
           </a:p>
@@ -8981,12 +9059,12 @@
         </p:nvSpPr>
         <p:spPr>
           <a:xfrm>
-            <a:off x="566928" y="2011680"/>
-            <a:ext cx="2558720" cy="2732024"/>
+            <a:off x="566928" y="1810512"/>
+            <a:ext cx="2448992" cy="3950208"/>
           </a:xfrm>
           <a:prstGeom prst="roundRect">
             <a:avLst>
-              <a:gd name="adj" fmla="val 2859"/>
+              <a:gd name="adj" fmla="val 3360"/>
             </a:avLst>
           </a:prstGeom>
           <a:solidFill>
@@ -9008,8 +9086,8 @@
         </p:nvSpPr>
         <p:spPr>
           <a:xfrm>
-            <a:off x="804672" y="2231136"/>
-            <a:ext cx="420624" cy="420624"/>
+            <a:off x="1507960" y="2066544"/>
+            <a:ext cx="566928" cy="566928"/>
           </a:xfrm>
           <a:prstGeom prst="ellipse">
             <a:avLst/>
@@ -9033,8 +9111,8 @@
         </p:nvSpPr>
         <p:spPr>
           <a:xfrm>
-            <a:off x="804672" y="2231136"/>
-            <a:ext cx="420624" cy="420624"/>
+            <a:off x="1507960" y="2066544"/>
+            <a:ext cx="566928" cy="566928"/>
           </a:xfrm>
           <a:prstGeom prst="rect">
             <a:avLst/>
@@ -9050,7 +9128,7 @@
               <a:buNone/>
             </a:pPr>
             <a:r>
-              <a:rPr lang="en-US" sz="1400" b="1" dirty="0">
+              <a:rPr lang="en-US" sz="2000" b="1" dirty="0">
                 <a:solidFill>
                   <a:srgbClr val="FFFFFF"/>
                 </a:solidFill>
@@ -9060,7 +9138,7 @@
               </a:rPr>
               <a:t>1</a:t>
             </a:r>
-            <a:endParaRPr lang="en-US" sz="1400" dirty="0"/>
+            <a:endParaRPr lang="en-US" sz="2000" dirty="0"/>
           </a:p>
         </p:txBody>
       </p:sp>
@@ -9072,7 +9150,7 @@
         </p:nvSpPr>
         <p:spPr>
           <a:xfrm>
-            <a:off x="804672" y="2798064"/>
+            <a:off x="749808" y="2743200"/>
             <a:ext cx="2083232" cy="457200"/>
           </a:xfrm>
           <a:prstGeom prst="rect">
@@ -9085,7 +9163,7 @@
           <a:bodyPr wrap="square" lIns="0" tIns="0" rIns="0" bIns="0" rtlCol="0" anchor="t"/>
           <a:lstStyle/>
           <a:p>
-            <a:pPr indent="0" marL="0">
+            <a:pPr algn="ctr" indent="0" marL="0">
               <a:buNone/>
             </a:pPr>
             <a:r>
@@ -9097,7 +9175,7 @@
                 <a:ea typeface="Arial" pitchFamily="34" charset="-122"/>
                 <a:cs typeface="Arial" pitchFamily="34" charset="-120"/>
               </a:rPr>
-              <a:t>Trazar</a:t>
+              <a:t>Traza</a:t>
             </a:r>
             <a:endParaRPr lang="en-US" sz="1600" dirty="0"/>
           </a:p>
@@ -9111,8 +9189,8 @@
         </p:nvSpPr>
         <p:spPr>
           <a:xfrm>
-            <a:off x="804672" y="3273552"/>
-            <a:ext cx="2083232" cy="1232408"/>
+            <a:off x="786384" y="3273552"/>
+            <a:ext cx="2010080" cy="2304288"/>
           </a:xfrm>
           <a:prstGeom prst="rect">
             <a:avLst/>
@@ -9126,12 +9204,12 @@
           <a:p>
             <a:pPr indent="0" marL="0">
               <a:lnSpc>
-                <a:spcPct val="110000"/>
+                <a:spcPct val="112000"/>
               </a:lnSpc>
               <a:buNone/>
             </a:pPr>
             <a:r>
-              <a:rPr lang="en-US" sz="1300" dirty="0">
+              <a:rPr lang="en-US" sz="1250" dirty="0">
                 <a:solidFill>
                   <a:srgbClr val="16262E"/>
                 </a:solidFill>
@@ -9139,9 +9217,38 @@
                 <a:ea typeface="Calibri" pitchFamily="34" charset="-122"/>
                 <a:cs typeface="Calibri" pitchFamily="34" charset="-120"/>
               </a:rPr>
-              <a:t>Cada afirmación debe poder señalar el documento y la sección de donde salió. Lo que no se puede trazar se marca y se investiga aparte.</a:t>
-            </a:r>
-            <a:endParaRPr lang="en-US" sz="1300" dirty="0"/>
+              <a:t>Cada afirmación tiene que poder señalar el documento y la sección de donde salió.</a:t>
+            </a:r>
+            <a:endParaRPr lang="en-US" sz="1250" dirty="0"/>
+          </a:p>
+          <a:p>
+            <a:pPr indent="0" marL="0">
+              <a:lnSpc>
+                <a:spcPct val="112000"/>
+              </a:lnSpc>
+              <a:buNone/>
+            </a:pPr>
+            <a:endParaRPr lang="en-US" sz="1250" dirty="0"/>
+          </a:p>
+          <a:p>
+            <a:pPr indent="0" marL="0">
+              <a:lnSpc>
+                <a:spcPct val="112000"/>
+              </a:lnSpc>
+              <a:buNone/>
+            </a:pPr>
+            <a:r>
+              <a:rPr lang="en-US" sz="1250" dirty="0">
+                <a:solidFill>
+                  <a:srgbClr val="16262E"/>
+                </a:solidFill>
+                <a:latin typeface="Calibri" pitchFamily="34" charset="0"/>
+                <a:ea typeface="Calibri" pitchFamily="34" charset="-122"/>
+                <a:cs typeface="Calibri" pitchFamily="34" charset="-120"/>
+              </a:rPr>
+              <a:t>Lo que no puedas trazar, márcalo e investígalo aparte.</a:t>
+            </a:r>
+            <a:endParaRPr lang="en-US" sz="1250" dirty="0"/>
           </a:p>
         </p:txBody>
       </p:sp>
@@ -9153,12 +9260,37 @@
         </p:nvSpPr>
         <p:spPr>
           <a:xfrm>
-            <a:off x="3399968" y="2011680"/>
-            <a:ext cx="2558720" cy="2732024"/>
+            <a:off x="3089072" y="2194560"/>
+            <a:ext cx="274320" cy="310896"/>
+          </a:xfrm>
+          <a:prstGeom prst="rightArrow">
+            <a:avLst/>
+          </a:prstGeom>
+          <a:solidFill>
+            <a:srgbClr val="5A6B73"/>
+          </a:solidFill>
+          <a:ln w="12700">
+            <a:solidFill>
+              <a:srgbClr val="5A6B73"/>
+            </a:solidFill>
+            <a:prstDash val="solid"/>
+          </a:ln>
+        </p:spPr>
+      </p:sp>
+      <p:sp>
+        <p:nvSpPr>
+          <p:cNvPr id="10" name="Shape 8"/>
+          <p:cNvSpPr/>
+          <p:nvPr/>
+        </p:nvSpPr>
+        <p:spPr>
+          <a:xfrm>
+            <a:off x="3436544" y="1810512"/>
+            <a:ext cx="2448992" cy="3950208"/>
           </a:xfrm>
           <a:prstGeom prst="roundRect">
             <a:avLst>
-              <a:gd name="adj" fmla="val 2859"/>
+              <a:gd name="adj" fmla="val 3360"/>
             </a:avLst>
           </a:prstGeom>
           <a:solidFill>
@@ -9174,14 +9306,14 @@
       </p:sp>
       <p:sp>
         <p:nvSpPr>
-          <p:cNvPr id="10" name="Shape 8"/>
+          <p:cNvPr id="11" name="Shape 9"/>
           <p:cNvSpPr/>
           <p:nvPr/>
         </p:nvSpPr>
         <p:spPr>
           <a:xfrm>
-            <a:off x="3637712" y="2231136"/>
-            <a:ext cx="420624" cy="420624"/>
+            <a:off x="4377576" y="2066544"/>
+            <a:ext cx="566928" cy="566928"/>
           </a:xfrm>
           <a:prstGeom prst="ellipse">
             <a:avLst/>
@@ -9199,14 +9331,14 @@
       </p:sp>
       <p:sp>
         <p:nvSpPr>
-          <p:cNvPr id="11" name="Text 9"/>
-          <p:cNvSpPr txBox="1"/>
-          <p:nvPr/>
-        </p:nvSpPr>
-        <p:spPr>
-          <a:xfrm>
-            <a:off x="3637712" y="2231136"/>
-            <a:ext cx="420624" cy="420624"/>
+          <p:cNvPr id="12" name="Text 10"/>
+          <p:cNvSpPr txBox="1"/>
+          <p:nvPr/>
+        </p:nvSpPr>
+        <p:spPr>
+          <a:xfrm>
+            <a:off x="4377576" y="2066544"/>
+            <a:ext cx="566928" cy="566928"/>
           </a:xfrm>
           <a:prstGeom prst="rect">
             <a:avLst/>
@@ -9222,7 +9354,7 @@
               <a:buNone/>
             </a:pPr>
             <a:r>
-              <a:rPr lang="en-US" sz="1400" b="1" dirty="0">
+              <a:rPr lang="en-US" sz="2000" b="1" dirty="0">
                 <a:solidFill>
                   <a:srgbClr val="FFFFFF"/>
                 </a:solidFill>
@@ -9232,19 +9364,19 @@
               </a:rPr>
               <a:t>2</a:t>
             </a:r>
-            <a:endParaRPr lang="en-US" sz="1400" dirty="0"/>
-          </a:p>
-        </p:txBody>
-      </p:sp>
-      <p:sp>
-        <p:nvSpPr>
-          <p:cNvPr id="12" name="Text 10"/>
-          <p:cNvSpPr txBox="1"/>
-          <p:nvPr/>
-        </p:nvSpPr>
-        <p:spPr>
-          <a:xfrm>
-            <a:off x="3637712" y="2798064"/>
+            <a:endParaRPr lang="en-US" sz="2000" dirty="0"/>
+          </a:p>
+        </p:txBody>
+      </p:sp>
+      <p:sp>
+        <p:nvSpPr>
+          <p:cNvPr id="13" name="Text 11"/>
+          <p:cNvSpPr txBox="1"/>
+          <p:nvPr/>
+        </p:nvSpPr>
+        <p:spPr>
+          <a:xfrm>
+            <a:off x="3619424" y="2743200"/>
             <a:ext cx="2083232" cy="457200"/>
           </a:xfrm>
           <a:prstGeom prst="rect">
@@ -9257,7 +9389,7 @@
           <a:bodyPr wrap="square" lIns="0" tIns="0" rIns="0" bIns="0" rtlCol="0" anchor="t"/>
           <a:lstStyle/>
           <a:p>
-            <a:pPr indent="0" marL="0">
+            <a:pPr algn="ctr" indent="0" marL="0">
               <a:buNone/>
             </a:pPr>
             <a:r>
@@ -9269,7 +9401,7 @@
                 <a:ea typeface="Arial" pitchFamily="34" charset="-122"/>
                 <a:cs typeface="Arial" pitchFamily="34" charset="-120"/>
               </a:rPr>
-              <a:t>Recalcular</a:t>
+              <a:t>Recalcula</a:t>
             </a:r>
             <a:endParaRPr lang="en-US" sz="1600" dirty="0"/>
           </a:p>
@@ -9277,14 +9409,14 @@
       </p:sp>
       <p:sp>
         <p:nvSpPr>
-          <p:cNvPr id="13" name="Text 11"/>
-          <p:cNvSpPr txBox="1"/>
-          <p:nvPr/>
-        </p:nvSpPr>
-        <p:spPr>
-          <a:xfrm>
-            <a:off x="3637712" y="3273552"/>
-            <a:ext cx="2083232" cy="1232408"/>
+          <p:cNvPr id="14" name="Text 12"/>
+          <p:cNvSpPr txBox="1"/>
+          <p:nvPr/>
+        </p:nvSpPr>
+        <p:spPr>
+          <a:xfrm>
+            <a:off x="3656000" y="3273552"/>
+            <a:ext cx="2010080" cy="2304288"/>
           </a:xfrm>
           <a:prstGeom prst="rect">
             <a:avLst/>
@@ -9298,12 +9430,12 @@
           <a:p>
             <a:pPr indent="0" marL="0">
               <a:lnSpc>
-                <a:spcPct val="110000"/>
+                <a:spcPct val="112000"/>
               </a:lnSpc>
               <a:buNone/>
             </a:pPr>
             <a:r>
-              <a:rPr lang="en-US" sz="1300" dirty="0">
+              <a:rPr lang="en-US" sz="1250" dirty="0">
                 <a:solidFill>
                   <a:srgbClr val="16262E"/>
                 </a:solidFill>
@@ -9311,26 +9443,80 @@
                 <a:ea typeface="Calibri" pitchFamily="34" charset="-122"/>
                 <a:cs typeface="Calibri" pitchFamily="34" charset="-120"/>
               </a:rPr>
-              <a:t>Toda cifra se comprueba a mano o en Excel. Revisen sobre todo que los porcentajes sumen y que los totales cuadren con sus partes.</a:t>
-            </a:r>
-            <a:endParaRPr lang="en-US" sz="1300" dirty="0"/>
-          </a:p>
-        </p:txBody>
-      </p:sp>
-      <p:sp>
-        <p:nvSpPr>
-          <p:cNvPr id="14" name="Shape 12"/>
+              <a:t>Comprueba toda cifra a mano o en Excel.</a:t>
+            </a:r>
+            <a:endParaRPr lang="en-US" sz="1250" dirty="0"/>
+          </a:p>
+          <a:p>
+            <a:pPr indent="0" marL="0">
+              <a:lnSpc>
+                <a:spcPct val="112000"/>
+              </a:lnSpc>
+              <a:buNone/>
+            </a:pPr>
+            <a:endParaRPr lang="en-US" sz="1250" dirty="0"/>
+          </a:p>
+          <a:p>
+            <a:pPr indent="0" marL="0">
+              <a:lnSpc>
+                <a:spcPct val="112000"/>
+              </a:lnSpc>
+              <a:buNone/>
+            </a:pPr>
+            <a:r>
+              <a:rPr lang="en-US" sz="1250" dirty="0">
+                <a:solidFill>
+                  <a:srgbClr val="16262E"/>
+                </a:solidFill>
+                <a:latin typeface="Calibri" pitchFamily="34" charset="0"/>
+                <a:ea typeface="Calibri" pitchFamily="34" charset="-122"/>
+                <a:cs typeface="Calibri" pitchFamily="34" charset="-120"/>
+              </a:rPr>
+              <a:t>Revisa sobre todo que los porcentajes sumen y que los totales cuadren con sus partes.</a:t>
+            </a:r>
+            <a:endParaRPr lang="en-US" sz="1250" dirty="0"/>
+          </a:p>
+        </p:txBody>
+      </p:sp>
+      <p:sp>
+        <p:nvSpPr>
+          <p:cNvPr id="15" name="Shape 13"/>
           <p:cNvSpPr/>
           <p:nvPr/>
         </p:nvSpPr>
         <p:spPr>
           <a:xfrm>
-            <a:off x="6233008" y="2011680"/>
-            <a:ext cx="2558720" cy="2732024"/>
+            <a:off x="5958688" y="2194560"/>
+            <a:ext cx="274320" cy="310896"/>
+          </a:xfrm>
+          <a:prstGeom prst="rightArrow">
+            <a:avLst/>
+          </a:prstGeom>
+          <a:solidFill>
+            <a:srgbClr val="5A6B73"/>
+          </a:solidFill>
+          <a:ln w="12700">
+            <a:solidFill>
+              <a:srgbClr val="5A6B73"/>
+            </a:solidFill>
+            <a:prstDash val="solid"/>
+          </a:ln>
+        </p:spPr>
+      </p:sp>
+      <p:sp>
+        <p:nvSpPr>
+          <p:cNvPr id="16" name="Shape 14"/>
+          <p:cNvSpPr/>
+          <p:nvPr/>
+        </p:nvSpPr>
+        <p:spPr>
+          <a:xfrm>
+            <a:off x="6306160" y="1810512"/>
+            <a:ext cx="2448992" cy="3950208"/>
           </a:xfrm>
           <a:prstGeom prst="roundRect">
             <a:avLst>
-              <a:gd name="adj" fmla="val 2859"/>
+              <a:gd name="adj" fmla="val 3360"/>
             </a:avLst>
           </a:prstGeom>
           <a:solidFill>
@@ -9346,14 +9532,14 @@
       </p:sp>
       <p:sp>
         <p:nvSpPr>
-          <p:cNvPr id="15" name="Shape 13"/>
+          <p:cNvPr id="17" name="Shape 15"/>
           <p:cNvSpPr/>
           <p:nvPr/>
         </p:nvSpPr>
         <p:spPr>
           <a:xfrm>
-            <a:off x="6470752" y="2231136"/>
-            <a:ext cx="420624" cy="420624"/>
+            <a:off x="7247191" y="2066544"/>
+            <a:ext cx="566928" cy="566928"/>
           </a:xfrm>
           <a:prstGeom prst="ellipse">
             <a:avLst/>
@@ -9371,14 +9557,14 @@
       </p:sp>
       <p:sp>
         <p:nvSpPr>
-          <p:cNvPr id="16" name="Text 14"/>
-          <p:cNvSpPr txBox="1"/>
-          <p:nvPr/>
-        </p:nvSpPr>
-        <p:spPr>
-          <a:xfrm>
-            <a:off x="6470752" y="2231136"/>
-            <a:ext cx="420624" cy="420624"/>
+          <p:cNvPr id="18" name="Text 16"/>
+          <p:cNvSpPr txBox="1"/>
+          <p:nvPr/>
+        </p:nvSpPr>
+        <p:spPr>
+          <a:xfrm>
+            <a:off x="7247191" y="2066544"/>
+            <a:ext cx="566928" cy="566928"/>
           </a:xfrm>
           <a:prstGeom prst="rect">
             <a:avLst/>
@@ -9394,7 +9580,7 @@
               <a:buNone/>
             </a:pPr>
             <a:r>
-              <a:rPr lang="en-US" sz="1400" b="1" dirty="0">
+              <a:rPr lang="en-US" sz="2000" b="1" dirty="0">
                 <a:solidFill>
                   <a:srgbClr val="FFFFFF"/>
                 </a:solidFill>
@@ -9404,19 +9590,19 @@
               </a:rPr>
               <a:t>3</a:t>
             </a:r>
-            <a:endParaRPr lang="en-US" sz="1400" dirty="0"/>
-          </a:p>
-        </p:txBody>
-      </p:sp>
-      <p:sp>
-        <p:nvSpPr>
-          <p:cNvPr id="17" name="Text 15"/>
-          <p:cNvSpPr txBox="1"/>
-          <p:nvPr/>
-        </p:nvSpPr>
-        <p:spPr>
-          <a:xfrm>
-            <a:off x="6470752" y="2798064"/>
+            <a:endParaRPr lang="en-US" sz="2000" dirty="0"/>
+          </a:p>
+        </p:txBody>
+      </p:sp>
+      <p:sp>
+        <p:nvSpPr>
+          <p:cNvPr id="19" name="Text 17"/>
+          <p:cNvSpPr txBox="1"/>
+          <p:nvPr/>
+        </p:nvSpPr>
+        <p:spPr>
+          <a:xfrm>
+            <a:off x="6489040" y="2743200"/>
             <a:ext cx="2083232" cy="457200"/>
           </a:xfrm>
           <a:prstGeom prst="rect">
@@ -9429,7 +9615,7 @@
           <a:bodyPr wrap="square" lIns="0" tIns="0" rIns="0" bIns="0" rtlCol="0" anchor="t"/>
           <a:lstStyle/>
           <a:p>
-            <a:pPr indent="0" marL="0">
+            <a:pPr algn="ctr" indent="0" marL="0">
               <a:buNone/>
             </a:pPr>
             <a:r>
@@ -9441,7 +9627,7 @@
                 <a:ea typeface="Arial" pitchFamily="34" charset="-122"/>
                 <a:cs typeface="Arial" pitchFamily="34" charset="-120"/>
               </a:rPr>
-              <a:t>Contrapreguntar</a:t>
+              <a:t>Contrapregunta</a:t>
             </a:r>
             <a:endParaRPr lang="en-US" sz="1600" dirty="0"/>
           </a:p>
@@ -9449,14 +9635,14 @@
       </p:sp>
       <p:sp>
         <p:nvSpPr>
-          <p:cNvPr id="18" name="Text 16"/>
-          <p:cNvSpPr txBox="1"/>
-          <p:nvPr/>
-        </p:nvSpPr>
-        <p:spPr>
-          <a:xfrm>
-            <a:off x="6470752" y="3273552"/>
-            <a:ext cx="2083232" cy="1232408"/>
+          <p:cNvPr id="20" name="Text 18"/>
+          <p:cNvSpPr txBox="1"/>
+          <p:nvPr/>
+        </p:nvSpPr>
+        <p:spPr>
+          <a:xfrm>
+            <a:off x="6525616" y="3273552"/>
+            <a:ext cx="2010080" cy="2304288"/>
           </a:xfrm>
           <a:prstGeom prst="rect">
             <a:avLst/>
@@ -9470,12 +9656,12 @@
           <a:p>
             <a:pPr indent="0" marL="0">
               <a:lnSpc>
-                <a:spcPct val="110000"/>
+                <a:spcPct val="112000"/>
               </a:lnSpc>
               <a:buNone/>
             </a:pPr>
             <a:r>
-              <a:rPr lang="en-US" sz="1300" dirty="0">
+              <a:rPr lang="en-US" sz="1250" dirty="0">
                 <a:solidFill>
                   <a:srgbClr val="16262E"/>
                 </a:solidFill>
@@ -9483,34 +9669,61 @@
                 <a:ea typeface="Calibri" pitchFamily="34" charset="-122"/>
                 <a:cs typeface="Calibri" pitchFamily="34" charset="-120"/>
               </a:rPr>
-              <a:t>Regrésele la pregunta al modelo pidiéndole que señale qué parte del documento sostiene cada afirmación.</a:t>
-            </a:r>
-            <a:endParaRPr lang="en-US" sz="1300" dirty="0"/>
-          </a:p>
-        </p:txBody>
-      </p:sp>
-      <p:sp>
-        <p:nvSpPr>
-          <p:cNvPr id="19" name="Shape 17"/>
+              <a:t>Regrésale la pregunta al modelo: que señale qué parte del documento sostiene cada afirmación.</a:t>
+            </a:r>
+            <a:endParaRPr lang="en-US" sz="1250" dirty="0"/>
+          </a:p>
+          <a:p>
+            <a:pPr indent="0" marL="0">
+              <a:lnSpc>
+                <a:spcPct val="112000"/>
+              </a:lnSpc>
+              <a:buNone/>
+            </a:pPr>
+            <a:endParaRPr lang="en-US" sz="1250" dirty="0"/>
+          </a:p>
+          <a:p>
+            <a:pPr indent="0" marL="0">
+              <a:lnSpc>
+                <a:spcPct val="112000"/>
+              </a:lnSpc>
+              <a:buNone/>
+            </a:pPr>
+            <a:r>
+              <a:rPr lang="en-US" sz="1250" dirty="0">
+                <a:solidFill>
+                  <a:srgbClr val="16262E"/>
+                </a:solidFill>
+                <a:latin typeface="Calibri" pitchFamily="34" charset="0"/>
+                <a:ea typeface="Calibri" pitchFamily="34" charset="-122"/>
+                <a:cs typeface="Calibri" pitchFamily="34" charset="-120"/>
+              </a:rPr>
+              <a:t>Cuando no puede señalarla, casi siempre es porque la inventó.</a:t>
+            </a:r>
+            <a:endParaRPr lang="en-US" sz="1250" dirty="0"/>
+          </a:p>
+        </p:txBody>
+      </p:sp>
+      <p:sp>
+        <p:nvSpPr>
+          <p:cNvPr id="21" name="Shape 19"/>
           <p:cNvSpPr/>
           <p:nvPr/>
         </p:nvSpPr>
         <p:spPr>
           <a:xfrm>
-            <a:off x="9066047" y="2011680"/>
-            <a:ext cx="2558720" cy="2732024"/>
-          </a:xfrm>
-          <a:prstGeom prst="roundRect">
-            <a:avLst>
-              <a:gd name="adj" fmla="val 2859"/>
-            </a:avLst>
+            <a:off x="8828303" y="2194560"/>
+            <a:ext cx="274320" cy="310896"/>
+          </a:xfrm>
+          <a:prstGeom prst="rightArrow">
+            <a:avLst/>
           </a:prstGeom>
           <a:solidFill>
-            <a:srgbClr val="D7E7E7"/>
+            <a:srgbClr val="5A6B73"/>
           </a:solidFill>
           <a:ln w="12700">
             <a:solidFill>
-              <a:srgbClr val="D7E7E7"/>
+              <a:srgbClr val="5A6B73"/>
             </a:solidFill>
             <a:prstDash val="solid"/>
           </a:ln>
@@ -9518,24 +9731,26 @@
       </p:sp>
       <p:sp>
         <p:nvSpPr>
-          <p:cNvPr id="20" name="Shape 18"/>
+          <p:cNvPr id="22" name="Shape 20"/>
           <p:cNvSpPr/>
           <p:nvPr/>
         </p:nvSpPr>
         <p:spPr>
           <a:xfrm>
-            <a:off x="9303791" y="2231136"/>
-            <a:ext cx="420624" cy="420624"/>
-          </a:xfrm>
-          <a:prstGeom prst="ellipse">
-            <a:avLst/>
+            <a:off x="9175775" y="1810512"/>
+            <a:ext cx="2448992" cy="3950208"/>
+          </a:xfrm>
+          <a:prstGeom prst="roundRect">
+            <a:avLst>
+              <a:gd name="adj" fmla="val 3360"/>
+            </a:avLst>
           </a:prstGeom>
           <a:solidFill>
-            <a:srgbClr val="2E7D7D"/>
+            <a:srgbClr val="F7E4D8"/>
           </a:solidFill>
           <a:ln w="12700">
             <a:solidFill>
-              <a:srgbClr val="2E7D7D"/>
+              <a:srgbClr val="F7E4D8"/>
             </a:solidFill>
             <a:prstDash val="solid"/>
           </a:ln>
@@ -9543,14 +9758,39 @@
       </p:sp>
       <p:sp>
         <p:nvSpPr>
-          <p:cNvPr id="21" name="Text 19"/>
-          <p:cNvSpPr txBox="1"/>
-          <p:nvPr/>
-        </p:nvSpPr>
-        <p:spPr>
-          <a:xfrm>
-            <a:off x="9303791" y="2231136"/>
-            <a:ext cx="420624" cy="420624"/>
+          <p:cNvPr id="23" name="Shape 21"/>
+          <p:cNvSpPr/>
+          <p:nvPr/>
+        </p:nvSpPr>
+        <p:spPr>
+          <a:xfrm>
+            <a:off x="10116807" y="2066544"/>
+            <a:ext cx="566928" cy="566928"/>
+          </a:xfrm>
+          <a:prstGeom prst="ellipse">
+            <a:avLst/>
+          </a:prstGeom>
+          <a:solidFill>
+            <a:srgbClr val="C85A28"/>
+          </a:solidFill>
+          <a:ln w="12700">
+            <a:solidFill>
+              <a:srgbClr val="C85A28"/>
+            </a:solidFill>
+            <a:prstDash val="solid"/>
+          </a:ln>
+        </p:spPr>
+      </p:sp>
+      <p:sp>
+        <p:nvSpPr>
+          <p:cNvPr id="24" name="Text 22"/>
+          <p:cNvSpPr txBox="1"/>
+          <p:nvPr/>
+        </p:nvSpPr>
+        <p:spPr>
+          <a:xfrm>
+            <a:off x="10116807" y="2066544"/>
+            <a:ext cx="566928" cy="566928"/>
           </a:xfrm>
           <a:prstGeom prst="rect">
             <a:avLst/>
@@ -9566,7 +9806,7 @@
               <a:buNone/>
             </a:pPr>
             <a:r>
-              <a:rPr lang="en-US" sz="1400" b="1" dirty="0">
+              <a:rPr lang="en-US" sz="2000" b="1" dirty="0">
                 <a:solidFill>
                   <a:srgbClr val="FFFFFF"/>
                 </a:solidFill>
@@ -9576,19 +9816,19 @@
               </a:rPr>
               <a:t>4</a:t>
             </a:r>
-            <a:endParaRPr lang="en-US" sz="1400" dirty="0"/>
-          </a:p>
-        </p:txBody>
-      </p:sp>
-      <p:sp>
-        <p:nvSpPr>
-          <p:cNvPr id="22" name="Text 20"/>
-          <p:cNvSpPr txBox="1"/>
-          <p:nvPr/>
-        </p:nvSpPr>
-        <p:spPr>
-          <a:xfrm>
-            <a:off x="9303791" y="2798064"/>
+            <a:endParaRPr lang="en-US" sz="2000" dirty="0"/>
+          </a:p>
+        </p:txBody>
+      </p:sp>
+      <p:sp>
+        <p:nvSpPr>
+          <p:cNvPr id="25" name="Text 23"/>
+          <p:cNvSpPr txBox="1"/>
+          <p:nvPr/>
+        </p:nvSpPr>
+        <p:spPr>
+          <a:xfrm>
+            <a:off x="9358655" y="2743200"/>
             <a:ext cx="2083232" cy="457200"/>
           </a:xfrm>
           <a:prstGeom prst="rect">
@@ -9601,7 +9841,7 @@
           <a:bodyPr wrap="square" lIns="0" tIns="0" rIns="0" bIns="0" rtlCol="0" anchor="t"/>
           <a:lstStyle/>
           <a:p>
-            <a:pPr indent="0" marL="0">
+            <a:pPr algn="ctr" indent="0" marL="0">
               <a:buNone/>
             </a:pPr>
             <a:r>
@@ -9613,7 +9853,7 @@
                 <a:ea typeface="Arial" pitchFamily="34" charset="-122"/>
                 <a:cs typeface="Arial" pitchFamily="34" charset="-120"/>
               </a:rPr>
-              <a:t>Triangular</a:t>
+              <a:t>Triangula</a:t>
             </a:r>
             <a:endParaRPr lang="en-US" sz="1600" dirty="0"/>
           </a:p>
@@ -9621,14 +9861,14 @@
       </p:sp>
       <p:sp>
         <p:nvSpPr>
-          <p:cNvPr id="23" name="Text 21"/>
-          <p:cNvSpPr txBox="1"/>
-          <p:nvPr/>
-        </p:nvSpPr>
-        <p:spPr>
-          <a:xfrm>
-            <a:off x="9303791" y="3273552"/>
-            <a:ext cx="2083232" cy="1232408"/>
+          <p:cNvPr id="26" name="Text 24"/>
+          <p:cNvSpPr txBox="1"/>
+          <p:nvPr/>
+        </p:nvSpPr>
+        <p:spPr>
+          <a:xfrm>
+            <a:off x="9395231" y="3273552"/>
+            <a:ext cx="2010080" cy="2304288"/>
           </a:xfrm>
           <a:prstGeom prst="rect">
             <a:avLst/>
@@ -9642,12 +9882,12 @@
           <a:p>
             <a:pPr indent="0" marL="0">
               <a:lnSpc>
-                <a:spcPct val="110000"/>
+                <a:spcPct val="112000"/>
               </a:lnSpc>
               <a:buNone/>
             </a:pPr>
             <a:r>
-              <a:rPr lang="en-US" sz="1300" dirty="0">
+              <a:rPr lang="en-US" sz="1250" dirty="0">
                 <a:solidFill>
                   <a:srgbClr val="16262E"/>
                 </a:solidFill>
@@ -9655,7 +9895,102 @@
                 <a:ea typeface="Calibri" pitchFamily="34" charset="-122"/>
                 <a:cs typeface="Calibri" pitchFamily="34" charset="-120"/>
               </a:rPr>
-              <a:t>Haga la misma pregunta en dos herramientas más. Tenemos ChatGPT, Claude y Gemini. Cuando las tres coinciden la confianza sube. Cuando discrepan, esa discrepancia es la señal de ir a la fuente.</a:t>
+              <a:t>Haz la misma pregunta en dos herramientas más. Tienes ChatGPT, Claude y Gemini.</a:t>
+            </a:r>
+            <a:endParaRPr lang="en-US" sz="1250" dirty="0"/>
+          </a:p>
+          <a:p>
+            <a:pPr indent="0" marL="0">
+              <a:lnSpc>
+                <a:spcPct val="112000"/>
+              </a:lnSpc>
+              <a:buNone/>
+            </a:pPr>
+            <a:endParaRPr lang="en-US" sz="1250" dirty="0"/>
+          </a:p>
+          <a:p>
+            <a:pPr indent="0" marL="0">
+              <a:lnSpc>
+                <a:spcPct val="112000"/>
+              </a:lnSpc>
+              <a:buNone/>
+            </a:pPr>
+            <a:r>
+              <a:rPr lang="en-US" sz="1250" dirty="0">
+                <a:solidFill>
+                  <a:srgbClr val="16262E"/>
+                </a:solidFill>
+                <a:latin typeface="Calibri" pitchFamily="34" charset="0"/>
+                <a:ea typeface="Calibri" pitchFamily="34" charset="-122"/>
+                <a:cs typeface="Calibri" pitchFamily="34" charset="-120"/>
+              </a:rPr>
+              <a:t>Si las tres coinciden, tu confianza sube. Si discrepan, esa discrepancia te dice dónde ir a la fuente.</a:t>
+            </a:r>
+            <a:endParaRPr lang="en-US" sz="1250" dirty="0"/>
+          </a:p>
+        </p:txBody>
+      </p:sp>
+      <p:sp>
+        <p:nvSpPr>
+          <p:cNvPr id="27" name="Shape 25"/>
+          <p:cNvSpPr/>
+          <p:nvPr/>
+        </p:nvSpPr>
+        <p:spPr>
+          <a:xfrm>
+            <a:off x="566928" y="5870448"/>
+            <a:ext cx="11057839" cy="493776"/>
+          </a:xfrm>
+          <a:prstGeom prst="roundRect">
+            <a:avLst>
+              <a:gd name="adj" fmla="val 11111"/>
+            </a:avLst>
+          </a:prstGeom>
+          <a:solidFill>
+            <a:srgbClr val="F7E4D8"/>
+          </a:solidFill>
+          <a:ln w="12700">
+            <a:solidFill>
+              <a:srgbClr val="F7E4D8"/>
+            </a:solidFill>
+            <a:prstDash val="solid"/>
+          </a:ln>
+        </p:spPr>
+      </p:sp>
+      <p:sp>
+        <p:nvSpPr>
+          <p:cNvPr id="28" name="Text 26"/>
+          <p:cNvSpPr txBox="1"/>
+          <p:nvPr/>
+        </p:nvSpPr>
+        <p:spPr>
+          <a:xfrm>
+            <a:off x="804672" y="5870448"/>
+            <a:ext cx="10582351" cy="493776"/>
+          </a:xfrm>
+          <a:prstGeom prst="rect">
+            <a:avLst/>
+          </a:prstGeom>
+          <a:noFill/>
+          <a:ln/>
+        </p:spPr>
+        <p:txBody>
+          <a:bodyPr wrap="square" lIns="0" tIns="0" rIns="0" bIns="0" rtlCol="0" anchor="ctr"/>
+          <a:lstStyle/>
+          <a:p>
+            <a:pPr indent="0" marL="0">
+              <a:buNone/>
+            </a:pPr>
+            <a:r>
+              <a:rPr lang="en-US" sz="1300" b="1" dirty="0">
+                <a:solidFill>
+                  <a:srgbClr val="16262E"/>
+                </a:solidFill>
+                <a:latin typeface="Calibri" pitchFamily="34" charset="0"/>
+                <a:ea typeface="Calibri" pitchFamily="34" charset="-122"/>
+                <a:cs typeface="Calibri" pitchFamily="34" charset="-120"/>
+              </a:rPr>
+              <a:t>El paso 4 solo funciona con información verde. El informe de hoy lo es. En tu trabajo real, no puedes triangular un borrador interno.</a:t>
             </a:r>
             <a:endParaRPr lang="en-US" sz="1300" dirty="0"/>
           </a:p>
@@ -9827,7 +10162,7 @@
                 <a:ea typeface="Courier New" pitchFamily="34" charset="-122"/>
                 <a:cs typeface="Courier New" pitchFamily="34" charset="-120"/>
               </a:rPr>
-              <a:t>Para cada una de las afirmaciones que acabas de hacer, indica la sección exacta del</a:t>
+              <a:t>Para cada una de las afirmaciones que acabas de hacer, indica la sección exacta</a:t>
             </a:r>
             <a:endParaRPr lang="en-US" sz="1300" dirty="0"/>
           </a:p>
@@ -9847,7 +10182,7 @@
                 <a:ea typeface="Courier New" pitchFamily="34" charset="-122"/>
                 <a:cs typeface="Courier New" pitchFamily="34" charset="-120"/>
               </a:rPr>
-              <a:t>documento que la sostiene y transcribe la frase textual correspondiente.</a:t>
+              <a:t>del documento que la sostiene y transcribe la frase textual correspondiente.</a:t>
             </a:r>
             <a:endParaRPr lang="en-US" sz="1300" dirty="0"/>
           </a:p>

</xml_diff>

<commit_message>
Sesión 3: calentamiento de anclaje, mapa corregido de Copilot y equipos
- En el INEGI no hay Copilot dentro de Word, Excel, Outlook ni Teams; el
  curso migra a Copilot Chat con archivos de OneDrive (comprobado en vivo).
  Lámina de referencia nueva y corrección en los handouts 2 y 3.
- La práctica de anclaje documental pendiente de la sesión 2 abre la
  sesión 3 como calentamiento de 18 minutos, con notas de ponente.
- Los equipos se forman en el receso del jueves; entregables pendientes
  reprogramados: biblioteca de prompts al viernes, hilo y transcripción
  como práctica en casa.

Co-Authored-By: Claude Fable 5 <noreply@anthropic.com>
</commit_message>
<xml_diff>
--- a/sesion-03/Sesion_03_Validacion_Critica.pptx
+++ b/sesion-03/Sesion_03_Validacion_Critica.pptx
@@ -7,6 +7,8 @@
   <p:sldIdLst>
     <p:sldId id="256" r:id="rId2"/>
     <p:sldId id="257" r:id="rId3"/>
+    <p:sldId id="271" r:id="rId22"/>
+    <p:sldId id="272" r:id="rId23"/>
     <p:sldId id="258" r:id="rId4"/>
     <p:sldId id="259" r:id="rId5"/>
     <p:sldId id="260" r:id="rId6"/>
@@ -14,6 +16,7 @@
     <p:sldId id="262" r:id="rId8"/>
     <p:sldId id="263" r:id="rId9"/>
     <p:sldId id="264" r:id="rId10"/>
+    <p:sldId id="273" r:id="rId24"/>
     <p:sldId id="265" r:id="rId11"/>
     <p:sldId id="266" r:id="rId12"/>
     <p:sldId id="267" r:id="rId13"/>
@@ -516,7 +519,7 @@
           <a:p>
             <a:r>
               <a:rPr lang="en-US" dirty="0"/>
-              <a:t>Ten listos: los seis equipos anunciados desde el martes, las salas de trabajo probadas, el informe sintético distribuido, y la clave abierta en tu segunda pantalla.</a:t>
+              <a:t>Ten listos: las salas de trabajo probadas, el informe sintético distribuido, la clave abierta en tu segunda pantalla, y un documento normativo limpio de respaldo para el calentamiento. Los equipos se forman en el receso: reparte a quienes han usado IA para programar, uno por equipo.</a:t>
             </a:r>
             <a:endParaRPr lang="en-US" dirty="0"/>
           </a:p>
@@ -1079,6 +1082,194 @@
         <p14:creationId xmlns:p14="http://schemas.microsoft.com/office/powerpoint/2010/main" val="1024086991"/>
       </p:ext>
     </p:extLst>
+  </p:cSld>
+  <p:clrMapOvr>
+    <a:masterClrMapping/>
+  </p:clrMapOvr>
+</p:notes>
+</file>
+
+<file path=ppt/notesSlides/notesSlide16.xml><?xml version="1.0" encoding="utf-8"?>
+<p:notes xmlns:a="http://schemas.openxmlformats.org/drawingml/2006/main" xmlns:r="http://schemas.openxmlformats.org/officeDocument/2006/relationships" xmlns:p="http://schemas.openxmlformats.org/presentationml/2006/main">
+  <p:cSld>
+    <p:spTree>
+      <p:nvGrpSpPr>
+        <p:cNvPr id="1" name=""/>
+        <p:cNvGrpSpPr/>
+        <p:nvPr/>
+      </p:nvGrpSpPr>
+      <p:grpSpPr>
+        <a:xfrm>
+          <a:off x="0" y="0"/>
+          <a:ext cx="0" cy="0"/>
+          <a:chOff x="0" y="0"/>
+          <a:chExt cx="0" cy="0"/>
+        </a:xfrm>
+      </p:grpSpPr>
+      <p:sp>
+        <p:nvSpPr>
+          <p:cNvPr id="2" name="Slide Image Placeholder 1"/>
+          <p:cNvSpPr>
+            <a:spLocks noGrp="1" noRot="1" noChangeAspect="1"/>
+          </p:cNvSpPr>
+          <p:nvPr>
+            <p:ph type="sldImg"/>
+          </p:nvPr>
+        </p:nvSpPr>
+        <p:spPr/>
+      </p:sp>
+      <p:sp>
+        <p:nvSpPr>
+          <p:cNvPr id="3" name="Notes Placeholder 2"/>
+          <p:cNvSpPr>
+            <a:spLocks noGrp="1"/>
+          </p:cNvSpPr>
+          <p:nvPr>
+            <p:ph type="body" idx="1"/>
+          </p:nvPr>
+        </p:nvSpPr>
+        <p:spPr/>
+        <p:txBody>
+          <a:bodyPr/>
+          <a:lstStyle/>
+          <a:p>
+            <a:r>
+              <a:rPr lang="en-US" dirty="0"/>
+              <a:t>Demuestra el primer minuto en pantalla: adjuntar el archivo, pegar el prompt, aparece la tabla. Después suéltalos.</a:t>
+            </a:r>
+          </a:p>
+          <a:p>
+            <a:r>
+              <a:rPr lang="en-US" dirty="0"/>
+              <a:t>A quien saque tres de tres, pídele que verifique otras tres.</a:t>
+            </a:r>
+          </a:p>
+          <a:p>
+            <a:r>
+              <a:rPr lang="en-US" dirty="0"/>
+              <a:t>Ten un documento limpio de respaldo para quien traiga un PDF escaneado que Copilot no pueda leer.</a:t>
+            </a:r>
+          </a:p>
+          <a:p>
+            <a:r>
+              <a:rPr lang="en-US" dirty="0"/>
+              <a:t>El cierre es el argumento de toda la sesión: pregunta en voz alta cuántos encontraron al menos un error y cuenta las manos. Ese número justifica los seis errores, el protocolo y el laboratorio.</a:t>
+            </a:r>
+          </a:p>
+        </p:txBody>
+      </p:sp>
+      <p:sp>
+        <p:nvSpPr>
+          <p:cNvPr id="4" name="Slide Number Placeholder 3"/>
+          <p:cNvSpPr>
+            <a:spLocks noGrp="1"/>
+          </p:cNvSpPr>
+          <p:nvPr>
+            <p:ph type="sldNum" sz="quarter" idx="10"/>
+          </p:nvPr>
+        </p:nvSpPr>
+        <p:spPr/>
+        <p:txBody>
+          <a:bodyPr/>
+          <a:lstStyle/>
+          <a:p>
+            <a:fld id="{D8735456-4A55-4D3E-9F52-D9D46D1F5B3C}" type="slidenum">
+              <a:rPr lang="en-US"/>
+              <a:t>4</a:t>
+            </a:fld>
+            <a:endParaRPr lang="en-US"/>
+          </a:p>
+        </p:txBody>
+      </p:sp>
+    </p:spTree>
+  </p:cSld>
+  <p:clrMapOvr>
+    <a:masterClrMapping/>
+  </p:clrMapOvr>
+</p:notes>
+</file>
+
+<file path=ppt/notesSlides/notesSlide17.xml><?xml version="1.0" encoding="utf-8"?>
+<p:notes xmlns:a="http://schemas.openxmlformats.org/drawingml/2006/main" xmlns:r="http://schemas.openxmlformats.org/officeDocument/2006/relationships" xmlns:p="http://schemas.openxmlformats.org/presentationml/2006/main">
+  <p:cSld>
+    <p:spTree>
+      <p:nvGrpSpPr>
+        <p:cNvPr id="1" name=""/>
+        <p:cNvGrpSpPr/>
+        <p:nvPr/>
+      </p:nvGrpSpPr>
+      <p:grpSpPr>
+        <a:xfrm>
+          <a:off x="0" y="0"/>
+          <a:ext cx="0" cy="0"/>
+          <a:chOff x="0" y="0"/>
+          <a:chExt cx="0" cy="0"/>
+        </a:xfrm>
+      </p:grpSpPr>
+      <p:sp>
+        <p:nvSpPr>
+          <p:cNvPr id="2" name="Slide Image Placeholder 1"/>
+          <p:cNvSpPr>
+            <a:spLocks noGrp="1" noRot="1" noChangeAspect="1"/>
+          </p:cNvSpPr>
+          <p:nvPr>
+            <p:ph type="sldImg"/>
+          </p:nvPr>
+        </p:nvSpPr>
+        <p:spPr/>
+      </p:sp>
+      <p:sp>
+        <p:nvSpPr>
+          <p:cNvPr id="3" name="Notes Placeholder 2"/>
+          <p:cNvSpPr>
+            <a:spLocks noGrp="1"/>
+          </p:cNvSpPr>
+          <p:nvPr>
+            <p:ph type="body" idx="1"/>
+          </p:nvPr>
+        </p:nvSpPr>
+        <p:spPr/>
+        <p:txBody>
+          <a:bodyPr/>
+          <a:lstStyle/>
+          <a:p>
+            <a:r>
+              <a:rPr lang="en-US" dirty="0"/>
+              <a:t>Mecánica de dos minutos: mano alzada de quienes han usado IA para programar y se reparten uno por equipo; el resto se acomoda libre.</a:t>
+            </a:r>
+          </a:p>
+          <a:p>
+            <a:r>
+              <a:rPr lang="en-US" dirty="0"/>
+              <a:t>Anuncia las salas de trabajo de cada equipo antes de soltar al receso.</a:t>
+            </a:r>
+          </a:p>
+        </p:txBody>
+      </p:sp>
+      <p:sp>
+        <p:nvSpPr>
+          <p:cNvPr id="4" name="Slide Number Placeholder 3"/>
+          <p:cNvSpPr>
+            <a:spLocks noGrp="1"/>
+          </p:cNvSpPr>
+          <p:nvPr>
+            <p:ph type="sldNum" sz="quarter" idx="10"/>
+          </p:nvPr>
+        </p:nvSpPr>
+        <p:spPr/>
+        <p:txBody>
+          <a:bodyPr/>
+          <a:lstStyle/>
+          <a:p>
+            <a:fld id="{D8735456-4A55-4D3E-9F52-D9D46D1F5B3C}" type="slidenum">
+              <a:rPr lang="en-US"/>
+              <a:t>12</a:t>
+            </a:fld>
+            <a:endParaRPr lang="en-US"/>
+          </a:p>
+        </p:txBody>
+      </p:sp>
+    </p:spTree>
   </p:cSld>
   <p:clrMapOvr>
     <a:masterClrMapping/>
@@ -3566,7 +3757,7 @@
                 <a:ea typeface="Arial" pitchFamily="34" charset="-122"/>
                 <a:cs typeface="Arial" pitchFamily="34" charset="-120"/>
               </a:rPr>
-              <a:t>Si le pides a Copilot que encuentre los errores, el modelo va a encontrar algunos, va a inventar otros, y va a pasar por alto casi todos los de omisión.</a:t>
+              <a:t>Si le pides a Copilot Chat, o a cualquiera de las gratuitas, que encuentre los errores, el modelo va a encontrar algunos, va a inventar otros, y va a pasar por alto casi todos los de omisión.</a:t>
             </a:r>
             <a:endParaRPr lang="en-US" sz="3000" dirty="0"/>
           </a:p>
@@ -5417,7 +5608,7 @@
     </p:bg>
     <p:spTree>
       <p:nvGrpSpPr>
-        <p:cNvPr id="1" name=""/>
+        <p:cNvPr id="2" name=""/>
         <p:cNvGrpSpPr/>
         <p:nvPr/>
       </p:nvGrpSpPr>
@@ -5431,17 +5622,97 @@
       </p:grpSpPr>
       <p:sp>
         <p:nvSpPr>
-          <p:cNvPr id="2" name="Shape 0"/>
+          <p:cNvPr id="3" name="Text 1"/>
+          <p:cNvSpPr txBox="1"/>
+          <p:nvPr/>
+        </p:nvSpPr>
+        <p:spPr>
+          <a:xfrm>
+            <a:off x="566928" y="685800"/>
+            <a:ext cx="10424160" cy="365760"/>
+          </a:xfrm>
+          <a:prstGeom prst="rect">
+            <a:avLst/>
+          </a:prstGeom>
+          <a:noFill/>
+          <a:ln/>
+        </p:spPr>
+        <p:txBody>
+          <a:bodyPr wrap="square" lIns="0" tIns="0" rIns="0" bIns="0" rtlCol="0" anchor="ctr"/>
+          <a:lstStyle/>
+          <a:p>
+            <a:pPr indent="0" marL="0">
+              <a:buNone/>
+            </a:pPr>
+            <a:r>
+              <a:rPr lang="en-US" sz="1400" b="1" spc="200" kern="0" dirty="0">
+                <a:solidFill>
+                  <a:srgbClr val="C85A28"/>
+                </a:solidFill>
+                <a:latin typeface="Calibri" pitchFamily="34" charset="0"/>
+                <a:ea typeface="Calibri" pitchFamily="34" charset="-122"/>
+                <a:cs typeface="Calibri" pitchFamily="34" charset="-120"/>
+              </a:rPr>
+              <a:t>AL SALIR DE HOY</a:t>
+            </a:r>
+            <a:endParaRPr lang="en-US" sz="1400" dirty="0"/>
+          </a:p>
+        </p:txBody>
+      </p:sp>
+      <p:sp>
+        <p:nvSpPr>
+          <p:cNvPr id="4" name="Text 2"/>
+          <p:cNvSpPr txBox="1"/>
+          <p:nvPr/>
+        </p:nvSpPr>
+        <p:spPr>
+          <a:xfrm>
+            <a:off x="566928" y="1097280"/>
+            <a:ext cx="10607040" cy="731520"/>
+          </a:xfrm>
+          <a:prstGeom prst="rect">
+            <a:avLst/>
+          </a:prstGeom>
+          <a:noFill/>
+          <a:ln/>
+        </p:spPr>
+        <p:txBody>
+          <a:bodyPr wrap="square" lIns="0" tIns="0" rIns="0" bIns="0" rtlCol="0" anchor="ctr"/>
+          <a:lstStyle/>
+          <a:p>
+            <a:pPr indent="0" marL="0">
+              <a:buNone/>
+            </a:pPr>
+            <a:r>
+              <a:rPr lang="en-US" sz="3000" b="1" dirty="0">
+                <a:solidFill>
+                  <a:srgbClr val="FFFFFF"/>
+                </a:solidFill>
+                <a:latin typeface="Arial" pitchFamily="34" charset="0"/>
+                <a:ea typeface="Arial" pitchFamily="34" charset="-122"/>
+                <a:cs typeface="Arial" pitchFamily="34" charset="-120"/>
+              </a:rPr>
+              <a:t>Lo que entregas hoy</a:t>
+            </a:r>
+            <a:endParaRPr lang="en-US" sz="3000" dirty="0"/>
+          </a:p>
+        </p:txBody>
+      </p:sp>
+      <p:sp>
+        <p:nvSpPr>
+          <p:cNvPr id="5" name="Shape 3"/>
           <p:cNvSpPr/>
           <p:nvPr/>
         </p:nvSpPr>
         <p:spPr>
           <a:xfrm>
-            <a:off x="-1737360" y="3931920"/>
-            <a:ext cx="4754880" cy="4754880"/>
-          </a:xfrm>
-          <a:prstGeom prst="ellipse">
-            <a:avLst/>
+            <a:off x="566928" y="1885950"/>
+            <a:ext cx="11057839" cy="630000"/>
+          </a:xfrm>
+          <a:prstGeom prst="roundRect">
+            <a:avLst>
+              <a:gd name="adj" fmla="val 7467"/>
+            </a:avLst>
           </a:prstGeom>
           <a:solidFill>
             <a:srgbClr val="24404E"/>
@@ -5456,14 +5727,39 @@
       </p:sp>
       <p:sp>
         <p:nvSpPr>
-          <p:cNvPr id="3" name="Text 1"/>
-          <p:cNvSpPr txBox="1"/>
-          <p:nvPr/>
-        </p:nvSpPr>
-        <p:spPr>
-          <a:xfrm>
-            <a:off x="566928" y="685800"/>
-            <a:ext cx="10424160" cy="365760"/>
+          <p:cNvPr id="6" name="Shape 4"/>
+          <p:cNvSpPr/>
+          <p:nvPr/>
+        </p:nvSpPr>
+        <p:spPr>
+          <a:xfrm>
+            <a:off x="804672" y="1999782"/>
+            <a:ext cx="402336" cy="402336"/>
+          </a:xfrm>
+          <a:prstGeom prst="ellipse">
+            <a:avLst/>
+          </a:prstGeom>
+          <a:solidFill>
+            <a:srgbClr val="2E7D7D"/>
+          </a:solidFill>
+          <a:ln w="12700">
+            <a:solidFill>
+              <a:srgbClr val="2E7D7D"/>
+            </a:solidFill>
+            <a:prstDash val="solid"/>
+          </a:ln>
+        </p:spPr>
+      </p:sp>
+      <p:sp>
+        <p:nvSpPr>
+          <p:cNvPr id="7" name="Text 5"/>
+          <p:cNvSpPr txBox="1"/>
+          <p:nvPr/>
+        </p:nvSpPr>
+        <p:spPr>
+          <a:xfrm>
+            <a:off x="804672" y="1999782"/>
+            <a:ext cx="402336" cy="402336"/>
           </a:xfrm>
           <a:prstGeom prst="rect">
             <a:avLst/>
@@ -5475,73 +5771,65 @@
           <a:bodyPr wrap="square" lIns="0" tIns="0" rIns="0" bIns="0" rtlCol="0" anchor="ctr"/>
           <a:lstStyle/>
           <a:p>
+            <a:pPr algn="ctr" indent="0" marL="0">
+              <a:buNone/>
+            </a:pPr>
+            <a:endParaRPr lang="en-US" sz="1200" dirty="0"/>
+          </a:p>
+        </p:txBody>
+      </p:sp>
+      <p:sp>
+        <p:nvSpPr>
+          <p:cNvPr id="8" name="Text 6"/>
+          <p:cNvSpPr txBox="1"/>
+          <p:nvPr/>
+        </p:nvSpPr>
+        <p:spPr>
+          <a:xfrm>
+            <a:off x="1426464" y="1949490"/>
+            <a:ext cx="9960559" cy="502920"/>
+          </a:xfrm>
+          <a:prstGeom prst="rect">
+            <a:avLst/>
+          </a:prstGeom>
+          <a:noFill/>
+          <a:ln/>
+        </p:spPr>
+        <p:txBody>
+          <a:bodyPr wrap="square" lIns="0" tIns="0" rIns="0" bIns="0" rtlCol="0" anchor="ctr"/>
+          <a:lstStyle/>
+          <a:p>
             <a:pPr indent="0" marL="0">
-              <a:buNone/>
-            </a:pPr>
-            <a:r>
-              <a:rPr lang="en-US" sz="1400" b="1" spc="200" kern="0" dirty="0">
-                <a:solidFill>
-                  <a:srgbClr val="C85A28"/>
+              <a:lnSpc>
+                <a:spcPct val="110000"/>
+              </a:lnSpc>
+              <a:buNone/>
+            </a:pPr>
+            <a:r>
+              <a:rPr lang="en-US" sz="1450" dirty="0">
+                <a:solidFill>
+                  <a:srgbClr val="FFFFFF"/>
                 </a:solidFill>
                 <a:latin typeface="Calibri" pitchFamily="34" charset="0"/>
                 <a:ea typeface="Calibri" pitchFamily="34" charset="-122"/>
                 <a:cs typeface="Calibri" pitchFamily="34" charset="-120"/>
               </a:rPr>
-              <a:t>AL SALIR DE HOY</a:t>
-            </a:r>
-            <a:endParaRPr lang="en-US" sz="1400" dirty="0"/>
-          </a:p>
-        </p:txBody>
-      </p:sp>
-      <p:sp>
-        <p:nvSpPr>
-          <p:cNvPr id="4" name="Text 2"/>
-          <p:cNvSpPr txBox="1"/>
-          <p:nvPr/>
-        </p:nvSpPr>
-        <p:spPr>
-          <a:xfrm>
-            <a:off x="566928" y="1097280"/>
-            <a:ext cx="10607040" cy="731520"/>
-          </a:xfrm>
-          <a:prstGeom prst="rect">
-            <a:avLst/>
-          </a:prstGeom>
-          <a:noFill/>
-          <a:ln/>
-        </p:spPr>
-        <p:txBody>
-          <a:bodyPr wrap="square" lIns="0" tIns="0" rIns="0" bIns="0" rtlCol="0" anchor="ctr"/>
-          <a:lstStyle/>
-          <a:p>
-            <a:pPr indent="0" marL="0">
-              <a:buNone/>
-            </a:pPr>
-            <a:r>
-              <a:rPr lang="en-US" sz="3000" b="1" dirty="0">
-                <a:solidFill>
-                  <a:srgbClr val="FFFFFF"/>
-                </a:solidFill>
-                <a:latin typeface="Arial" pitchFamily="34" charset="0"/>
-                <a:ea typeface="Arial" pitchFamily="34" charset="-122"/>
-                <a:cs typeface="Arial" pitchFamily="34" charset="-120"/>
-              </a:rPr>
-              <a:t>Lo que entregas hoy</a:t>
-            </a:r>
-            <a:endParaRPr lang="en-US" sz="3000" dirty="0"/>
-          </a:p>
-        </p:txBody>
-      </p:sp>
-      <p:sp>
-        <p:nvSpPr>
-          <p:cNvPr id="5" name="Shape 3"/>
+              <a:t>El dictamen de validación de tu equipo, con todos los hallazgos verificados. Por correo: S03_Equipo##_Dictamen.docx, lo manda una sola persona.</a:t>
+            </a:r>
+            <a:endParaRPr lang="en-US" sz="1450" dirty="0"/>
+          </a:p>
+        </p:txBody>
+      </p:sp>
+      <p:sp>
+        <p:nvSpPr>
+          <p:cNvPr id="9" name="Shape 3"/>
           <p:cNvSpPr/>
           <p:nvPr/>
         </p:nvSpPr>
         <p:spPr>
           <a:xfrm>
-            <a:off x="566928" y="2011680"/>
-            <a:ext cx="11057839" cy="857250"/>
+            <a:off x="566928" y="2600950"/>
+            <a:ext cx="11057839" cy="630000"/>
           </a:xfrm>
           <a:prstGeom prst="roundRect">
             <a:avLst>
@@ -5561,13 +5849,13 @@
       </p:sp>
       <p:sp>
         <p:nvSpPr>
-          <p:cNvPr id="6" name="Shape 4"/>
+          <p:cNvPr id="10" name="Shape 4"/>
           <p:cNvSpPr/>
           <p:nvPr/>
         </p:nvSpPr>
         <p:spPr>
           <a:xfrm>
-            <a:off x="804672" y="2239137"/>
+            <a:off x="804672" y="2714782"/>
             <a:ext cx="402336" cy="402336"/>
           </a:xfrm>
           <a:prstGeom prst="ellipse">
@@ -5586,13 +5874,13 @@
       </p:sp>
       <p:sp>
         <p:nvSpPr>
-          <p:cNvPr id="7" name="Text 5"/>
-          <p:cNvSpPr txBox="1"/>
-          <p:nvPr/>
-        </p:nvSpPr>
-        <p:spPr>
-          <a:xfrm>
-            <a:off x="804672" y="2239137"/>
+          <p:cNvPr id="11" name="Text 5"/>
+          <p:cNvSpPr txBox="1"/>
+          <p:nvPr/>
+        </p:nvSpPr>
+        <p:spPr>
+          <a:xfrm>
+            <a:off x="804672" y="2714782"/>
             <a:ext cx="402336" cy="402336"/>
           </a:xfrm>
           <a:prstGeom prst="rect">
@@ -5614,14 +5902,14 @@
       </p:sp>
       <p:sp>
         <p:nvSpPr>
-          <p:cNvPr id="8" name="Text 6"/>
-          <p:cNvSpPr txBox="1"/>
-          <p:nvPr/>
-        </p:nvSpPr>
-        <p:spPr>
-          <a:xfrm>
-            <a:off x="1426464" y="2084832"/>
-            <a:ext cx="9960559" cy="710946"/>
+          <p:cNvPr id="12" name="Text 6"/>
+          <p:cNvSpPr txBox="1"/>
+          <p:nvPr/>
+        </p:nvSpPr>
+        <p:spPr>
+          <a:xfrm>
+            <a:off x="1426464" y="2664490"/>
+            <a:ext cx="9960559" cy="502920"/>
           </a:xfrm>
           <a:prstGeom prst="rect">
             <a:avLst/>
@@ -5648,7 +5936,7 @@
                 <a:ea typeface="Calibri" pitchFamily="34" charset="-122"/>
                 <a:cs typeface="Calibri" pitchFamily="34" charset="-120"/>
               </a:rPr>
-              <a:t>El dictamen de validación de tu equipo, con todos los hallazgos verificados.</a:t>
+              <a:t>La lista de hallazgos que el modelo reportó y que tu equipo descartó, con la razón. Esa lista cuenta a favor.</a:t>
             </a:r>
             <a:endParaRPr lang="en-US" sz="1450" dirty="0"/>
           </a:p>
@@ -5656,14 +5944,14 @@
       </p:sp>
       <p:sp>
         <p:nvSpPr>
-          <p:cNvPr id="9" name="Shape 7"/>
+          <p:cNvPr id="13" name="Shape 3"/>
           <p:cNvSpPr/>
           <p:nvPr/>
         </p:nvSpPr>
         <p:spPr>
           <a:xfrm>
-            <a:off x="566928" y="3051810"/>
-            <a:ext cx="11057839" cy="857250"/>
+            <a:off x="566928" y="3315950"/>
+            <a:ext cx="11057839" cy="630000"/>
           </a:xfrm>
           <a:prstGeom prst="roundRect">
             <a:avLst>
@@ -5683,13 +5971,13 @@
       </p:sp>
       <p:sp>
         <p:nvSpPr>
-          <p:cNvPr id="10" name="Shape 8"/>
+          <p:cNvPr id="14" name="Shape 4"/>
           <p:cNvSpPr/>
           <p:nvPr/>
         </p:nvSpPr>
         <p:spPr>
           <a:xfrm>
-            <a:off x="804672" y="3279267"/>
+            <a:off x="804672" y="3429782"/>
             <a:ext cx="402336" cy="402336"/>
           </a:xfrm>
           <a:prstGeom prst="ellipse">
@@ -5708,13 +5996,13 @@
       </p:sp>
       <p:sp>
         <p:nvSpPr>
-          <p:cNvPr id="11" name="Text 9"/>
-          <p:cNvSpPr txBox="1"/>
-          <p:nvPr/>
-        </p:nvSpPr>
-        <p:spPr>
-          <a:xfrm>
-            <a:off x="804672" y="3279267"/>
+          <p:cNvPr id="15" name="Text 5"/>
+          <p:cNvSpPr txBox="1"/>
+          <p:nvPr/>
+        </p:nvSpPr>
+        <p:spPr>
+          <a:xfrm>
+            <a:off x="804672" y="3429782"/>
             <a:ext cx="402336" cy="402336"/>
           </a:xfrm>
           <a:prstGeom prst="rect">
@@ -5736,14 +6024,14 @@
       </p:sp>
       <p:sp>
         <p:nvSpPr>
-          <p:cNvPr id="12" name="Text 10"/>
-          <p:cNvSpPr txBox="1"/>
-          <p:nvPr/>
-        </p:nvSpPr>
-        <p:spPr>
-          <a:xfrm>
-            <a:off x="1426464" y="3124962"/>
-            <a:ext cx="9960559" cy="710946"/>
+          <p:cNvPr id="16" name="Text 6"/>
+          <p:cNvSpPr txBox="1"/>
+          <p:nvPr/>
+        </p:nvSpPr>
+        <p:spPr>
+          <a:xfrm>
+            <a:off x="1426464" y="3379490"/>
+            <a:ext cx="9960559" cy="502920"/>
           </a:xfrm>
           <a:prstGeom prst="rect">
             <a:avLst/>
@@ -5770,7 +6058,7 @@
                 <a:ea typeface="Calibri" pitchFamily="34" charset="-122"/>
                 <a:cs typeface="Calibri" pitchFamily="34" charset="-120"/>
               </a:rPr>
-              <a:t>La lista de hallazgos que el modelo reportó y que tu equipo descartó, con la razón. Esa lista cuenta a favor.</a:t>
+              <a:t>Tu bitácora al día, con los prompts de verificación que usaste, incluido el del calentamiento.</a:t>
             </a:r>
             <a:endParaRPr lang="en-US" sz="1450" dirty="0"/>
           </a:p>
@@ -5778,14 +6066,14 @@
       </p:sp>
       <p:sp>
         <p:nvSpPr>
-          <p:cNvPr id="13" name="Shape 11"/>
+          <p:cNvPr id="17" name="Shape 3"/>
           <p:cNvSpPr/>
           <p:nvPr/>
         </p:nvSpPr>
         <p:spPr>
           <a:xfrm>
-            <a:off x="566928" y="4091940"/>
-            <a:ext cx="11057839" cy="857250"/>
+            <a:off x="566928" y="4030950"/>
+            <a:ext cx="11057839" cy="630000"/>
           </a:xfrm>
           <a:prstGeom prst="roundRect">
             <a:avLst>
@@ -5805,13 +6093,13 @@
       </p:sp>
       <p:sp>
         <p:nvSpPr>
-          <p:cNvPr id="14" name="Shape 12"/>
+          <p:cNvPr id="18" name="Shape 4"/>
           <p:cNvSpPr/>
           <p:nvPr/>
         </p:nvSpPr>
         <p:spPr>
           <a:xfrm>
-            <a:off x="804672" y="4319397"/>
+            <a:off x="804672" y="4144782"/>
             <a:ext cx="402336" cy="402336"/>
           </a:xfrm>
           <a:prstGeom prst="ellipse">
@@ -5830,13 +6118,13 @@
       </p:sp>
       <p:sp>
         <p:nvSpPr>
-          <p:cNvPr id="15" name="Text 13"/>
-          <p:cNvSpPr txBox="1"/>
-          <p:nvPr/>
-        </p:nvSpPr>
-        <p:spPr>
-          <a:xfrm>
-            <a:off x="804672" y="4319397"/>
+          <p:cNvPr id="19" name="Text 5"/>
+          <p:cNvSpPr txBox="1"/>
+          <p:nvPr/>
+        </p:nvSpPr>
+        <p:spPr>
+          <a:xfrm>
+            <a:off x="804672" y="4144782"/>
             <a:ext cx="402336" cy="402336"/>
           </a:xfrm>
           <a:prstGeom prst="rect">
@@ -5858,14 +6146,14 @@
       </p:sp>
       <p:sp>
         <p:nvSpPr>
-          <p:cNvPr id="16" name="Text 14"/>
-          <p:cNvSpPr txBox="1"/>
-          <p:nvPr/>
-        </p:nvSpPr>
-        <p:spPr>
-          <a:xfrm>
-            <a:off x="1426464" y="4165092"/>
-            <a:ext cx="9960559" cy="710946"/>
+          <p:cNvPr id="20" name="Text 6"/>
+          <p:cNvSpPr txBox="1"/>
+          <p:nvPr/>
+        </p:nvSpPr>
+        <p:spPr>
+          <a:xfrm>
+            <a:off x="1426464" y="4094490"/>
+            <a:ext cx="9960559" cy="502920"/>
           </a:xfrm>
           <a:prstGeom prst="rect">
             <a:avLst/>
@@ -5892,7 +6180,7 @@
                 <a:ea typeface="Calibri" pitchFamily="34" charset="-122"/>
                 <a:cs typeface="Calibri" pitchFamily="34" charset="-120"/>
               </a:rPr>
-              <a:t>Tu bitácora al día, con los prompts de verificación que usaste.</a:t>
+              <a:t>Pendiente de la sesión 2: los tres prompts de tu biblioteca se entregan el viernes antes de las 9:00, cada uno con sus dos versiones.</a:t>
             </a:r>
             <a:endParaRPr lang="en-US" sz="1450" dirty="0"/>
           </a:p>
@@ -5900,14 +6188,14 @@
       </p:sp>
       <p:sp>
         <p:nvSpPr>
-          <p:cNvPr id="17" name="Shape 15"/>
+          <p:cNvPr id="21" name="Shape 3"/>
           <p:cNvSpPr/>
           <p:nvPr/>
         </p:nvSpPr>
         <p:spPr>
           <a:xfrm>
-            <a:off x="566928" y="5132070"/>
-            <a:ext cx="11057839" cy="857250"/>
+            <a:off x="566928" y="4745950"/>
+            <a:ext cx="11057839" cy="630000"/>
           </a:xfrm>
           <a:prstGeom prst="roundRect">
             <a:avLst>
@@ -5927,13 +6215,13 @@
       </p:sp>
       <p:sp>
         <p:nvSpPr>
-          <p:cNvPr id="18" name="Shape 16"/>
+          <p:cNvPr id="22" name="Shape 4"/>
           <p:cNvSpPr/>
           <p:nvPr/>
         </p:nvSpPr>
         <p:spPr>
           <a:xfrm>
-            <a:off x="804672" y="5359527"/>
+            <a:off x="804672" y="4859782"/>
             <a:ext cx="402336" cy="402336"/>
           </a:xfrm>
           <a:prstGeom prst="ellipse">
@@ -5952,13 +6240,13 @@
       </p:sp>
       <p:sp>
         <p:nvSpPr>
-          <p:cNvPr id="19" name="Text 17"/>
-          <p:cNvSpPr txBox="1"/>
-          <p:nvPr/>
-        </p:nvSpPr>
-        <p:spPr>
-          <a:xfrm>
-            <a:off x="804672" y="5359527"/>
+          <p:cNvPr id="23" name="Text 5"/>
+          <p:cNvSpPr txBox="1"/>
+          <p:nvPr/>
+        </p:nvSpPr>
+        <p:spPr>
+          <a:xfrm>
+            <a:off x="804672" y="4859782"/>
             <a:ext cx="402336" cy="402336"/>
           </a:xfrm>
           <a:prstGeom prst="rect">
@@ -5980,14 +6268,14 @@
       </p:sp>
       <p:sp>
         <p:nvSpPr>
-          <p:cNvPr id="20" name="Text 18"/>
-          <p:cNvSpPr txBox="1"/>
-          <p:nvPr/>
-        </p:nvSpPr>
-        <p:spPr>
-          <a:xfrm>
-            <a:off x="1426464" y="5205222"/>
-            <a:ext cx="9960559" cy="710946"/>
+          <p:cNvPr id="24" name="Text 6"/>
+          <p:cNvSpPr txBox="1"/>
+          <p:nvPr/>
+        </p:nvSpPr>
+        <p:spPr>
+          <a:xfrm>
+            <a:off x="1426464" y="4809490"/>
+            <a:ext cx="9960559" cy="502920"/>
           </a:xfrm>
           <a:prstGeom prst="rect">
             <a:avLst/>
@@ -6014,6 +6302,128 @@
                 <a:ea typeface="Calibri" pitchFamily="34" charset="-122"/>
                 <a:cs typeface="Calibri" pitchFamily="34" charset="-120"/>
               </a:rPr>
+              <a:t>También en casa: el hilo de correo y la transcripción, con la sección 3 del handout del martes como guía.</a:t>
+            </a:r>
+            <a:endParaRPr lang="en-US" sz="1450" dirty="0"/>
+          </a:p>
+        </p:txBody>
+      </p:sp>
+      <p:sp>
+        <p:nvSpPr>
+          <p:cNvPr id="25" name="Shape 3"/>
+          <p:cNvSpPr/>
+          <p:nvPr/>
+        </p:nvSpPr>
+        <p:spPr>
+          <a:xfrm>
+            <a:off x="566928" y="5460950"/>
+            <a:ext cx="11057839" cy="630000"/>
+          </a:xfrm>
+          <a:prstGeom prst="roundRect">
+            <a:avLst>
+              <a:gd name="adj" fmla="val 7467"/>
+            </a:avLst>
+          </a:prstGeom>
+          <a:solidFill>
+            <a:srgbClr val="24404E"/>
+          </a:solidFill>
+          <a:ln w="12700">
+            <a:solidFill>
+              <a:srgbClr val="24404E"/>
+            </a:solidFill>
+            <a:prstDash val="solid"/>
+          </a:ln>
+        </p:spPr>
+      </p:sp>
+      <p:sp>
+        <p:nvSpPr>
+          <p:cNvPr id="26" name="Shape 4"/>
+          <p:cNvSpPr/>
+          <p:nvPr/>
+        </p:nvSpPr>
+        <p:spPr>
+          <a:xfrm>
+            <a:off x="804672" y="5574782"/>
+            <a:ext cx="402336" cy="402336"/>
+          </a:xfrm>
+          <a:prstGeom prst="ellipse">
+            <a:avLst/>
+          </a:prstGeom>
+          <a:solidFill>
+            <a:srgbClr val="2E7D7D"/>
+          </a:solidFill>
+          <a:ln w="12700">
+            <a:solidFill>
+              <a:srgbClr val="2E7D7D"/>
+            </a:solidFill>
+            <a:prstDash val="solid"/>
+          </a:ln>
+        </p:spPr>
+      </p:sp>
+      <p:sp>
+        <p:nvSpPr>
+          <p:cNvPr id="27" name="Text 5"/>
+          <p:cNvSpPr txBox="1"/>
+          <p:nvPr/>
+        </p:nvSpPr>
+        <p:spPr>
+          <a:xfrm>
+            <a:off x="804672" y="5574782"/>
+            <a:ext cx="402336" cy="402336"/>
+          </a:xfrm>
+          <a:prstGeom prst="rect">
+            <a:avLst/>
+          </a:prstGeom>
+          <a:noFill/>
+          <a:ln/>
+        </p:spPr>
+        <p:txBody>
+          <a:bodyPr wrap="square" lIns="0" tIns="0" rIns="0" bIns="0" rtlCol="0" anchor="ctr"/>
+          <a:lstStyle/>
+          <a:p>
+            <a:pPr algn="ctr" indent="0" marL="0">
+              <a:buNone/>
+            </a:pPr>
+            <a:endParaRPr lang="en-US" sz="1200" dirty="0"/>
+          </a:p>
+        </p:txBody>
+      </p:sp>
+      <p:sp>
+        <p:nvSpPr>
+          <p:cNvPr id="28" name="Text 6"/>
+          <p:cNvSpPr txBox="1"/>
+          <p:nvPr/>
+        </p:nvSpPr>
+        <p:spPr>
+          <a:xfrm>
+            <a:off x="1426464" y="5524490"/>
+            <a:ext cx="9960559" cy="502920"/>
+          </a:xfrm>
+          <a:prstGeom prst="rect">
+            <a:avLst/>
+          </a:prstGeom>
+          <a:noFill/>
+          <a:ln/>
+        </p:spPr>
+        <p:txBody>
+          <a:bodyPr wrap="square" lIns="0" tIns="0" rIns="0" bIns="0" rtlCol="0" anchor="ctr"/>
+          <a:lstStyle/>
+          <a:p>
+            <a:pPr indent="0" marL="0">
+              <a:lnSpc>
+                <a:spcPct val="110000"/>
+              </a:lnSpc>
+              <a:buNone/>
+            </a:pPr>
+            <a:r>
+              <a:rPr lang="en-US" sz="1450" dirty="0">
+                <a:solidFill>
+                  <a:srgbClr val="FFFFFF"/>
+                </a:solidFill>
+                <a:latin typeface="Calibri" pitchFamily="34" charset="0"/>
+                <a:ea typeface="Calibri" pitchFamily="34" charset="-122"/>
+                <a:cs typeface="Calibri" pitchFamily="34" charset="-120"/>
+              </a:rPr>
               <a:t>Con esto cierra el Módulo I. Mañana empieza el trabajo cualitativo, que es donde vas a pasar la mayor parte del tiempo.</a:t>
             </a:r>
             <a:endParaRPr lang="en-US" sz="1450" dirty="0"/>
@@ -6022,7 +6432,7 @@
       </p:sp>
       <p:sp>
         <p:nvSpPr>
-          <p:cNvPr id="21" name="Text 19"/>
+          <p:cNvPr id="29" name="Text 19"/>
           <p:cNvSpPr txBox="1"/>
           <p:nvPr/>
         </p:nvSpPr>
@@ -6067,9 +6477,9 @@
 </p:sld>
 </file>
 
-<file path=ppt/slides/slide2.xml><?xml version="1.0" encoding="utf-8"?>
+<file path=ppt/slides/slide16.xml><?xml version="1.0" encoding="utf-8"?>
 <p:sld xmlns:a="http://schemas.openxmlformats.org/drawingml/2006/main" xmlns:r="http://schemas.openxmlformats.org/officeDocument/2006/relationships" xmlns:p="http://schemas.openxmlformats.org/presentationml/2006/main">
-  <p:cSld name="Slide 2">
+  <p:cSld name="Mapa corregido">
     <p:spTree>
       <p:nvGrpSpPr>
         <p:cNvPr id="1" name=""/>
@@ -6086,14 +6496,14 @@
       </p:grpSpPr>
       <p:sp>
         <p:nvSpPr>
-          <p:cNvPr id="2" name="Text 0"/>
+          <p:cNvPr id="8" name="Text"/>
           <p:cNvSpPr txBox="1"/>
           <p:nvPr/>
         </p:nvSpPr>
         <p:spPr>
           <a:xfrm>
             <a:off x="566928" y="402336"/>
-            <a:ext cx="9229039" cy="749808"/>
+            <a:ext cx="11057839" cy="749808"/>
           </a:xfrm>
           <a:prstGeom prst="rect">
             <a:avLst/>
@@ -6117,7 +6527,7 @@
                 <a:ea typeface="Arial" pitchFamily="34" charset="-122"/>
                 <a:cs typeface="Arial" pitchFamily="34" charset="-120"/>
               </a:rPr>
-              <a:t>Cómo vamos a usar los 150 minutos</a:t>
+              <a:t>Dónde vive Copilot en el INEGI, corregido</a:t>
             </a:r>
             <a:endParaRPr lang="en-US" sz="3200" dirty="0"/>
           </a:p>
@@ -6125,18 +6535,237 @@
       </p:sp>
       <p:sp>
         <p:nvSpPr>
-          <p:cNvPr id="3" name="Shape 1"/>
+          <p:cNvPr id="9" name="Text"/>
+          <p:cNvSpPr txBox="1"/>
+          <p:nvPr/>
+        </p:nvSpPr>
+        <p:spPr>
+          <a:xfrm>
+            <a:off x="566928" y="1280160"/>
+            <a:ext cx="11057839" cy="731520"/>
+          </a:xfrm>
+          <a:prstGeom prst="rect">
+            <a:avLst/>
+          </a:prstGeom>
+          <a:noFill/>
+          <a:ln/>
+        </p:spPr>
+        <p:txBody>
+          <a:bodyPr wrap="square" lIns="0" tIns="0" rIns="0" bIns="0" rtlCol="0" anchor="t"/>
+          <a:lstStyle/>
+          <a:p>
+            <a:pPr indent="0" marL="0">
+              <a:buNone/>
+            </a:pPr>
+            <a:r>
+              <a:rPr lang="en-US" sz="1500" dirty="0">
+                <a:solidFill>
+                  <a:srgbClr val="5A6B73"/>
+                </a:solidFill>
+                <a:latin typeface="Calibri" pitchFamily="34" charset="0"/>
+                <a:ea typeface="Calibri" pitchFamily="34" charset="-122"/>
+                <a:cs typeface="Calibri" pitchFamily="34" charset="-120"/>
+              </a:rPr>
+              <a:t>Cambia dónde se trabaja, no la regla. Queda aquí como referencia para el resto del curso.</a:t>
+            </a:r>
+            <a:endParaRPr lang="en-US" sz="1500" dirty="0"/>
+          </a:p>
+        </p:txBody>
+      </p:sp>
+      <p:sp>
+        <p:nvSpPr>
+          <p:cNvPr id="2" name="Shape"/>
           <p:cNvSpPr/>
           <p:nvPr/>
         </p:nvSpPr>
         <p:spPr>
           <a:xfrm>
-            <a:off x="9485071" y="457200"/>
-            <a:ext cx="2139696" cy="347472"/>
+            <a:off x="566928" y="1810512"/>
+            <a:ext cx="5460655" cy="3400000"/>
           </a:xfrm>
           <a:prstGeom prst="roundRect">
             <a:avLst>
-              <a:gd name="adj" fmla="val 50000"/>
+              <a:gd name="adj" fmla="val 2933"/>
+            </a:avLst>
+          </a:prstGeom>
+          <a:solidFill>
+            <a:srgbClr val="D7E7E7"/>
+          </a:solidFill>
+          <a:ln w="12700">
+            <a:solidFill>
+              <a:srgbClr val="D7E7E7"/>
+            </a:solidFill>
+            <a:prstDash val="solid"/>
+          </a:ln>
+        </p:spPr>
+      </p:sp>
+      <p:sp>
+        <p:nvSpPr>
+          <p:cNvPr id="3" name="Text"/>
+          <p:cNvSpPr txBox="1"/>
+          <p:nvPr/>
+        </p:nvSpPr>
+        <p:spPr>
+          <a:xfrm>
+            <a:off x="841248" y="2029968"/>
+            <a:ext cx="4912015" cy="365760"/>
+          </a:xfrm>
+          <a:prstGeom prst="rect">
+            <a:avLst/>
+          </a:prstGeom>
+          <a:noFill/>
+          <a:ln/>
+        </p:spPr>
+        <p:txBody>
+          <a:bodyPr wrap="square" lIns="0" tIns="0" rIns="0" bIns="0" rtlCol="0" anchor="t"/>
+          <a:lstStyle/>
+          <a:p>
+            <a:pPr indent="0" marL="0">
+              <a:buNone/>
+            </a:pPr>
+            <a:r>
+              <a:rPr lang="en-US" sz="1700" b="1" dirty="0">
+                <a:solidFill>
+                  <a:srgbClr val="2E7D7D"/>
+                </a:solidFill>
+                <a:latin typeface="Arial" pitchFamily="34" charset="0"/>
+                <a:ea typeface="Arial" pitchFamily="34" charset="-122"/>
+                <a:cs typeface="Arial" pitchFamily="34" charset="-120"/>
+              </a:rPr>
+              <a:t>Lo que sí tienes: Copilot Chat</a:t>
+            </a:r>
+            <a:endParaRPr lang="en-US" sz="1700" dirty="0"/>
+          </a:p>
+        </p:txBody>
+      </p:sp>
+      <p:sp>
+        <p:nvSpPr>
+          <p:cNvPr id="4" name="Text"/>
+          <p:cNvSpPr txBox="1"/>
+          <p:nvPr/>
+        </p:nvSpPr>
+        <p:spPr>
+          <a:xfrm>
+            <a:off x="841248" y="2560320"/>
+            <a:ext cx="4912015" cy="2800000"/>
+          </a:xfrm>
+          <a:prstGeom prst="rect">
+            <a:avLst/>
+          </a:prstGeom>
+          <a:noFill/>
+          <a:ln/>
+        </p:spPr>
+        <p:txBody>
+          <a:bodyPr wrap="square" lIns="0" tIns="0" rIns="0" bIns="0" rtlCol="0" anchor="t"/>
+          <a:lstStyle/>
+          <a:p>
+            <a:pPr indent="0" marL="0">
+              <a:lnSpc>
+                <a:spcPct val="110000"/>
+              </a:lnSpc>
+              <a:spcAft>
+                <a:spcPts val="800"/>
+              </a:spcAft>
+              <a:buNone/>
+            </a:pPr>
+            <a:r>
+              <a:rPr lang="en-US" sz="1300" dirty="0">
+                <a:solidFill>
+                  <a:srgbClr val="16262E"/>
+                </a:solidFill>
+                <a:latin typeface="Calibri" pitchFamily="34" charset="0"/>
+                <a:ea typeface="Calibri" pitchFamily="34" charset="-122"/>
+                <a:cs typeface="Calibri" pitchFamily="34" charset="-120"/>
+              </a:rPr>
+              <a:t>Con tu cuenta del Instituto estás dentro del contrato: tus prompts y tus archivos no entrenan modelos.</a:t>
+            </a:r>
+            <a:endParaRPr lang="en-US" sz="1300" dirty="0"/>
+          </a:p>
+          <a:p>
+            <a:pPr indent="0" marL="0">
+              <a:lnSpc>
+                <a:spcPct val="110000"/>
+              </a:lnSpc>
+              <a:spcAft>
+                <a:spcPts val="800"/>
+              </a:spcAft>
+              <a:buNone/>
+            </a:pPr>
+            <a:r>
+              <a:rPr lang="en-US" sz="1300" dirty="0">
+                <a:solidFill>
+                  <a:srgbClr val="16262E"/>
+                </a:solidFill>
+                <a:latin typeface="Calibri" pitchFamily="34" charset="0"/>
+                <a:ea typeface="Calibri" pitchFamily="34" charset="-122"/>
+                <a:cs typeface="Calibri" pitchFamily="34" charset="-120"/>
+              </a:rPr>
+              <a:t>Puede leer tus archivos de OneDrive: adjúntalos desde el chat o referéncialos. Lo comprobamos el martes en vivo.</a:t>
+            </a:r>
+            <a:endParaRPr lang="en-US" sz="1300" dirty="0"/>
+          </a:p>
+          <a:p>
+            <a:pPr indent="0" marL="0">
+              <a:lnSpc>
+                <a:spcPct val="110000"/>
+              </a:lnSpc>
+              <a:spcAft>
+                <a:spcPts val="800"/>
+              </a:spcAft>
+              <a:buNone/>
+            </a:pPr>
+            <a:r>
+              <a:rPr lang="en-US" sz="1300" dirty="0">
+                <a:solidFill>
+                  <a:srgbClr val="16262E"/>
+                </a:solidFill>
+                <a:latin typeface="Calibri" pitchFamily="34" charset="0"/>
+                <a:ea typeface="Calibri" pitchFamily="34" charset="-122"/>
+                <a:cs typeface="Calibri" pitchFamily="34" charset="-120"/>
+              </a:rPr>
+              <a:t>Es el único lugar para trabajar información amarilla.</a:t>
+            </a:r>
+            <a:endParaRPr lang="en-US" sz="1300" dirty="0"/>
+          </a:p>
+          <a:p>
+            <a:pPr indent="0" marL="0">
+              <a:lnSpc>
+                <a:spcPct val="110000"/>
+              </a:lnSpc>
+              <a:spcAft>
+                <a:spcPts val="800"/>
+              </a:spcAft>
+              <a:buNone/>
+            </a:pPr>
+            <a:r>
+              <a:rPr lang="en-US" sz="1300" dirty="0">
+                <a:solidFill>
+                  <a:srgbClr val="16262E"/>
+                </a:solidFill>
+                <a:latin typeface="Calibri" pitchFamily="34" charset="0"/>
+                <a:ea typeface="Calibri" pitchFamily="34" charset="-122"/>
+                <a:cs typeface="Calibri" pitchFamily="34" charset="-120"/>
+              </a:rPr>
+              <a:t>El calentamiento de hoy corre exactamente así: tu archivo adjunto y el prompt de seis casillas.</a:t>
+            </a:r>
+            <a:endParaRPr lang="en-US" sz="1300" dirty="0"/>
+          </a:p>
+        </p:txBody>
+      </p:sp>
+      <p:sp>
+        <p:nvSpPr>
+          <p:cNvPr id="5" name="Shape"/>
+          <p:cNvSpPr/>
+          <p:nvPr/>
+        </p:nvSpPr>
+        <p:spPr>
+          <a:xfrm>
+            <a:off x="6164511" y="1810512"/>
+            <a:ext cx="5460655" cy="3400000"/>
+          </a:xfrm>
+          <a:prstGeom prst="roundRect">
+            <a:avLst>
+              <a:gd name="adj" fmla="val 2933"/>
             </a:avLst>
           </a:prstGeom>
           <a:solidFill>
@@ -6152,57 +6781,1392 @@
       </p:sp>
       <p:sp>
         <p:nvSpPr>
-          <p:cNvPr id="4" name="Text 2"/>
-          <p:cNvSpPr txBox="1"/>
-          <p:nvPr/>
-        </p:nvSpPr>
-        <p:spPr>
-          <a:xfrm>
-            <a:off x="9485071" y="457200"/>
-            <a:ext cx="2139696" cy="347472"/>
-          </a:xfrm>
-          <a:prstGeom prst="rect">
-            <a:avLst/>
-          </a:prstGeom>
-          <a:noFill/>
-          <a:ln/>
-        </p:spPr>
-        <p:txBody>
-          <a:bodyPr wrap="square" lIns="0" tIns="0" rIns="0" bIns="0" rtlCol="0" anchor="ctr"/>
-          <a:lstStyle/>
-          <a:p>
-            <a:pPr algn="ctr" indent="0" marL="0">
-              <a:buNone/>
-            </a:pPr>
-            <a:r>
-              <a:rPr lang="en-US" sz="1200" b="1" dirty="0">
+          <p:cNvPr id="6" name="Text"/>
+          <p:cNvSpPr txBox="1"/>
+          <p:nvPr/>
+        </p:nvSpPr>
+        <p:spPr>
+          <a:xfrm>
+            <a:off x="6438831" y="2029968"/>
+            <a:ext cx="4912015" cy="365760"/>
+          </a:xfrm>
+          <a:prstGeom prst="rect">
+            <a:avLst/>
+          </a:prstGeom>
+          <a:noFill/>
+          <a:ln/>
+        </p:spPr>
+        <p:txBody>
+          <a:bodyPr wrap="square" lIns="0" tIns="0" rIns="0" bIns="0" rtlCol="0" anchor="t"/>
+          <a:lstStyle/>
+          <a:p>
+            <a:pPr indent="0" marL="0">
+              <a:buNone/>
+            </a:pPr>
+            <a:r>
+              <a:rPr lang="en-US" sz="1700" b="1" dirty="0">
                 <a:solidFill>
                   <a:srgbClr val="5A6B73"/>
+                </a:solidFill>
+                <a:latin typeface="Arial" pitchFamily="34" charset="0"/>
+                <a:ea typeface="Arial" pitchFamily="34" charset="-122"/>
+                <a:cs typeface="Arial" pitchFamily="34" charset="-120"/>
+              </a:rPr>
+              <a:t>Lo que no aparece</a:t>
+            </a:r>
+            <a:endParaRPr lang="en-US" sz="1700" dirty="0"/>
+          </a:p>
+        </p:txBody>
+      </p:sp>
+      <p:sp>
+        <p:nvSpPr>
+          <p:cNvPr id="7" name="Text"/>
+          <p:cNvSpPr txBox="1"/>
+          <p:nvPr/>
+        </p:nvSpPr>
+        <p:spPr>
+          <a:xfrm>
+            <a:off x="6438831" y="2560320"/>
+            <a:ext cx="4912015" cy="2800000"/>
+          </a:xfrm>
+          <a:prstGeom prst="rect">
+            <a:avLst/>
+          </a:prstGeom>
+          <a:noFill/>
+          <a:ln/>
+        </p:spPr>
+        <p:txBody>
+          <a:bodyPr wrap="square" lIns="0" tIns="0" rIns="0" bIns="0" rtlCol="0" anchor="t"/>
+          <a:lstStyle/>
+          <a:p>
+            <a:pPr indent="0" marL="0">
+              <a:lnSpc>
+                <a:spcPct val="110000"/>
+              </a:lnSpc>
+              <a:spcAft>
+                <a:spcPts val="800"/>
+              </a:spcAft>
+              <a:buNone/>
+            </a:pPr>
+            <a:r>
+              <a:rPr lang="en-US" sz="1300" dirty="0">
+                <a:solidFill>
+                  <a:srgbClr val="16262E"/>
                 </a:solidFill>
                 <a:latin typeface="Calibri" pitchFamily="34" charset="0"/>
                 <a:ea typeface="Calibri" pitchFamily="34" charset="-122"/>
                 <a:cs typeface="Calibri" pitchFamily="34" charset="-120"/>
               </a:rPr>
-              <a:t>9:00 a 11:30</a:t>
-            </a:r>
-            <a:endParaRPr lang="en-US" sz="1200" dirty="0"/>
-          </a:p>
-        </p:txBody>
-      </p:sp>
-      <p:sp>
-        <p:nvSpPr>
-          <p:cNvPr id="5" name="Shape 3"/>
+              <a:t>Copilot dentro de Word, Excel, Outlook y Teams no está habilitado en el Instituto.</a:t>
+            </a:r>
+            <a:endParaRPr lang="en-US" sz="1300" dirty="0"/>
+          </a:p>
+          <a:p>
+            <a:pPr indent="0" marL="0">
+              <a:lnSpc>
+                <a:spcPct val="110000"/>
+              </a:lnSpc>
+              <a:spcAft>
+                <a:spcPts val="800"/>
+              </a:spcAft>
+              <a:buNone/>
+            </a:pPr>
+            <a:r>
+              <a:rPr lang="en-US" sz="1300" dirty="0">
+                <a:solidFill>
+                  <a:srgbClr val="16262E"/>
+                </a:solidFill>
+                <a:latin typeface="Calibri" pitchFamily="34" charset="0"/>
+                <a:ea typeface="Calibri" pitchFamily="34" charset="-122"/>
+                <a:cs typeface="Calibri" pitchFamily="34" charset="-120"/>
+              </a:rPr>
+              <a:t>Donde una práctica del curso diga «Copilot en Word», léela como «Copilot Chat con el archivo adjunto».</a:t>
+            </a:r>
+            <a:endParaRPr lang="en-US" sz="1300" dirty="0"/>
+          </a:p>
+          <a:p>
+            <a:pPr indent="0" marL="0">
+              <a:lnSpc>
+                <a:spcPct val="110000"/>
+              </a:lnSpc>
+              <a:spcAft>
+                <a:spcPts val="800"/>
+              </a:spcAft>
+              <a:buNone/>
+            </a:pPr>
+            <a:r>
+              <a:rPr lang="en-US" sz="1300" dirty="0">
+                <a:solidFill>
+                  <a:srgbClr val="16262E"/>
+                </a:solidFill>
+                <a:latin typeface="Calibri" pitchFamily="34" charset="0"/>
+                <a:ea typeface="Calibri" pitchFamily="34" charset="-122"/>
+                <a:cs typeface="Calibri" pitchFamily="34" charset="-120"/>
+              </a:rPr>
+              <a:t>Sin tu cuenta institucional, Copilot queda fuera del contrato: solo información verde.</a:t>
+            </a:r>
+            <a:endParaRPr lang="en-US" sz="1300" dirty="0"/>
+          </a:p>
+          <a:p>
+            <a:pPr indent="0" marL="0">
+              <a:lnSpc>
+                <a:spcPct val="110000"/>
+              </a:lnSpc>
+              <a:spcAft>
+                <a:spcPts val="800"/>
+              </a:spcAft>
+              <a:buNone/>
+            </a:pPr>
+            <a:r>
+              <a:rPr lang="en-US" sz="1300" dirty="0">
+                <a:solidFill>
+                  <a:srgbClr val="16262E"/>
+                </a:solidFill>
+                <a:latin typeface="Calibri" pitchFamily="34" charset="0"/>
+                <a:ea typeface="Calibri" pitchFamily="34" charset="-122"/>
+                <a:cs typeface="Calibri" pitchFamily="34" charset="-120"/>
+              </a:rPr>
+              <a:t>Outlook y Teams siguen funcionando igual que siempre: lo que no hay es el asistente adentro.</a:t>
+            </a:r>
+            <a:endParaRPr lang="en-US" sz="1300" dirty="0"/>
+          </a:p>
+        </p:txBody>
+      </p:sp>
+      <p:sp>
+        <p:nvSpPr>
+          <p:cNvPr id="10" name="Shape"/>
           <p:cNvSpPr/>
           <p:nvPr/>
         </p:nvSpPr>
         <p:spPr>
           <a:xfrm>
-            <a:off x="566928" y="1408176"/>
-            <a:ext cx="5364328" cy="1490472"/>
+            <a:off x="566928" y="5824728"/>
+            <a:ext cx="11057839" cy="594360"/>
           </a:xfrm>
           <a:prstGeom prst="roundRect">
             <a:avLst>
-              <a:gd name="adj" fmla="val 4294"/>
+              <a:gd name="adj" fmla="val 8235"/>
+            </a:avLst>
+          </a:prstGeom>
+          <a:solidFill>
+            <a:srgbClr val="F7E4D8"/>
+          </a:solidFill>
+          <a:ln w="12700">
+            <a:solidFill>
+              <a:srgbClr val="F7E4D8"/>
+            </a:solidFill>
+            <a:prstDash val="solid"/>
+          </a:ln>
+        </p:spPr>
+      </p:sp>
+      <p:sp>
+        <p:nvSpPr>
+          <p:cNvPr id="11" name="Text"/>
+          <p:cNvSpPr txBox="1"/>
+          <p:nvPr/>
+        </p:nvSpPr>
+        <p:spPr>
+          <a:xfrm>
+            <a:off x="804672" y="5824728"/>
+            <a:ext cx="10582351" cy="594360"/>
+          </a:xfrm>
+          <a:prstGeom prst="rect">
+            <a:avLst/>
+          </a:prstGeom>
+          <a:noFill/>
+          <a:ln/>
+        </p:spPr>
+        <p:txBody>
+          <a:bodyPr wrap="square" lIns="0" tIns="0" rIns="0" bIns="0" rtlCol="0" anchor="ctr"/>
+          <a:lstStyle/>
+          <a:p>
+            <a:pPr indent="0" marL="0">
+              <a:lnSpc>
+                <a:spcPct val="110000"/>
+              </a:lnSpc>
+              <a:buNone/>
+            </a:pPr>
+            <a:r>
+              <a:rPr lang="en-US" sz="1300" dirty="0">
+                <a:solidFill>
+                  <a:srgbClr val="16262E"/>
+                </a:solidFill>
+                <a:latin typeface="Calibri" pitchFamily="34" charset="0"/>
+                <a:ea typeface="Calibri" pitchFamily="34" charset="-122"/>
+                <a:cs typeface="Calibri" pitchFamily="34" charset="-120"/>
+              </a:rPr>
+              <a:t>El semáforo no cambia: verde en cualquier herramienta, amarillo solo en Copilot Chat con tu cuenta del Instituto, y rojo en ninguna.</a:t>
+            </a:r>
+            <a:endParaRPr lang="en-US" sz="1300" dirty="0"/>
+          </a:p>
+        </p:txBody>
+      </p:sp>
+    </p:spTree>
+  </p:cSld>
+  <p:clrMapOvr>
+    <a:masterClrMapping/>
+  </p:clrMapOvr>
+</p:sld>
+</file>
+
+<file path=ppt/slides/slide17.xml><?xml version="1.0" encoding="utf-8"?>
+<p:sld xmlns:a="http://schemas.openxmlformats.org/drawingml/2006/main" xmlns:r="http://schemas.openxmlformats.org/officeDocument/2006/relationships" xmlns:p="http://schemas.openxmlformats.org/presentationml/2006/main">
+  <p:cSld name="Calentamiento anclaje">
+    <p:bg>
+      <p:bgPr>
+        <a:solidFill>
+          <a:srgbClr val="D7E7E7"/>
+        </a:solidFill>
+        <a:effectLst/>
+      </p:bgPr>
+    </p:bg>
+    <p:spTree>
+      <p:nvGrpSpPr>
+        <p:cNvPr id="1" name=""/>
+        <p:cNvGrpSpPr/>
+        <p:nvPr/>
+      </p:nvGrpSpPr>
+      <p:grpSpPr>
+        <a:xfrm>
+          <a:off x="0" y="0"/>
+          <a:ext cx="0" cy="0"/>
+          <a:chOff x="0" y="0"/>
+          <a:chExt cx="0" cy="0"/>
+        </a:xfrm>
+      </p:grpSpPr>
+      <p:sp>
+        <p:nvSpPr>
+          <p:cNvPr id="2" name="Shape"/>
+          <p:cNvSpPr/>
+          <p:nvPr/>
+        </p:nvSpPr>
+        <p:spPr>
+          <a:xfrm>
+            <a:off x="566928" y="457200"/>
+            <a:ext cx="2788920" cy="457200"/>
+          </a:xfrm>
+          <a:prstGeom prst="roundRect">
+            <a:avLst>
+              <a:gd name="adj" fmla="val 50000"/>
+            </a:avLst>
+          </a:prstGeom>
+          <a:solidFill>
+            <a:srgbClr val="2E7D7D"/>
+          </a:solidFill>
+          <a:ln w="12700">
+            <a:solidFill>
+              <a:srgbClr val="2E7D7D"/>
+            </a:solidFill>
+            <a:prstDash val="solid"/>
+          </a:ln>
+        </p:spPr>
+      </p:sp>
+      <p:sp>
+        <p:nvSpPr>
+          <p:cNvPr id="3" name="Text"/>
+          <p:cNvSpPr txBox="1"/>
+          <p:nvPr/>
+        </p:nvSpPr>
+        <p:spPr>
+          <a:xfrm>
+            <a:off x="566928" y="457200"/>
+            <a:ext cx="2788920" cy="457200"/>
+          </a:xfrm>
+          <a:prstGeom prst="rect">
+            <a:avLst/>
+          </a:prstGeom>
+          <a:noFill/>
+          <a:ln/>
+        </p:spPr>
+        <p:txBody>
+          <a:bodyPr wrap="square" lIns="0" tIns="0" rIns="0" bIns="0" rtlCol="0" anchor="ctr"/>
+          <a:lstStyle/>
+          <a:p>
+            <a:pPr algn="ctr" indent="0" marL="0">
+              <a:buNone/>
+            </a:pPr>
+            <a:r>
+              <a:rPr lang="en-US" sz="1300" b="1" spc="200" kern="0" dirty="0">
+                <a:solidFill>
+                  <a:srgbClr val="FFFFFF"/>
+                </a:solidFill>
+                <a:latin typeface="Arial" pitchFamily="34" charset="0"/>
+                <a:ea typeface="Arial" pitchFamily="34" charset="-122"/>
+                <a:cs typeface="Arial" pitchFamily="34" charset="-120"/>
+              </a:rPr>
+              <a:t>TU TURNO</a:t>
+            </a:r>
+            <a:endParaRPr lang="en-US" sz="1300" dirty="0"/>
+          </a:p>
+        </p:txBody>
+      </p:sp>
+      <p:sp>
+        <p:nvSpPr>
+          <p:cNvPr id="4" name="Shape"/>
+          <p:cNvSpPr/>
+          <p:nvPr/>
+        </p:nvSpPr>
+        <p:spPr>
+          <a:xfrm>
+            <a:off x="9704527" y="457200"/>
+            <a:ext cx="1920240" cy="457200"/>
+          </a:xfrm>
+          <a:prstGeom prst="roundRect">
+            <a:avLst>
+              <a:gd name="adj" fmla="val 50000"/>
+            </a:avLst>
+          </a:prstGeom>
+          <a:solidFill>
+            <a:srgbClr val="C85A28"/>
+          </a:solidFill>
+          <a:ln w="12700">
+            <a:solidFill>
+              <a:srgbClr val="C85A28"/>
+            </a:solidFill>
+            <a:prstDash val="solid"/>
+          </a:ln>
+        </p:spPr>
+      </p:sp>
+      <p:sp>
+        <p:nvSpPr>
+          <p:cNvPr id="5" name="Text"/>
+          <p:cNvSpPr txBox="1"/>
+          <p:nvPr/>
+        </p:nvSpPr>
+        <p:spPr>
+          <a:xfrm>
+            <a:off x="9704527" y="457200"/>
+            <a:ext cx="1920240" cy="457200"/>
+          </a:xfrm>
+          <a:prstGeom prst="rect">
+            <a:avLst/>
+          </a:prstGeom>
+          <a:noFill/>
+          <a:ln/>
+        </p:spPr>
+        <p:txBody>
+          <a:bodyPr wrap="square" lIns="0" tIns="0" rIns="0" bIns="0" rtlCol="0" anchor="ctr"/>
+          <a:lstStyle/>
+          <a:p>
+            <a:pPr algn="ctr" indent="0" marL="0">
+              <a:buNone/>
+            </a:pPr>
+            <a:r>
+              <a:rPr lang="en-US" sz="1300" b="1" dirty="0">
+                <a:solidFill>
+                  <a:srgbClr val="FFFFFF"/>
+                </a:solidFill>
+                <a:latin typeface="Arial" pitchFamily="34" charset="0"/>
+                <a:ea typeface="Arial" pitchFamily="34" charset="-122"/>
+                <a:cs typeface="Arial" pitchFamily="34" charset="-120"/>
+              </a:rPr>
+              <a:t>18 minutos</a:t>
+            </a:r>
+            <a:endParaRPr lang="en-US" sz="1300" dirty="0"/>
+          </a:p>
+        </p:txBody>
+      </p:sp>
+      <p:sp>
+        <p:nvSpPr>
+          <p:cNvPr id="6" name="Text"/>
+          <p:cNvSpPr txBox="1"/>
+          <p:nvPr/>
+        </p:nvSpPr>
+        <p:spPr>
+          <a:xfrm>
+            <a:off x="566928" y="1078992"/>
+            <a:ext cx="11057839" cy="685800"/>
+          </a:xfrm>
+          <a:prstGeom prst="rect">
+            <a:avLst/>
+          </a:prstGeom>
+          <a:noFill/>
+          <a:ln/>
+        </p:spPr>
+        <p:txBody>
+          <a:bodyPr wrap="square" lIns="0" tIns="0" rIns="0" bIns="0" rtlCol="0" anchor="ctr"/>
+          <a:lstStyle/>
+          <a:p>
+            <a:pPr indent="0" marL="0">
+              <a:buNone/>
+            </a:pPr>
+            <a:r>
+              <a:rPr lang="en-US" sz="2900" b="1" dirty="0">
+                <a:solidFill>
+                  <a:srgbClr val="16262E"/>
+                </a:solidFill>
+                <a:latin typeface="Arial" pitchFamily="34" charset="0"/>
+                <a:ea typeface="Arial" pitchFamily="34" charset="-122"/>
+                <a:cs typeface="Arial" pitchFamily="34" charset="-120"/>
+              </a:rPr>
+              <a:t>Tu documento, tu tabla, tu verificación</a:t>
+            </a:r>
+            <a:endParaRPr lang="en-US" sz="2900" dirty="0"/>
+          </a:p>
+        </p:txBody>
+      </p:sp>
+      <p:sp>
+        <p:nvSpPr>
+          <p:cNvPr id="7" name="Shape"/>
+          <p:cNvSpPr/>
+          <p:nvPr/>
+        </p:nvSpPr>
+        <p:spPr>
+          <a:xfrm>
+            <a:off x="566928" y="1920240"/>
+            <a:ext cx="11057839" cy="628650"/>
+          </a:xfrm>
+          <a:prstGeom prst="roundRect">
+            <a:avLst>
+              <a:gd name="adj" fmla="val 10182"/>
+            </a:avLst>
+          </a:prstGeom>
+          <a:solidFill>
+            <a:srgbClr val="FFFFFF"/>
+          </a:solidFill>
+          <a:ln w="12700">
+            <a:solidFill>
+              <a:srgbClr val="FFFFFF"/>
+            </a:solidFill>
+            <a:prstDash val="solid"/>
+          </a:ln>
+        </p:spPr>
+      </p:sp>
+      <p:sp>
+        <p:nvSpPr>
+          <p:cNvPr id="8" name="Shape"/>
+          <p:cNvSpPr/>
+          <p:nvPr/>
+        </p:nvSpPr>
+        <p:spPr>
+          <a:xfrm>
+            <a:off x="786384" y="2024253"/>
+            <a:ext cx="420624" cy="420624"/>
+          </a:xfrm>
+          <a:prstGeom prst="ellipse">
+            <a:avLst/>
+          </a:prstGeom>
+          <a:solidFill>
+            <a:srgbClr val="2E7D7D"/>
+          </a:solidFill>
+          <a:ln w="12700">
+            <a:solidFill>
+              <a:srgbClr val="2E7D7D"/>
+            </a:solidFill>
+            <a:prstDash val="solid"/>
+          </a:ln>
+        </p:spPr>
+      </p:sp>
+      <p:sp>
+        <p:nvSpPr>
+          <p:cNvPr id="9" name="Text"/>
+          <p:cNvSpPr txBox="1"/>
+          <p:nvPr/>
+        </p:nvSpPr>
+        <p:spPr>
+          <a:xfrm>
+            <a:off x="786384" y="2024253"/>
+            <a:ext cx="420624" cy="420624"/>
+          </a:xfrm>
+          <a:prstGeom prst="rect">
+            <a:avLst/>
+          </a:prstGeom>
+          <a:noFill/>
+          <a:ln/>
+        </p:spPr>
+        <p:txBody>
+          <a:bodyPr wrap="square" lIns="0" tIns="0" rIns="0" bIns="0" rtlCol="0" anchor="ctr"/>
+          <a:lstStyle/>
+          <a:p>
+            <a:pPr algn="ctr" indent="0" marL="0">
+              <a:buNone/>
+            </a:pPr>
+            <a:r>
+              <a:rPr lang="en-US" sz="1400" b="1" dirty="0">
+                <a:solidFill>
+                  <a:srgbClr val="FFFFFF"/>
+                </a:solidFill>
+                <a:latin typeface="Arial" pitchFamily="34" charset="0"/>
+                <a:ea typeface="Arial" pitchFamily="34" charset="-122"/>
+                <a:cs typeface="Arial" pitchFamily="34" charset="-120"/>
+              </a:rPr>
+              <a:t>1</a:t>
+            </a:r>
+            <a:endParaRPr lang="en-US" sz="1400" dirty="0"/>
+          </a:p>
+        </p:txBody>
+      </p:sp>
+      <p:sp>
+        <p:nvSpPr>
+          <p:cNvPr id="10" name="Text"/>
+          <p:cNvSpPr txBox="1"/>
+          <p:nvPr/>
+        </p:nvSpPr>
+        <p:spPr>
+          <a:xfrm>
+            <a:off x="1408176" y="2011680"/>
+            <a:ext cx="9960559" cy="445770"/>
+          </a:xfrm>
+          <a:prstGeom prst="rect">
+            <a:avLst/>
+          </a:prstGeom>
+          <a:noFill/>
+          <a:ln/>
+        </p:spPr>
+        <p:txBody>
+          <a:bodyPr wrap="square" lIns="0" tIns="0" rIns="0" bIns="0" rtlCol="0" anchor="ctr"/>
+          <a:lstStyle/>
+          <a:p>
+            <a:pPr indent="0" marL="0">
+              <a:lnSpc>
+                <a:spcPct val="110000"/>
+              </a:lnSpc>
+              <a:buNone/>
+            </a:pPr>
+            <a:r>
+              <a:rPr lang="en-US" sz="1450" dirty="0">
+                <a:solidFill>
+                  <a:srgbClr val="16262E"/>
+                </a:solidFill>
+                <a:latin typeface="Calibri" pitchFamily="34" charset="0"/>
+                <a:ea typeface="Calibri" pitchFamily="34" charset="-122"/>
+                <a:cs typeface="Calibri" pitchFamily="34" charset="-120"/>
+              </a:rPr>
+              <a:t>Abre Copilot Chat con tu cuenta del Instituto y adjunta tu documento normativo: súbelo directo o referéncialo desde OneDrive.</a:t>
+            </a:r>
+            <a:endParaRPr lang="en-US" sz="1450" dirty="0"/>
+          </a:p>
+        </p:txBody>
+      </p:sp>
+      <p:sp>
+        <p:nvSpPr>
+          <p:cNvPr id="11" name="Shape"/>
+          <p:cNvSpPr/>
+          <p:nvPr/>
+        </p:nvSpPr>
+        <p:spPr>
+          <a:xfrm>
+            <a:off x="566928" y="2731770"/>
+            <a:ext cx="11057839" cy="628650"/>
+          </a:xfrm>
+          <a:prstGeom prst="roundRect">
+            <a:avLst>
+              <a:gd name="adj" fmla="val 10182"/>
+            </a:avLst>
+          </a:prstGeom>
+          <a:solidFill>
+            <a:srgbClr val="FFFFFF"/>
+          </a:solidFill>
+          <a:ln w="12700">
+            <a:solidFill>
+              <a:srgbClr val="FFFFFF"/>
+            </a:solidFill>
+            <a:prstDash val="solid"/>
+          </a:ln>
+        </p:spPr>
+      </p:sp>
+      <p:sp>
+        <p:nvSpPr>
+          <p:cNvPr id="12" name="Shape"/>
+          <p:cNvSpPr/>
+          <p:nvPr/>
+        </p:nvSpPr>
+        <p:spPr>
+          <a:xfrm>
+            <a:off x="786384" y="2835783"/>
+            <a:ext cx="420624" cy="420624"/>
+          </a:xfrm>
+          <a:prstGeom prst="ellipse">
+            <a:avLst/>
+          </a:prstGeom>
+          <a:solidFill>
+            <a:srgbClr val="2E7D7D"/>
+          </a:solidFill>
+          <a:ln w="12700">
+            <a:solidFill>
+              <a:srgbClr val="2E7D7D"/>
+            </a:solidFill>
+            <a:prstDash val="solid"/>
+          </a:ln>
+        </p:spPr>
+      </p:sp>
+      <p:sp>
+        <p:nvSpPr>
+          <p:cNvPr id="13" name="Text"/>
+          <p:cNvSpPr txBox="1"/>
+          <p:nvPr/>
+        </p:nvSpPr>
+        <p:spPr>
+          <a:xfrm>
+            <a:off x="786384" y="2835783"/>
+            <a:ext cx="420624" cy="420624"/>
+          </a:xfrm>
+          <a:prstGeom prst="rect">
+            <a:avLst/>
+          </a:prstGeom>
+          <a:noFill/>
+          <a:ln/>
+        </p:spPr>
+        <p:txBody>
+          <a:bodyPr wrap="square" lIns="0" tIns="0" rIns="0" bIns="0" rtlCol="0" anchor="ctr"/>
+          <a:lstStyle/>
+          <a:p>
+            <a:pPr algn="ctr" indent="0" marL="0">
+              <a:buNone/>
+            </a:pPr>
+            <a:r>
+              <a:rPr lang="en-US" sz="1400" b="1" dirty="0">
+                <a:solidFill>
+                  <a:srgbClr val="FFFFFF"/>
+                </a:solidFill>
+                <a:latin typeface="Arial" pitchFamily="34" charset="0"/>
+                <a:ea typeface="Arial" pitchFamily="34" charset="-122"/>
+                <a:cs typeface="Arial" pitchFamily="34" charset="-120"/>
+              </a:rPr>
+              <a:t>2</a:t>
+            </a:r>
+            <a:endParaRPr lang="en-US" sz="1400" dirty="0"/>
+          </a:p>
+        </p:txBody>
+      </p:sp>
+      <p:sp>
+        <p:nvSpPr>
+          <p:cNvPr id="14" name="Text"/>
+          <p:cNvSpPr txBox="1"/>
+          <p:nvPr/>
+        </p:nvSpPr>
+        <p:spPr>
+          <a:xfrm>
+            <a:off x="1408176" y="2823210"/>
+            <a:ext cx="9960559" cy="445770"/>
+          </a:xfrm>
+          <a:prstGeom prst="rect">
+            <a:avLst/>
+          </a:prstGeom>
+          <a:noFill/>
+          <a:ln/>
+        </p:spPr>
+        <p:txBody>
+          <a:bodyPr wrap="square" lIns="0" tIns="0" rIns="0" bIns="0" rtlCol="0" anchor="ctr"/>
+          <a:lstStyle/>
+          <a:p>
+            <a:pPr indent="0" marL="0">
+              <a:lnSpc>
+                <a:spcPct val="110000"/>
+              </a:lnSpc>
+              <a:buNone/>
+            </a:pPr>
+            <a:r>
+              <a:rPr lang="en-US" sz="1450" dirty="0">
+                <a:solidFill>
+                  <a:srgbClr val="16262E"/>
+                </a:solidFill>
+                <a:latin typeface="Calibri" pitchFamily="34" charset="0"/>
+                <a:ea typeface="Calibri" pitchFamily="34" charset="-122"/>
+                <a:cs typeface="Calibri" pitchFamily="34" charset="-120"/>
+              </a:rPr>
+              <a:t>Corre el prompt completo de la sección 2 del handout del martes: la tabla con la sección de donde salió cada dato.</a:t>
+            </a:r>
+            <a:endParaRPr lang="en-US" sz="1450" dirty="0"/>
+          </a:p>
+        </p:txBody>
+      </p:sp>
+      <p:sp>
+        <p:nvSpPr>
+          <p:cNvPr id="15" name="Shape"/>
+          <p:cNvSpPr/>
+          <p:nvPr/>
+        </p:nvSpPr>
+        <p:spPr>
+          <a:xfrm>
+            <a:off x="566928" y="3543300"/>
+            <a:ext cx="11057839" cy="628650"/>
+          </a:xfrm>
+          <a:prstGeom prst="roundRect">
+            <a:avLst>
+              <a:gd name="adj" fmla="val 10182"/>
+            </a:avLst>
+          </a:prstGeom>
+          <a:solidFill>
+            <a:srgbClr val="FFFFFF"/>
+          </a:solidFill>
+          <a:ln w="12700">
+            <a:solidFill>
+              <a:srgbClr val="FFFFFF"/>
+            </a:solidFill>
+            <a:prstDash val="solid"/>
+          </a:ln>
+        </p:spPr>
+      </p:sp>
+      <p:sp>
+        <p:nvSpPr>
+          <p:cNvPr id="16" name="Shape"/>
+          <p:cNvSpPr/>
+          <p:nvPr/>
+        </p:nvSpPr>
+        <p:spPr>
+          <a:xfrm>
+            <a:off x="786384" y="3647313"/>
+            <a:ext cx="420624" cy="420624"/>
+          </a:xfrm>
+          <a:prstGeom prst="ellipse">
+            <a:avLst/>
+          </a:prstGeom>
+          <a:solidFill>
+            <a:srgbClr val="2E7D7D"/>
+          </a:solidFill>
+          <a:ln w="12700">
+            <a:solidFill>
+              <a:srgbClr val="2E7D7D"/>
+            </a:solidFill>
+            <a:prstDash val="solid"/>
+          </a:ln>
+        </p:spPr>
+      </p:sp>
+      <p:sp>
+        <p:nvSpPr>
+          <p:cNvPr id="17" name="Text"/>
+          <p:cNvSpPr txBox="1"/>
+          <p:nvPr/>
+        </p:nvSpPr>
+        <p:spPr>
+          <a:xfrm>
+            <a:off x="786384" y="3647313"/>
+            <a:ext cx="420624" cy="420624"/>
+          </a:xfrm>
+          <a:prstGeom prst="rect">
+            <a:avLst/>
+          </a:prstGeom>
+          <a:noFill/>
+          <a:ln/>
+        </p:spPr>
+        <p:txBody>
+          <a:bodyPr wrap="square" lIns="0" tIns="0" rIns="0" bIns="0" rtlCol="0" anchor="ctr"/>
+          <a:lstStyle/>
+          <a:p>
+            <a:pPr algn="ctr" indent="0" marL="0">
+              <a:buNone/>
+            </a:pPr>
+            <a:r>
+              <a:rPr lang="en-US" sz="1400" b="1" dirty="0">
+                <a:solidFill>
+                  <a:srgbClr val="FFFFFF"/>
+                </a:solidFill>
+                <a:latin typeface="Arial" pitchFamily="34" charset="0"/>
+                <a:ea typeface="Arial" pitchFamily="34" charset="-122"/>
+                <a:cs typeface="Arial" pitchFamily="34" charset="-120"/>
+              </a:rPr>
+              <a:t>3</a:t>
+            </a:r>
+            <a:endParaRPr lang="en-US" sz="1400" dirty="0"/>
+          </a:p>
+        </p:txBody>
+      </p:sp>
+      <p:sp>
+        <p:nvSpPr>
+          <p:cNvPr id="18" name="Text"/>
+          <p:cNvSpPr txBox="1"/>
+          <p:nvPr/>
+        </p:nvSpPr>
+        <p:spPr>
+          <a:xfrm>
+            <a:off x="1408176" y="3634740"/>
+            <a:ext cx="9960559" cy="445770"/>
+          </a:xfrm>
+          <a:prstGeom prst="rect">
+            <a:avLst/>
+          </a:prstGeom>
+          <a:noFill/>
+          <a:ln/>
+        </p:spPr>
+        <p:txBody>
+          <a:bodyPr wrap="square" lIns="0" tIns="0" rIns="0" bIns="0" rtlCol="0" anchor="ctr"/>
+          <a:lstStyle/>
+          <a:p>
+            <a:pPr indent="0" marL="0">
+              <a:lnSpc>
+                <a:spcPct val="110000"/>
+              </a:lnSpc>
+              <a:buNone/>
+            </a:pPr>
+            <a:r>
+              <a:rPr lang="en-US" sz="1450" dirty="0">
+                <a:solidFill>
+                  <a:srgbClr val="16262E"/>
+                </a:solidFill>
+                <a:latin typeface="Calibri" pitchFamily="34" charset="0"/>
+                <a:ea typeface="Calibri" pitchFamily="34" charset="-122"/>
+                <a:cs typeface="Calibri" pitchFamily="34" charset="-120"/>
+              </a:rPr>
+              <a:t>Elige tres celdas al azar y búscalas en el documento original. Anota cuántas de las tres coincidían.</a:t>
+            </a:r>
+            <a:endParaRPr lang="en-US" sz="1450" dirty="0"/>
+          </a:p>
+        </p:txBody>
+      </p:sp>
+      <p:sp>
+        <p:nvSpPr>
+          <p:cNvPr id="19" name="Shape"/>
+          <p:cNvSpPr/>
+          <p:nvPr/>
+        </p:nvSpPr>
+        <p:spPr>
+          <a:xfrm>
+            <a:off x="566928" y="4354830"/>
+            <a:ext cx="11057839" cy="628650"/>
+          </a:xfrm>
+          <a:prstGeom prst="roundRect">
+            <a:avLst>
+              <a:gd name="adj" fmla="val 10182"/>
+            </a:avLst>
+          </a:prstGeom>
+          <a:solidFill>
+            <a:srgbClr val="FFFFFF"/>
+          </a:solidFill>
+          <a:ln w="12700">
+            <a:solidFill>
+              <a:srgbClr val="FFFFFF"/>
+            </a:solidFill>
+            <a:prstDash val="solid"/>
+          </a:ln>
+        </p:spPr>
+      </p:sp>
+      <p:sp>
+        <p:nvSpPr>
+          <p:cNvPr id="20" name="Shape"/>
+          <p:cNvSpPr/>
+          <p:nvPr/>
+        </p:nvSpPr>
+        <p:spPr>
+          <a:xfrm>
+            <a:off x="786384" y="4458843"/>
+            <a:ext cx="420624" cy="420624"/>
+          </a:xfrm>
+          <a:prstGeom prst="ellipse">
+            <a:avLst/>
+          </a:prstGeom>
+          <a:solidFill>
+            <a:srgbClr val="2E7D7D"/>
+          </a:solidFill>
+          <a:ln w="12700">
+            <a:solidFill>
+              <a:srgbClr val="2E7D7D"/>
+            </a:solidFill>
+            <a:prstDash val="solid"/>
+          </a:ln>
+        </p:spPr>
+      </p:sp>
+      <p:sp>
+        <p:nvSpPr>
+          <p:cNvPr id="21" name="Text"/>
+          <p:cNvSpPr txBox="1"/>
+          <p:nvPr/>
+        </p:nvSpPr>
+        <p:spPr>
+          <a:xfrm>
+            <a:off x="786384" y="4458843"/>
+            <a:ext cx="420624" cy="420624"/>
+          </a:xfrm>
+          <a:prstGeom prst="rect">
+            <a:avLst/>
+          </a:prstGeom>
+          <a:noFill/>
+          <a:ln/>
+        </p:spPr>
+        <p:txBody>
+          <a:bodyPr wrap="square" lIns="0" tIns="0" rIns="0" bIns="0" rtlCol="0" anchor="ctr"/>
+          <a:lstStyle/>
+          <a:p>
+            <a:pPr algn="ctr" indent="0" marL="0">
+              <a:buNone/>
+            </a:pPr>
+            <a:r>
+              <a:rPr lang="en-US" sz="1400" b="1" dirty="0">
+                <a:solidFill>
+                  <a:srgbClr val="FFFFFF"/>
+                </a:solidFill>
+                <a:latin typeface="Arial" pitchFamily="34" charset="0"/>
+                <a:ea typeface="Arial" pitchFamily="34" charset="-122"/>
+                <a:cs typeface="Arial" pitchFamily="34" charset="-120"/>
+              </a:rPr>
+              <a:t>4</a:t>
+            </a:r>
+            <a:endParaRPr lang="en-US" sz="1400" dirty="0"/>
+          </a:p>
+        </p:txBody>
+      </p:sp>
+      <p:sp>
+        <p:nvSpPr>
+          <p:cNvPr id="22" name="Text"/>
+          <p:cNvSpPr txBox="1"/>
+          <p:nvPr/>
+        </p:nvSpPr>
+        <p:spPr>
+          <a:xfrm>
+            <a:off x="1408176" y="4446270"/>
+            <a:ext cx="9960559" cy="445770"/>
+          </a:xfrm>
+          <a:prstGeom prst="rect">
+            <a:avLst/>
+          </a:prstGeom>
+          <a:noFill/>
+          <a:ln/>
+        </p:spPr>
+        <p:txBody>
+          <a:bodyPr wrap="square" lIns="0" tIns="0" rIns="0" bIns="0" rtlCol="0" anchor="ctr"/>
+          <a:lstStyle/>
+          <a:p>
+            <a:pPr indent="0" marL="0">
+              <a:lnSpc>
+                <a:spcPct val="110000"/>
+              </a:lnSpc>
+              <a:buNone/>
+            </a:pPr>
+            <a:r>
+              <a:rPr lang="en-US" sz="1450" dirty="0">
+                <a:solidFill>
+                  <a:srgbClr val="16262E"/>
+                </a:solidFill>
+                <a:latin typeface="Calibri" pitchFamily="34" charset="0"/>
+                <a:ea typeface="Calibri" pitchFamily="34" charset="-122"/>
+                <a:cs typeface="Calibri" pitchFamily="34" charset="-120"/>
+              </a:rPr>
+              <a:t>Registra el prompt y el resultado en tu bitácora. ¿Tres de tres? Verifica otras tres: un seis de seis es raro.</a:t>
+            </a:r>
+            <a:endParaRPr lang="en-US" sz="1450" dirty="0"/>
+          </a:p>
+        </p:txBody>
+      </p:sp>
+      <p:sp>
+        <p:nvSpPr>
+          <p:cNvPr id="23" name="Shape"/>
+          <p:cNvSpPr/>
+          <p:nvPr/>
+        </p:nvSpPr>
+        <p:spPr>
+          <a:xfrm>
+            <a:off x="566928" y="5193792"/>
+            <a:ext cx="11057839" cy="777240"/>
+          </a:xfrm>
+          <a:prstGeom prst="roundRect">
+            <a:avLst>
+              <a:gd name="adj" fmla="val 8235"/>
+            </a:avLst>
+          </a:prstGeom>
+          <a:solidFill>
+            <a:srgbClr val="16262E"/>
+          </a:solidFill>
+          <a:ln w="12700">
+            <a:solidFill>
+              <a:srgbClr val="16262E"/>
+            </a:solidFill>
+            <a:prstDash val="solid"/>
+          </a:ln>
+        </p:spPr>
+      </p:sp>
+      <p:sp>
+        <p:nvSpPr>
+          <p:cNvPr id="24" name="Text"/>
+          <p:cNvSpPr txBox="1"/>
+          <p:nvPr/>
+        </p:nvSpPr>
+        <p:spPr>
+          <a:xfrm>
+            <a:off x="841248" y="5193792"/>
+            <a:ext cx="10509199" cy="777240"/>
+          </a:xfrm>
+          <a:prstGeom prst="rect">
+            <a:avLst/>
+          </a:prstGeom>
+          <a:noFill/>
+          <a:ln/>
+        </p:spPr>
+        <p:txBody>
+          <a:bodyPr wrap="square" lIns="0" tIns="0" rIns="0" bIns="0" rtlCol="0" anchor="ctr"/>
+          <a:lstStyle/>
+          <a:p>
+            <a:pPr indent="0" marL="0">
+              <a:lnSpc>
+                <a:spcPct val="110000"/>
+              </a:lnSpc>
+              <a:buNone/>
+            </a:pPr>
+            <a:r>
+              <a:rPr lang="en-US" sz="1350" dirty="0">
+                <a:solidFill>
+                  <a:srgbClr val="FFFFFF"/>
+                </a:solidFill>
+                <a:latin typeface="Calibri" pitchFamily="34" charset="0"/>
+                <a:ea typeface="Calibri" pitchFamily="34" charset="-122"/>
+                <a:cs typeface="Calibri" pitchFamily="34" charset="-120"/>
+              </a:rPr>
+              <a:t>Era la práctica pendiente del martes y es el paso Traza del protocolo de hoy, antes de ponerle nombre. Casi siempre aparece al menos un error: encontrarlo es el punto.</a:t>
+            </a:r>
+            <a:endParaRPr lang="en-US" sz="1350" dirty="0"/>
+          </a:p>
+        </p:txBody>
+      </p:sp>
+    </p:spTree>
+  </p:cSld>
+  <p:clrMapOvr>
+    <a:masterClrMapping/>
+  </p:clrMapOvr>
+</p:sld>
+</file>
+
+<file path=ppt/slides/slide18.xml><?xml version="1.0" encoding="utf-8"?>
+<p:sld xmlns:a="http://schemas.openxmlformats.org/drawingml/2006/main" xmlns:r="http://schemas.openxmlformats.org/officeDocument/2006/relationships" xmlns:p="http://schemas.openxmlformats.org/presentationml/2006/main">
+  <p:cSld name="Receso equipos">
+    <p:bg>
+      <p:bgPr>
+        <a:solidFill>
+          <a:srgbClr val="16262E"/>
+        </a:solidFill>
+        <a:effectLst/>
+      </p:bgPr>
+    </p:bg>
+    <p:spTree>
+      <p:nvGrpSpPr>
+        <p:cNvPr id="1" name=""/>
+        <p:cNvGrpSpPr/>
+        <p:nvPr/>
+      </p:nvGrpSpPr>
+      <p:grpSpPr>
+        <a:xfrm>
+          <a:off x="0" y="0"/>
+          <a:ext cx="0" cy="0"/>
+          <a:chOff x="0" y="0"/>
+          <a:chExt cx="0" cy="0"/>
+        </a:xfrm>
+      </p:grpSpPr>
+      <p:sp>
+        <p:nvSpPr>
+          <p:cNvPr id="2" name="Shape"/>
+          <p:cNvSpPr/>
+          <p:nvPr/>
+        </p:nvSpPr>
+        <p:spPr>
+          <a:xfrm>
+            <a:off x="566928" y="2331720"/>
+            <a:ext cx="1371600" cy="1371600"/>
+          </a:xfrm>
+          <a:prstGeom prst="ellipse">
+            <a:avLst/>
+          </a:prstGeom>
+          <a:solidFill>
+            <a:srgbClr val="2E7D7D"/>
+          </a:solidFill>
+          <a:ln w="12700">
+            <a:solidFill>
+              <a:srgbClr val="2E7D7D"/>
+            </a:solidFill>
+            <a:prstDash val="solid"/>
+          </a:ln>
+        </p:spPr>
+      </p:sp>
+      <p:sp>
+        <p:nvSpPr>
+          <p:cNvPr id="3" name="Text"/>
+          <p:cNvSpPr txBox="1"/>
+          <p:nvPr/>
+        </p:nvSpPr>
+        <p:spPr>
+          <a:xfrm>
+            <a:off x="566928" y="2331720"/>
+            <a:ext cx="1371600" cy="1371600"/>
+          </a:xfrm>
+          <a:prstGeom prst="rect">
+            <a:avLst/>
+          </a:prstGeom>
+          <a:noFill/>
+          <a:ln/>
+        </p:spPr>
+        <p:txBody>
+          <a:bodyPr wrap="square" lIns="0" tIns="0" rIns="0" bIns="0" rtlCol="0" anchor="ctr"/>
+          <a:lstStyle/>
+          <a:p>
+            <a:pPr algn="ctr" indent="0" marL="0">
+              <a:buNone/>
+            </a:pPr>
+            <a:r>
+              <a:rPr lang="en-US" sz="4400" b="1" dirty="0">
+                <a:solidFill>
+                  <a:srgbClr val="FFFFFF"/>
+                </a:solidFill>
+                <a:latin typeface="Arial" pitchFamily="34" charset="0"/>
+                <a:ea typeface="Arial" pitchFamily="34" charset="-122"/>
+                <a:cs typeface="Arial" pitchFamily="34" charset="-120"/>
+              </a:rPr>
+              <a:t>10</a:t>
+            </a:r>
+            <a:endParaRPr lang="en-US" sz="4400" dirty="0"/>
+          </a:p>
+        </p:txBody>
+      </p:sp>
+      <p:sp>
+        <p:nvSpPr>
+          <p:cNvPr id="4" name="Text"/>
+          <p:cNvSpPr txBox="1"/>
+          <p:nvPr/>
+        </p:nvSpPr>
+        <p:spPr>
+          <a:xfrm>
+            <a:off x="2487168" y="2331720"/>
+            <a:ext cx="8778240" cy="365760"/>
+          </a:xfrm>
+          <a:prstGeom prst="rect">
+            <a:avLst/>
+          </a:prstGeom>
+          <a:noFill/>
+          <a:ln/>
+        </p:spPr>
+        <p:txBody>
+          <a:bodyPr wrap="square" lIns="0" tIns="0" rIns="0" bIns="0" rtlCol="0" anchor="ctr"/>
+          <a:lstStyle/>
+          <a:p>
+            <a:pPr indent="0" marL="0">
+              <a:buNone/>
+            </a:pPr>
+            <a:r>
+              <a:rPr lang="en-US" sz="1400" b="1" spc="200" kern="0" dirty="0">
+                <a:solidFill>
+                  <a:srgbClr val="D7E7E7"/>
+                </a:solidFill>
+                <a:latin typeface="Calibri" pitchFamily="34" charset="0"/>
+                <a:ea typeface="Calibri" pitchFamily="34" charset="-122"/>
+                <a:cs typeface="Calibri" pitchFamily="34" charset="-120"/>
+              </a:rPr>
+              <a:t>MINUTOS DE RECESO Y EQUIPOS</a:t>
+            </a:r>
+            <a:endParaRPr lang="en-US" sz="1400" dirty="0"/>
+          </a:p>
+        </p:txBody>
+      </p:sp>
+      <p:sp>
+        <p:nvSpPr>
+          <p:cNvPr id="5" name="Text"/>
+          <p:cNvSpPr txBox="1"/>
+          <p:nvPr/>
+        </p:nvSpPr>
+        <p:spPr>
+          <a:xfrm>
+            <a:off x="2487168" y="2697480"/>
+            <a:ext cx="8961120" cy="1188720"/>
+          </a:xfrm>
+          <a:prstGeom prst="rect">
+            <a:avLst/>
+          </a:prstGeom>
+          <a:noFill/>
+          <a:ln/>
+        </p:spPr>
+        <p:txBody>
+          <a:bodyPr wrap="square" lIns="0" tIns="0" rIns="0" bIns="0" rtlCol="0" anchor="t"/>
+          <a:lstStyle/>
+          <a:p>
+            <a:pPr indent="0" marL="0">
+              <a:buNone/>
+            </a:pPr>
+            <a:r>
+              <a:rPr lang="en-US" sz="3400" b="1" dirty="0">
+                <a:solidFill>
+                  <a:srgbClr val="FFFFFF"/>
+                </a:solidFill>
+                <a:latin typeface="Arial" pitchFamily="34" charset="0"/>
+                <a:ea typeface="Arial" pitchFamily="34" charset="-122"/>
+                <a:cs typeface="Arial" pitchFamily="34" charset="-120"/>
+              </a:rPr>
+              <a:t>Formamos los seis equipos de cuatro</a:t>
+            </a:r>
+            <a:endParaRPr lang="en-US" sz="3400" dirty="0"/>
+          </a:p>
+        </p:txBody>
+      </p:sp>
+      <p:sp>
+        <p:nvSpPr>
+          <p:cNvPr id="6" name="Text"/>
+          <p:cNvSpPr txBox="1"/>
+          <p:nvPr/>
+        </p:nvSpPr>
+        <p:spPr>
+          <a:xfrm>
+            <a:off x="2487168" y="3990000"/>
+            <a:ext cx="8961120" cy="731520"/>
+          </a:xfrm>
+          <a:prstGeom prst="rect">
+            <a:avLst/>
+          </a:prstGeom>
+          <a:noFill/>
+          <a:ln/>
+        </p:spPr>
+        <p:txBody>
+          <a:bodyPr wrap="square" lIns="0" tIns="0" rIns="0" bIns="0" rtlCol="0" anchor="t"/>
+          <a:lstStyle/>
+          <a:p>
+            <a:pPr indent="0" marL="0">
+              <a:lnSpc>
+                <a:spcPct val="110000"/>
+              </a:lnSpc>
+              <a:buNone/>
+            </a:pPr>
+            <a:r>
+              <a:rPr lang="en-US" sz="1500" dirty="0">
+                <a:solidFill>
+                  <a:srgbClr val="D7E7E7"/>
+                </a:solidFill>
+                <a:latin typeface="Calibri" pitchFamily="34" charset="0"/>
+                <a:ea typeface="Calibri" pitchFamily="34" charset="-122"/>
+                <a:cs typeface="Calibri" pitchFamily="34" charset="-120"/>
+              </a:rPr>
+              <a:t>Cada equipo necesita al menos una persona que haya usado IA para programar. Según la encuesta de la sesión 1 hay al menos trece: alcanza y sobra.</a:t>
+            </a:r>
+            <a:endParaRPr lang="en-US" sz="1500" dirty="0"/>
+          </a:p>
+        </p:txBody>
+      </p:sp>
+      <p:sp>
+        <p:nvSpPr>
+          <p:cNvPr id="7" name="Shape"/>
+          <p:cNvSpPr/>
+          <p:nvPr/>
+        </p:nvSpPr>
+        <p:spPr>
+          <a:xfrm>
+            <a:off x="9338767" y="457200"/>
+            <a:ext cx="2286000" cy="347472"/>
+          </a:xfrm>
+          <a:prstGeom prst="roundRect">
+            <a:avLst>
+              <a:gd name="adj" fmla="val 50000"/>
+            </a:avLst>
+          </a:prstGeom>
+          <a:solidFill>
+            <a:srgbClr val="24404E"/>
+          </a:solidFill>
+          <a:ln w="12700">
+            <a:solidFill>
+              <a:srgbClr val="24404E"/>
+            </a:solidFill>
+            <a:prstDash val="solid"/>
+          </a:ln>
+        </p:spPr>
+      </p:sp>
+      <p:sp>
+        <p:nvSpPr>
+          <p:cNvPr id="8" name="Text"/>
+          <p:cNvSpPr txBox="1"/>
+          <p:nvPr/>
+        </p:nvSpPr>
+        <p:spPr>
+          <a:xfrm>
+            <a:off x="9338767" y="457200"/>
+            <a:ext cx="2286000" cy="347472"/>
+          </a:xfrm>
+          <a:prstGeom prst="rect">
+            <a:avLst/>
+          </a:prstGeom>
+          <a:noFill/>
+          <a:ln/>
+        </p:spPr>
+        <p:txBody>
+          <a:bodyPr wrap="square" lIns="0" tIns="0" rIns="0" bIns="0" rtlCol="0" anchor="ctr"/>
+          <a:lstStyle/>
+          <a:p>
+            <a:pPr algn="ctr" indent="0" marL="0">
+              <a:buNone/>
+            </a:pPr>
+            <a:r>
+              <a:rPr lang="en-US" sz="1300" b="1" dirty="0">
+                <a:solidFill>
+                  <a:srgbClr val="FFFFFF"/>
+                </a:solidFill>
+                <a:latin typeface="Arial" pitchFamily="34" charset="0"/>
+                <a:ea typeface="Arial" pitchFamily="34" charset="-122"/>
+                <a:cs typeface="Arial" pitchFamily="34" charset="-120"/>
+              </a:rPr>
+              <a:t>9:55 a 10:05</a:t>
+            </a:r>
+            <a:endParaRPr lang="en-US" sz="1300" dirty="0"/>
+          </a:p>
+        </p:txBody>
+      </p:sp>
+    </p:spTree>
+  </p:cSld>
+  <p:clrMapOvr>
+    <a:masterClrMapping/>
+  </p:clrMapOvr>
+</p:sld>
+</file>
+
+<file path=ppt/slides/slide2.xml><?xml version="1.0" encoding="utf-8"?>
+<p:sld xmlns:a="http://schemas.openxmlformats.org/drawingml/2006/main" xmlns:r="http://schemas.openxmlformats.org/officeDocument/2006/relationships" xmlns:p="http://schemas.openxmlformats.org/presentationml/2006/main">
+  <p:cSld name="Agenda">
+    <p:spTree>
+      <p:nvGrpSpPr>
+        <p:cNvPr id="1" name=""/>
+        <p:cNvGrpSpPr/>
+        <p:nvPr/>
+      </p:nvGrpSpPr>
+      <p:grpSpPr>
+        <a:xfrm>
+          <a:off x="0" y="0"/>
+          <a:ext cx="0" cy="0"/>
+          <a:chOff x="0" y="0"/>
+          <a:chExt cx="0" cy="0"/>
+        </a:xfrm>
+      </p:grpSpPr>
+      <p:sp>
+        <p:nvSpPr>
+          <p:cNvPr id="2" name="Text"/>
+          <p:cNvSpPr txBox="1"/>
+          <p:nvPr/>
+        </p:nvSpPr>
+        <p:spPr>
+          <a:xfrm>
+            <a:off x="566928" y="402336"/>
+            <a:ext cx="11057839" cy="749808"/>
+          </a:xfrm>
+          <a:prstGeom prst="rect">
+            <a:avLst/>
+          </a:prstGeom>
+          <a:noFill/>
+          <a:ln/>
+        </p:spPr>
+        <p:txBody>
+          <a:bodyPr wrap="square" lIns="0" tIns="0" rIns="0" bIns="0" rtlCol="0" anchor="t"/>
+          <a:lstStyle/>
+          <a:p>
+            <a:pPr algn="l" indent="0" marL="0">
+              <a:buNone/>
+            </a:pPr>
+            <a:r>
+              <a:rPr lang="en-US" sz="3200" b="1" dirty="0">
+                <a:solidFill>
+                  <a:srgbClr val="16262E"/>
+                </a:solidFill>
+                <a:latin typeface="Arial" pitchFamily="34" charset="0"/>
+                <a:ea typeface="Arial" pitchFamily="34" charset="-122"/>
+                <a:cs typeface="Arial" pitchFamily="34" charset="-120"/>
+              </a:rPr>
+              <a:t>Cómo vamos a usar los 150 minutos</a:t>
+            </a:r>
+            <a:endParaRPr lang="en-US" sz="3200" dirty="0"/>
+          </a:p>
+        </p:txBody>
+      </p:sp>
+      <p:sp>
+        <p:nvSpPr>
+          <p:cNvPr id="3" name="Shape"/>
+          <p:cNvSpPr/>
+          <p:nvPr/>
+        </p:nvSpPr>
+        <p:spPr>
+          <a:xfrm>
+            <a:off x="9485071" y="457200"/>
+            <a:ext cx="2139696" cy="347472"/>
+          </a:xfrm>
+          <a:prstGeom prst="roundRect">
+            <a:avLst>
+              <a:gd name="adj" fmla="val 50000"/>
             </a:avLst>
           </a:prstGeom>
           <a:solidFill>
@@ -6218,14 +8182,14 @@
       </p:sp>
       <p:sp>
         <p:nvSpPr>
-          <p:cNvPr id="6" name="Text 4"/>
-          <p:cNvSpPr txBox="1"/>
-          <p:nvPr/>
-        </p:nvSpPr>
-        <p:spPr>
-          <a:xfrm>
-            <a:off x="786384" y="1408176"/>
-            <a:ext cx="1371600" cy="1490472"/>
+          <p:cNvPr id="4" name="Text"/>
+          <p:cNvSpPr txBox="1"/>
+          <p:nvPr/>
+        </p:nvSpPr>
+        <p:spPr>
+          <a:xfrm>
+            <a:off x="9485071" y="457200"/>
+            <a:ext cx="2139696" cy="347472"/>
           </a:xfrm>
           <a:prstGeom prst="rect">
             <a:avLst/>
@@ -6237,80 +8201,38 @@
           <a:bodyPr wrap="square" lIns="0" tIns="0" rIns="0" bIns="0" rtlCol="0" anchor="ctr"/>
           <a:lstStyle/>
           <a:p>
-            <a:pPr indent="0" marL="0">
-              <a:buNone/>
-            </a:pPr>
-            <a:r>
-              <a:rPr lang="en-US" sz="1300" b="1" dirty="0">
-                <a:solidFill>
-                  <a:srgbClr val="2E7D7D"/>
-                </a:solidFill>
-                <a:latin typeface="Arial" pitchFamily="34" charset="0"/>
-                <a:ea typeface="Arial" pitchFamily="34" charset="-122"/>
-                <a:cs typeface="Arial" pitchFamily="34" charset="-120"/>
-              </a:rPr>
-              <a:t>9:00</a:t>
-            </a:r>
-            <a:endParaRPr lang="en-US" sz="1300" dirty="0"/>
-          </a:p>
-        </p:txBody>
-      </p:sp>
-      <p:sp>
-        <p:nvSpPr>
-          <p:cNvPr id="7" name="Text 5"/>
-          <p:cNvSpPr txBox="1"/>
-          <p:nvPr/>
-        </p:nvSpPr>
-        <p:spPr>
-          <a:xfrm>
-            <a:off x="2194560" y="1463040"/>
-            <a:ext cx="3517240" cy="1380744"/>
-          </a:xfrm>
-          <a:prstGeom prst="rect">
-            <a:avLst/>
-          </a:prstGeom>
-          <a:noFill/>
-          <a:ln/>
-        </p:spPr>
-        <p:txBody>
-          <a:bodyPr wrap="square" lIns="0" tIns="0" rIns="0" bIns="0" rtlCol="0" anchor="ctr"/>
-          <a:lstStyle/>
-          <a:p>
-            <a:pPr indent="0" marL="0">
-              <a:lnSpc>
-                <a:spcPct val="105000"/>
-              </a:lnSpc>
-              <a:buNone/>
-            </a:pPr>
-            <a:r>
-              <a:rPr lang="en-US" sz="1350" dirty="0">
-                <a:solidFill>
-                  <a:srgbClr val="16262E"/>
+            <a:pPr algn="ctr" indent="0" marL="0">
+              <a:buNone/>
+            </a:pPr>
+            <a:r>
+              <a:rPr lang="en-US" sz="1200" b="1" dirty="0">
+                <a:solidFill>
+                  <a:srgbClr val="5A6B73"/>
                 </a:solidFill>
                 <a:latin typeface="Calibri" pitchFamily="34" charset="0"/>
                 <a:ea typeface="Calibri" pitchFamily="34" charset="-122"/>
                 <a:cs typeface="Calibri" pitchFamily="34" charset="-120"/>
               </a:rPr>
-              <a:t>Los seis errores típicos, con ejemplos de estas sesiones</a:t>
-            </a:r>
-            <a:endParaRPr lang="en-US" sz="1350" dirty="0"/>
-          </a:p>
-        </p:txBody>
-      </p:sp>
-      <p:sp>
-        <p:nvSpPr>
-          <p:cNvPr id="8" name="Shape 6"/>
+              <a:t>9:00 a 11:30</a:t>
+            </a:r>
+            <a:endParaRPr lang="en-US" sz="1200" dirty="0"/>
+          </a:p>
+        </p:txBody>
+      </p:sp>
+      <p:sp>
+        <p:nvSpPr>
+          <p:cNvPr id="5" name="Shape"/>
           <p:cNvSpPr/>
           <p:nvPr/>
         </p:nvSpPr>
         <p:spPr>
           <a:xfrm>
-            <a:off x="566928" y="3044952"/>
-            <a:ext cx="5364328" cy="1490472"/>
+            <a:off x="566928" y="1408176"/>
+            <a:ext cx="5364328" cy="1081278"/>
           </a:xfrm>
           <a:prstGeom prst="roundRect">
             <a:avLst>
-              <a:gd name="adj" fmla="val 4294"/>
+              <a:gd name="adj" fmla="val 5000"/>
             </a:avLst>
           </a:prstGeom>
           <a:solidFill>
@@ -6326,14 +8248,14 @@
       </p:sp>
       <p:sp>
         <p:nvSpPr>
-          <p:cNvPr id="9" name="Text 7"/>
-          <p:cNvSpPr txBox="1"/>
-          <p:nvPr/>
-        </p:nvSpPr>
-        <p:spPr>
-          <a:xfrm>
-            <a:off x="786384" y="3044952"/>
-            <a:ext cx="1371600" cy="1490472"/>
+          <p:cNvPr id="6" name="Text"/>
+          <p:cNvSpPr txBox="1"/>
+          <p:nvPr/>
+        </p:nvSpPr>
+        <p:spPr>
+          <a:xfrm>
+            <a:off x="786384" y="1408176"/>
+            <a:ext cx="1371600" cy="1081278"/>
           </a:xfrm>
           <a:prstGeom prst="rect">
             <a:avLst/>
@@ -6357,7 +8279,7 @@
                 <a:ea typeface="Arial" pitchFamily="34" charset="-122"/>
                 <a:cs typeface="Arial" pitchFamily="34" charset="-120"/>
               </a:rPr>
-              <a:t>9:30</a:t>
+              <a:t>9:00</a:t>
             </a:r>
             <a:endParaRPr lang="en-US" sz="1300" dirty="0"/>
           </a:p>
@@ -6365,14 +8287,14 @@
       </p:sp>
       <p:sp>
         <p:nvSpPr>
-          <p:cNvPr id="10" name="Text 8"/>
-          <p:cNvSpPr txBox="1"/>
-          <p:nvPr/>
-        </p:nvSpPr>
-        <p:spPr>
-          <a:xfrm>
-            <a:off x="2194560" y="3099816"/>
-            <a:ext cx="3517240" cy="1380744"/>
+          <p:cNvPr id="7" name="Text"/>
+          <p:cNvSpPr txBox="1"/>
+          <p:nvPr/>
+        </p:nvSpPr>
+        <p:spPr>
+          <a:xfrm>
+            <a:off x="2194560" y="1463040"/>
+            <a:ext cx="3517240" cy="971550"/>
           </a:xfrm>
           <a:prstGeom prst="rect">
             <a:avLst/>
@@ -6386,7 +8308,7 @@
           <a:p>
             <a:pPr indent="0" marL="0">
               <a:lnSpc>
-                <a:spcPct val="105000"/>
+                <a:spcPct val="110000"/>
               </a:lnSpc>
               <a:buNone/>
             </a:pPr>
@@ -6399,7 +8321,7 @@
                 <a:ea typeface="Calibri" pitchFamily="34" charset="-122"/>
                 <a:cs typeface="Calibri" pitchFamily="34" charset="-120"/>
               </a:rPr>
-              <a:t>El protocolo de verificación en cuatro pasos</a:t>
+              <a:t>El mapa corregido: dónde vive Copilot en el INEGI</a:t>
             </a:r>
             <a:endParaRPr lang="en-US" sz="1350" dirty="0"/>
           </a:p>
@@ -6407,18 +8329,342 @@
       </p:sp>
       <p:sp>
         <p:nvSpPr>
-          <p:cNvPr id="11" name="Shape 9"/>
+          <p:cNvPr id="8" name="Shape"/>
           <p:cNvSpPr/>
           <p:nvPr/>
         </p:nvSpPr>
         <p:spPr>
           <a:xfrm>
-            <a:off x="566928" y="4681728"/>
-            <a:ext cx="5364328" cy="1490472"/>
+            <a:off x="566928" y="2635758"/>
+            <a:ext cx="5364328" cy="1081278"/>
           </a:xfrm>
           <a:prstGeom prst="roundRect">
             <a:avLst>
-              <a:gd name="adj" fmla="val 4294"/>
+              <a:gd name="adj" fmla="val 5000"/>
+            </a:avLst>
+          </a:prstGeom>
+          <a:solidFill>
+            <a:srgbClr val="F2F5F6"/>
+          </a:solidFill>
+          <a:ln w="12700">
+            <a:solidFill>
+              <a:srgbClr val="F2F5F6"/>
+            </a:solidFill>
+            <a:prstDash val="solid"/>
+          </a:ln>
+        </p:spPr>
+      </p:sp>
+      <p:sp>
+        <p:nvSpPr>
+          <p:cNvPr id="9" name="Text"/>
+          <p:cNvSpPr txBox="1"/>
+          <p:nvPr/>
+        </p:nvSpPr>
+        <p:spPr>
+          <a:xfrm>
+            <a:off x="786384" y="2635758"/>
+            <a:ext cx="1371600" cy="1081278"/>
+          </a:xfrm>
+          <a:prstGeom prst="rect">
+            <a:avLst/>
+          </a:prstGeom>
+          <a:noFill/>
+          <a:ln/>
+        </p:spPr>
+        <p:txBody>
+          <a:bodyPr wrap="square" lIns="0" tIns="0" rIns="0" bIns="0" rtlCol="0" anchor="ctr"/>
+          <a:lstStyle/>
+          <a:p>
+            <a:pPr indent="0" marL="0">
+              <a:buNone/>
+            </a:pPr>
+            <a:r>
+              <a:rPr lang="en-US" sz="1300" b="1" dirty="0">
+                <a:solidFill>
+                  <a:srgbClr val="2E7D7D"/>
+                </a:solidFill>
+                <a:latin typeface="Arial" pitchFamily="34" charset="0"/>
+                <a:ea typeface="Arial" pitchFamily="34" charset="-122"/>
+                <a:cs typeface="Arial" pitchFamily="34" charset="-120"/>
+              </a:rPr>
+              <a:t>9:05</a:t>
+            </a:r>
+            <a:endParaRPr lang="en-US" sz="1300" dirty="0"/>
+          </a:p>
+        </p:txBody>
+      </p:sp>
+      <p:sp>
+        <p:nvSpPr>
+          <p:cNvPr id="10" name="Text"/>
+          <p:cNvSpPr txBox="1"/>
+          <p:nvPr/>
+        </p:nvSpPr>
+        <p:spPr>
+          <a:xfrm>
+            <a:off x="2194560" y="2690622"/>
+            <a:ext cx="3517240" cy="971550"/>
+          </a:xfrm>
+          <a:prstGeom prst="rect">
+            <a:avLst/>
+          </a:prstGeom>
+          <a:noFill/>
+          <a:ln/>
+        </p:spPr>
+        <p:txBody>
+          <a:bodyPr wrap="square" lIns="0" tIns="0" rIns="0" bIns="0" rtlCol="0" anchor="ctr"/>
+          <a:lstStyle/>
+          <a:p>
+            <a:pPr indent="0" marL="0">
+              <a:lnSpc>
+                <a:spcPct val="110000"/>
+              </a:lnSpc>
+              <a:buNone/>
+            </a:pPr>
+            <a:r>
+              <a:rPr lang="en-US" sz="1350" dirty="0">
+                <a:solidFill>
+                  <a:srgbClr val="16262E"/>
+                </a:solidFill>
+                <a:latin typeface="Calibri" pitchFamily="34" charset="0"/>
+                <a:ea typeface="Calibri" pitchFamily="34" charset="-122"/>
+                <a:cs typeface="Calibri" pitchFamily="34" charset="-120"/>
+              </a:rPr>
+              <a:t>Tu turno: tu documento, tu tabla, tu verificación</a:t>
+            </a:r>
+            <a:endParaRPr lang="en-US" sz="1350" dirty="0"/>
+          </a:p>
+        </p:txBody>
+      </p:sp>
+      <p:sp>
+        <p:nvSpPr>
+          <p:cNvPr id="11" name="Shape"/>
+          <p:cNvSpPr/>
+          <p:nvPr/>
+        </p:nvSpPr>
+        <p:spPr>
+          <a:xfrm>
+            <a:off x="566928" y="3863340"/>
+            <a:ext cx="5364328" cy="1081278"/>
+          </a:xfrm>
+          <a:prstGeom prst="roundRect">
+            <a:avLst>
+              <a:gd name="adj" fmla="val 5000"/>
+            </a:avLst>
+          </a:prstGeom>
+          <a:solidFill>
+            <a:srgbClr val="F2F5F6"/>
+          </a:solidFill>
+          <a:ln w="12700">
+            <a:solidFill>
+              <a:srgbClr val="F2F5F6"/>
+            </a:solidFill>
+            <a:prstDash val="solid"/>
+          </a:ln>
+        </p:spPr>
+      </p:sp>
+      <p:sp>
+        <p:nvSpPr>
+          <p:cNvPr id="12" name="Text"/>
+          <p:cNvSpPr txBox="1"/>
+          <p:nvPr/>
+        </p:nvSpPr>
+        <p:spPr>
+          <a:xfrm>
+            <a:off x="786384" y="3863340"/>
+            <a:ext cx="1371600" cy="1081278"/>
+          </a:xfrm>
+          <a:prstGeom prst="rect">
+            <a:avLst/>
+          </a:prstGeom>
+          <a:noFill/>
+          <a:ln/>
+        </p:spPr>
+        <p:txBody>
+          <a:bodyPr wrap="square" lIns="0" tIns="0" rIns="0" bIns="0" rtlCol="0" anchor="ctr"/>
+          <a:lstStyle/>
+          <a:p>
+            <a:pPr indent="0" marL="0">
+              <a:buNone/>
+            </a:pPr>
+            <a:r>
+              <a:rPr lang="en-US" sz="1300" b="1" dirty="0">
+                <a:solidFill>
+                  <a:srgbClr val="2E7D7D"/>
+                </a:solidFill>
+                <a:latin typeface="Arial" pitchFamily="34" charset="0"/>
+                <a:ea typeface="Arial" pitchFamily="34" charset="-122"/>
+                <a:cs typeface="Arial" pitchFamily="34" charset="-120"/>
+              </a:rPr>
+              <a:t>9:23</a:t>
+            </a:r>
+            <a:endParaRPr lang="en-US" sz="1300" dirty="0"/>
+          </a:p>
+        </p:txBody>
+      </p:sp>
+      <p:sp>
+        <p:nvSpPr>
+          <p:cNvPr id="13" name="Text"/>
+          <p:cNvSpPr txBox="1"/>
+          <p:nvPr/>
+        </p:nvSpPr>
+        <p:spPr>
+          <a:xfrm>
+            <a:off x="2194560" y="3918204"/>
+            <a:ext cx="3517240" cy="971550"/>
+          </a:xfrm>
+          <a:prstGeom prst="rect">
+            <a:avLst/>
+          </a:prstGeom>
+          <a:noFill/>
+          <a:ln/>
+        </p:spPr>
+        <p:txBody>
+          <a:bodyPr wrap="square" lIns="0" tIns="0" rIns="0" bIns="0" rtlCol="0" anchor="ctr"/>
+          <a:lstStyle/>
+          <a:p>
+            <a:pPr indent="0" marL="0">
+              <a:lnSpc>
+                <a:spcPct val="110000"/>
+              </a:lnSpc>
+              <a:buNone/>
+            </a:pPr>
+            <a:r>
+              <a:rPr lang="en-US" sz="1350" dirty="0">
+                <a:solidFill>
+                  <a:srgbClr val="16262E"/>
+                </a:solidFill>
+                <a:latin typeface="Calibri" pitchFamily="34" charset="0"/>
+                <a:ea typeface="Calibri" pitchFamily="34" charset="-122"/>
+                <a:cs typeface="Calibri" pitchFamily="34" charset="-120"/>
+              </a:rPr>
+              <a:t>Los seis errores típicos, con ejemplos de estas sesiones</a:t>
+            </a:r>
+            <a:endParaRPr lang="en-US" sz="1350" dirty="0"/>
+          </a:p>
+        </p:txBody>
+      </p:sp>
+      <p:sp>
+        <p:nvSpPr>
+          <p:cNvPr id="14" name="Shape"/>
+          <p:cNvSpPr/>
+          <p:nvPr/>
+        </p:nvSpPr>
+        <p:spPr>
+          <a:xfrm>
+            <a:off x="566928" y="5090922"/>
+            <a:ext cx="5364328" cy="1081278"/>
+          </a:xfrm>
+          <a:prstGeom prst="roundRect">
+            <a:avLst>
+              <a:gd name="adj" fmla="val 5000"/>
+            </a:avLst>
+          </a:prstGeom>
+          <a:solidFill>
+            <a:srgbClr val="F2F5F6"/>
+          </a:solidFill>
+          <a:ln w="12700">
+            <a:solidFill>
+              <a:srgbClr val="F2F5F6"/>
+            </a:solidFill>
+            <a:prstDash val="solid"/>
+          </a:ln>
+        </p:spPr>
+      </p:sp>
+      <p:sp>
+        <p:nvSpPr>
+          <p:cNvPr id="15" name="Text"/>
+          <p:cNvSpPr txBox="1"/>
+          <p:nvPr/>
+        </p:nvSpPr>
+        <p:spPr>
+          <a:xfrm>
+            <a:off x="786384" y="5090922"/>
+            <a:ext cx="1371600" cy="1081278"/>
+          </a:xfrm>
+          <a:prstGeom prst="rect">
+            <a:avLst/>
+          </a:prstGeom>
+          <a:noFill/>
+          <a:ln/>
+        </p:spPr>
+        <p:txBody>
+          <a:bodyPr wrap="square" lIns="0" tIns="0" rIns="0" bIns="0" rtlCol="0" anchor="ctr"/>
+          <a:lstStyle/>
+          <a:p>
+            <a:pPr indent="0" marL="0">
+              <a:buNone/>
+            </a:pPr>
+            <a:r>
+              <a:rPr lang="en-US" sz="1300" b="1" dirty="0">
+                <a:solidFill>
+                  <a:srgbClr val="2E7D7D"/>
+                </a:solidFill>
+                <a:latin typeface="Arial" pitchFamily="34" charset="0"/>
+                <a:ea typeface="Arial" pitchFamily="34" charset="-122"/>
+                <a:cs typeface="Arial" pitchFamily="34" charset="-120"/>
+              </a:rPr>
+              <a:t>9:42</a:t>
+            </a:r>
+            <a:endParaRPr lang="en-US" sz="1300" dirty="0"/>
+          </a:p>
+        </p:txBody>
+      </p:sp>
+      <p:sp>
+        <p:nvSpPr>
+          <p:cNvPr id="16" name="Text"/>
+          <p:cNvSpPr txBox="1"/>
+          <p:nvPr/>
+        </p:nvSpPr>
+        <p:spPr>
+          <a:xfrm>
+            <a:off x="2194560" y="5145786"/>
+            <a:ext cx="3517240" cy="971550"/>
+          </a:xfrm>
+          <a:prstGeom prst="rect">
+            <a:avLst/>
+          </a:prstGeom>
+          <a:noFill/>
+          <a:ln/>
+        </p:spPr>
+        <p:txBody>
+          <a:bodyPr wrap="square" lIns="0" tIns="0" rIns="0" bIns="0" rtlCol="0" anchor="ctr"/>
+          <a:lstStyle/>
+          <a:p>
+            <a:pPr indent="0" marL="0">
+              <a:lnSpc>
+                <a:spcPct val="110000"/>
+              </a:lnSpc>
+              <a:buNone/>
+            </a:pPr>
+            <a:r>
+              <a:rPr lang="en-US" sz="1350" dirty="0">
+                <a:solidFill>
+                  <a:srgbClr val="16262E"/>
+                </a:solidFill>
+                <a:latin typeface="Calibri" pitchFamily="34" charset="0"/>
+                <a:ea typeface="Calibri" pitchFamily="34" charset="-122"/>
+                <a:cs typeface="Calibri" pitchFamily="34" charset="-120"/>
+              </a:rPr>
+              <a:t>El protocolo de verificación en cuatro pasos</a:t>
+            </a:r>
+            <a:endParaRPr lang="en-US" sz="1350" dirty="0"/>
+          </a:p>
+        </p:txBody>
+      </p:sp>
+      <p:sp>
+        <p:nvSpPr>
+          <p:cNvPr id="17" name="Shape"/>
+          <p:cNvSpPr/>
+          <p:nvPr/>
+        </p:nvSpPr>
+        <p:spPr>
+          <a:xfrm>
+            <a:off x="6260440" y="1408176"/>
+            <a:ext cx="5364328" cy="1081278"/>
+          </a:xfrm>
+          <a:prstGeom prst="roundRect">
+            <a:avLst>
+              <a:gd name="adj" fmla="val 5000"/>
             </a:avLst>
           </a:prstGeom>
           <a:solidFill>
@@ -6434,14 +8680,14 @@
       </p:sp>
       <p:sp>
         <p:nvSpPr>
-          <p:cNvPr id="12" name="Text 10"/>
-          <p:cNvSpPr txBox="1"/>
-          <p:nvPr/>
-        </p:nvSpPr>
-        <p:spPr>
-          <a:xfrm>
-            <a:off x="786384" y="4681728"/>
-            <a:ext cx="1371600" cy="1490472"/>
+          <p:cNvPr id="18" name="Text"/>
+          <p:cNvSpPr txBox="1"/>
+          <p:nvPr/>
+        </p:nvSpPr>
+        <p:spPr>
+          <a:xfrm>
+            <a:off x="6479896" y="1408176"/>
+            <a:ext cx="1371600" cy="1081278"/>
           </a:xfrm>
           <a:prstGeom prst="rect">
             <a:avLst/>
@@ -6473,14 +8719,14 @@
       </p:sp>
       <p:sp>
         <p:nvSpPr>
-          <p:cNvPr id="13" name="Text 11"/>
-          <p:cNvSpPr txBox="1"/>
-          <p:nvPr/>
-        </p:nvSpPr>
-        <p:spPr>
-          <a:xfrm>
-            <a:off x="2194560" y="4736592"/>
-            <a:ext cx="3517240" cy="1380744"/>
+          <p:cNvPr id="19" name="Text"/>
+          <p:cNvSpPr txBox="1"/>
+          <p:nvPr/>
+        </p:nvSpPr>
+        <p:spPr>
+          <a:xfrm>
+            <a:off x="7888072" y="1463040"/>
+            <a:ext cx="3517240" cy="971550"/>
           </a:xfrm>
           <a:prstGeom prst="rect">
             <a:avLst/>
@@ -6494,7 +8740,7 @@
           <a:p>
             <a:pPr indent="0" marL="0">
               <a:lnSpc>
-                <a:spcPct val="105000"/>
+                <a:spcPct val="110000"/>
               </a:lnSpc>
               <a:buNone/>
             </a:pPr>
@@ -6507,7 +8753,7 @@
                 <a:ea typeface="Calibri" pitchFamily="34" charset="-122"/>
                 <a:cs typeface="Calibri" pitchFamily="34" charset="-120"/>
               </a:rPr>
-              <a:t>Receso de diez minutos</a:t>
+              <a:t>Receso y formación de los seis equipos</a:t>
             </a:r>
             <a:endParaRPr lang="en-US" sz="1350" dirty="0"/>
           </a:p>
@@ -6515,18 +8761,18 @@
       </p:sp>
       <p:sp>
         <p:nvSpPr>
-          <p:cNvPr id="14" name="Shape 12"/>
+          <p:cNvPr id="20" name="Shape"/>
           <p:cNvSpPr/>
           <p:nvPr/>
         </p:nvSpPr>
         <p:spPr>
           <a:xfrm>
-            <a:off x="6260440" y="1408176"/>
-            <a:ext cx="5364328" cy="1490472"/>
+            <a:off x="6260440" y="2635758"/>
+            <a:ext cx="5364328" cy="1081278"/>
           </a:xfrm>
           <a:prstGeom prst="roundRect">
             <a:avLst>
-              <a:gd name="adj" fmla="val 4294"/>
+              <a:gd name="adj" fmla="val 5000"/>
             </a:avLst>
           </a:prstGeom>
           <a:solidFill>
@@ -6542,14 +8788,14 @@
       </p:sp>
       <p:sp>
         <p:nvSpPr>
-          <p:cNvPr id="15" name="Text 13"/>
-          <p:cNvSpPr txBox="1"/>
-          <p:nvPr/>
-        </p:nvSpPr>
-        <p:spPr>
-          <a:xfrm>
-            <a:off x="6479896" y="1408176"/>
-            <a:ext cx="1371600" cy="1490472"/>
+          <p:cNvPr id="21" name="Text"/>
+          <p:cNvSpPr txBox="1"/>
+          <p:nvPr/>
+        </p:nvSpPr>
+        <p:spPr>
+          <a:xfrm>
+            <a:off x="6479896" y="2635758"/>
+            <a:ext cx="1371600" cy="1081278"/>
           </a:xfrm>
           <a:prstGeom prst="rect">
             <a:avLst/>
@@ -6581,14 +8827,14 @@
       </p:sp>
       <p:sp>
         <p:nvSpPr>
-          <p:cNvPr id="16" name="Text 14"/>
-          <p:cNvSpPr txBox="1"/>
-          <p:nvPr/>
-        </p:nvSpPr>
-        <p:spPr>
-          <a:xfrm>
-            <a:off x="7888072" y="1463040"/>
-            <a:ext cx="3517240" cy="1380744"/>
+          <p:cNvPr id="22" name="Text"/>
+          <p:cNvSpPr txBox="1"/>
+          <p:nvPr/>
+        </p:nvSpPr>
+        <p:spPr>
+          <a:xfrm>
+            <a:off x="7888072" y="2690622"/>
+            <a:ext cx="3517240" cy="971550"/>
           </a:xfrm>
           <a:prstGeom prst="rect">
             <a:avLst/>
@@ -6602,7 +8848,7 @@
           <a:p>
             <a:pPr indent="0" marL="0">
               <a:lnSpc>
-                <a:spcPct val="105000"/>
+                <a:spcPct val="110000"/>
               </a:lnSpc>
               <a:buNone/>
             </a:pPr>
@@ -6623,18 +8869,18 @@
       </p:sp>
       <p:sp>
         <p:nvSpPr>
-          <p:cNvPr id="17" name="Shape 15"/>
+          <p:cNvPr id="23" name="Shape"/>
           <p:cNvSpPr/>
           <p:nvPr/>
         </p:nvSpPr>
         <p:spPr>
           <a:xfrm>
-            <a:off x="6260440" y="3044952"/>
-            <a:ext cx="5364328" cy="1490472"/>
+            <a:off x="6260440" y="3863340"/>
+            <a:ext cx="5364328" cy="1081278"/>
           </a:xfrm>
           <a:prstGeom prst="roundRect">
             <a:avLst>
-              <a:gd name="adj" fmla="val 4294"/>
+              <a:gd name="adj" fmla="val 5000"/>
             </a:avLst>
           </a:prstGeom>
           <a:solidFill>
@@ -6650,14 +8896,14 @@
       </p:sp>
       <p:sp>
         <p:nvSpPr>
-          <p:cNvPr id="18" name="Text 16"/>
-          <p:cNvSpPr txBox="1"/>
-          <p:nvPr/>
-        </p:nvSpPr>
-        <p:spPr>
-          <a:xfrm>
-            <a:off x="6479896" y="3044952"/>
-            <a:ext cx="1371600" cy="1490472"/>
+          <p:cNvPr id="24" name="Text"/>
+          <p:cNvSpPr txBox="1"/>
+          <p:nvPr/>
+        </p:nvSpPr>
+        <p:spPr>
+          <a:xfrm>
+            <a:off x="6479896" y="3863340"/>
+            <a:ext cx="1371600" cy="1081278"/>
           </a:xfrm>
           <a:prstGeom prst="rect">
             <a:avLst/>
@@ -6689,14 +8935,14 @@
       </p:sp>
       <p:sp>
         <p:nvSpPr>
-          <p:cNvPr id="19" name="Text 17"/>
-          <p:cNvSpPr txBox="1"/>
-          <p:nvPr/>
-        </p:nvSpPr>
-        <p:spPr>
-          <a:xfrm>
-            <a:off x="7888072" y="3099816"/>
-            <a:ext cx="3517240" cy="1380744"/>
+          <p:cNvPr id="25" name="Text"/>
+          <p:cNvSpPr txBox="1"/>
+          <p:nvPr/>
+        </p:nvSpPr>
+        <p:spPr>
+          <a:xfrm>
+            <a:off x="7888072" y="3918204"/>
+            <a:ext cx="3517240" cy="971550"/>
           </a:xfrm>
           <a:prstGeom prst="rect">
             <a:avLst/>
@@ -6710,7 +8956,7 @@
           <a:p>
             <a:pPr indent="0" marL="0">
               <a:lnSpc>
-                <a:spcPct val="105000"/>
+                <a:spcPct val="110000"/>
               </a:lnSpc>
               <a:buNone/>
             </a:pPr>
@@ -6731,18 +8977,18 @@
       </p:sp>
       <p:sp>
         <p:nvSpPr>
-          <p:cNvPr id="20" name="Shape 18"/>
+          <p:cNvPr id="26" name="Shape"/>
           <p:cNvSpPr/>
           <p:nvPr/>
         </p:nvSpPr>
         <p:spPr>
           <a:xfrm>
-            <a:off x="6260440" y="4681728"/>
-            <a:ext cx="5364328" cy="1490472"/>
+            <a:off x="6260440" y="5090922"/>
+            <a:ext cx="5364328" cy="1081278"/>
           </a:xfrm>
           <a:prstGeom prst="roundRect">
             <a:avLst>
-              <a:gd name="adj" fmla="val 4294"/>
+              <a:gd name="adj" fmla="val 5000"/>
             </a:avLst>
           </a:prstGeom>
           <a:solidFill>
@@ -6758,14 +9004,14 @@
       </p:sp>
       <p:sp>
         <p:nvSpPr>
-          <p:cNvPr id="21" name="Text 19"/>
-          <p:cNvSpPr txBox="1"/>
-          <p:nvPr/>
-        </p:nvSpPr>
-        <p:spPr>
-          <a:xfrm>
-            <a:off x="6479896" y="4681728"/>
-            <a:ext cx="1371600" cy="1490472"/>
+          <p:cNvPr id="27" name="Text"/>
+          <p:cNvSpPr txBox="1"/>
+          <p:nvPr/>
+        </p:nvSpPr>
+        <p:spPr>
+          <a:xfrm>
+            <a:off x="6479896" y="5090922"/>
+            <a:ext cx="1371600" cy="1081278"/>
           </a:xfrm>
           <a:prstGeom prst="rect">
             <a:avLst/>
@@ -6797,14 +9043,14 @@
       </p:sp>
       <p:sp>
         <p:nvSpPr>
-          <p:cNvPr id="22" name="Text 20"/>
-          <p:cNvSpPr txBox="1"/>
-          <p:nvPr/>
-        </p:nvSpPr>
-        <p:spPr>
-          <a:xfrm>
-            <a:off x="7888072" y="4736592"/>
-            <a:ext cx="3517240" cy="1380744"/>
+          <p:cNvPr id="28" name="Text"/>
+          <p:cNvSpPr txBox="1"/>
+          <p:nvPr/>
+        </p:nvSpPr>
+        <p:spPr>
+          <a:xfrm>
+            <a:off x="7888072" y="5145786"/>
+            <a:ext cx="3517240" cy="971550"/>
           </a:xfrm>
           <a:prstGeom prst="rect">
             <a:avLst/>
@@ -6818,7 +9064,7 @@
           <a:p>
             <a:pPr indent="0" marL="0">
               <a:lnSpc>
-                <a:spcPct val="105000"/>
+                <a:spcPct val="110000"/>
               </a:lnSpc>
               <a:buNone/>
             </a:pPr>
@@ -6839,7 +9085,7 @@
       </p:sp>
       <p:sp>
         <p:nvSpPr>
-          <p:cNvPr id="23" name="Text 21"/>
+          <p:cNvPr id="29" name="Text"/>
           <p:cNvSpPr txBox="1"/>
           <p:nvPr/>
         </p:nvSpPr>
@@ -6855,7 +9101,7 @@
           <a:ln/>
         </p:spPr>
         <p:txBody>
-          <a:bodyPr wrap="square" lIns="0" tIns="0" rIns="0" bIns="0" rtlCol="0" anchor="ctr"/>
+          <a:bodyPr wrap="square" lIns="0" tIns="0" rIns="0" bIns="0" rtlCol="0" anchor="t"/>
           <a:lstStyle/>
           <a:p>
             <a:pPr indent="0" marL="0">
@@ -6870,7 +9116,7 @@
                 <a:ea typeface="Calibri" pitchFamily="34" charset="-122"/>
                 <a:cs typeface="Calibri" pitchFamily="34" charset="-120"/>
               </a:rPr>
-              <a:t>Hoy trabajas 65 minutos seguidos en equipo. Forma tu equipo desde el primer minuto.</a:t>
+              <a:t>Hoy trabajas unos 85 minutos con las manos en el teclado, 65 de ellos en equipo. Los equipos se forman en el receso.</a:t>
             </a:r>
             <a:endParaRPr lang="en-US" sz="1000" dirty="0"/>
           </a:p>
@@ -7110,7 +9356,7 @@
                 <a:ea typeface="Calibri" pitchFamily="34" charset="-122"/>
                 <a:cs typeface="Calibri" pitchFamily="34" charset="-120"/>
               </a:rPr>
-              <a:t>9:00 a 9:30</a:t>
+              <a:t>9:23 a 9:42</a:t>
             </a:r>
             <a:endParaRPr lang="en-US" sz="1200" dirty="0"/>
           </a:p>
@@ -7213,7 +9459,7 @@
                 <a:ea typeface="Calibri" pitchFamily="34" charset="-122"/>
                 <a:cs typeface="Calibri" pitchFamily="34" charset="-120"/>
               </a:rPr>
-              <a:t>Los tres ya te pasaron en estas dos sesiones. Ahora tienen nombre.</a:t>
+              <a:t>Los tres ya te pasaron entre el lunes y el calentamiento de hoy. Ahora tienen nombre.</a:t>
             </a:r>
             <a:endParaRPr lang="en-US" sz="1500" dirty="0"/>
           </a:p>
@@ -8942,7 +11188,7 @@
                 <a:ea typeface="Calibri" pitchFamily="34" charset="-122"/>
                 <a:cs typeface="Calibri" pitchFamily="34" charset="-120"/>
               </a:rPr>
-              <a:t>9:30 a 9:55</a:t>
+              <a:t>9:42 a 9:55</a:t>
             </a:r>
             <a:endParaRPr lang="en-US" sz="1200" dirty="0"/>
           </a:p>

</xml_diff>